<commit_message>
feat(presentation): polish deck for visual design emphasis
- Update member names/IDs on title slide
- Rework slides to focus on typography, layout, design thinking, and UI/UX rationale

Made-with: Cursor
</commit_message>
<xml_diff>
--- a/presentation/Portfolio-ReStyle-AI-Design-Deck.pptx
+++ b/presentation/Portfolio-ReStyle-AI-Design-Deck.pptx
@@ -1641,9 +1641,9 @@
                 <a:solidFill>
                   <a:srgbClr val="4F46E5"/>
                 </a:solidFill>
-                <a:latin typeface="Arial" pitchFamily="34" charset="0"/>
-                <a:ea typeface="Arial" pitchFamily="34" charset="-122"/>
-                <a:cs typeface="Arial" pitchFamily="34" charset="-120"/>
+                <a:latin typeface="Helvetica Neue" pitchFamily="34" charset="0"/>
+                <a:ea typeface="Helvetica Neue" pitchFamily="34" charset="-122"/>
+                <a:cs typeface="Helvetica Neue" pitchFamily="34" charset="-120"/>
               </a:rPr>
               <a:t>Portfolio ReStyle AI</a:t>
             </a:r>
@@ -1680,9 +1680,9 @@
                 <a:solidFill>
                   <a:srgbClr val="0F172A"/>
                 </a:solidFill>
-                <a:latin typeface="Arial" pitchFamily="34" charset="0"/>
-                <a:ea typeface="Arial" pitchFamily="34" charset="-122"/>
-                <a:cs typeface="Arial" pitchFamily="34" charset="-120"/>
+                <a:latin typeface="Helvetica Neue" pitchFamily="34" charset="0"/>
+                <a:ea typeface="Helvetica Neue" pitchFamily="34" charset="-122"/>
+                <a:cs typeface="Helvetica Neue" pitchFamily="34" charset="-120"/>
               </a:rPr>
               <a:t>視覺傳達設計 · Visual communication design</a:t>
             </a:r>
@@ -1697,9 +1697,9 @@
                 <a:solidFill>
                   <a:srgbClr val="0F172A"/>
                 </a:solidFill>
-                <a:latin typeface="Arial" pitchFamily="34" charset="0"/>
-                <a:ea typeface="Arial" pitchFamily="34" charset="-122"/>
-                <a:cs typeface="Arial" pitchFamily="34" charset="-120"/>
+                <a:latin typeface="Helvetica Neue" pitchFamily="34" charset="0"/>
+                <a:ea typeface="Helvetica Neue" pitchFamily="34" charset="-122"/>
+                <a:cs typeface="Helvetica Neue" pitchFamily="34" charset="-120"/>
               </a:rPr>
               <a:t>Human–AI layout collaboration · 人機協作版面實驗</a:t>
             </a:r>
@@ -1736,11 +1736,11 @@
                 <a:solidFill>
                   <a:srgbClr val="64748B"/>
                 </a:solidFill>
-                <a:latin typeface="Arial" pitchFamily="34" charset="0"/>
-                <a:ea typeface="Arial" pitchFamily="34" charset="-122"/>
-                <a:cs typeface="Arial" pitchFamily="34" charset="-120"/>
-              </a:rPr>
-              <a:t>組員 Members（請改為真實姓名學號 · Edit with your names &amp; student IDs）</a:t>
+                <a:latin typeface="Helvetica Neue" pitchFamily="34" charset="0"/>
+                <a:ea typeface="Helvetica Neue" pitchFamily="34" charset="-122"/>
+                <a:cs typeface="Helvetica Neue" pitchFamily="34" charset="-120"/>
+              </a:rPr>
+              <a:t>組員 Members</a:t>
             </a:r>
             <a:endParaRPr lang="en-US" sz="1400" dirty="0"/>
           </a:p>
@@ -1753,11 +1753,28 @@
                 <a:solidFill>
                   <a:srgbClr val="64748B"/>
                 </a:solidFill>
-                <a:latin typeface="Arial" pitchFamily="34" charset="0"/>
-                <a:ea typeface="Arial" pitchFamily="34" charset="-122"/>
-                <a:cs typeface="Arial" pitchFamily="34" charset="-120"/>
-              </a:rPr>
-              <a:t>English name / 中文姓名 · Student ID 學號</a:t>
+                <a:latin typeface="Helvetica Neue" pitchFamily="34" charset="0"/>
+                <a:ea typeface="Helvetica Neue" pitchFamily="34" charset="-122"/>
+                <a:cs typeface="Helvetica Neue" pitchFamily="34" charset="-120"/>
+              </a:rPr>
+              <a:t>郭曉玥 (Guo Xiaoyue) · MC569254</a:t>
+            </a:r>
+            <a:endParaRPr lang="en-US" sz="1400" dirty="0"/>
+          </a:p>
+          <a:p>
+            <a:pPr indent="0" marL="0">
+              <a:buNone/>
+            </a:pPr>
+            <a:r>
+              <a:rPr lang="en-US" sz="1400" i="1" dirty="0">
+                <a:solidFill>
+                  <a:srgbClr val="64748B"/>
+                </a:solidFill>
+                <a:latin typeface="Helvetica Neue" pitchFamily="34" charset="0"/>
+                <a:ea typeface="Helvetica Neue" pitchFamily="34" charset="-122"/>
+                <a:cs typeface="Helvetica Neue" pitchFamily="34" charset="-120"/>
+              </a:rPr>
+              <a:t>劉佳群 (Liu Jiaqun) · MCxxxxxx</a:t>
             </a:r>
             <a:endParaRPr lang="en-US" sz="1400" dirty="0"/>
           </a:p>
@@ -1824,9 +1841,9 @@
                 <a:solidFill>
                   <a:srgbClr val="4F46E5"/>
                 </a:solidFill>
-                <a:latin typeface="Arial" pitchFamily="34" charset="0"/>
-                <a:ea typeface="Arial" pitchFamily="34" charset="-122"/>
-                <a:cs typeface="Arial" pitchFamily="34" charset="-120"/>
+                <a:latin typeface="Helvetica Neue" pitchFamily="34" charset="0"/>
+                <a:ea typeface="Helvetica Neue" pitchFamily="34" charset="-122"/>
+                <a:cs typeface="Helvetica Neue" pitchFamily="34" charset="-120"/>
               </a:rPr>
               <a:t>Why this matters 問題背景</a:t>
             </a:r>
@@ -1863,9 +1880,9 @@
                 <a:solidFill>
                   <a:srgbClr val="64748B"/>
                 </a:solidFill>
-                <a:latin typeface="Arial" pitchFamily="34" charset="0"/>
-                <a:ea typeface="Arial" pitchFamily="34" charset="-122"/>
-                <a:cs typeface="Arial" pitchFamily="34" charset="-120"/>
+                <a:latin typeface="Helvetica Neue" pitchFamily="34" charset="0"/>
+                <a:ea typeface="Helvetica Neue" pitchFamily="34" charset="-122"/>
+                <a:cs typeface="Helvetica Neue" pitchFamily="34" charset="-120"/>
               </a:rPr>
               <a:t>Problem · 作品集不只是「好看」</a:t>
             </a:r>
@@ -1906,9 +1923,9 @@
                 <a:solidFill>
                   <a:srgbClr val="0F172A"/>
                 </a:solidFill>
-                <a:latin typeface="Arial" pitchFamily="34" charset="0"/>
-                <a:ea typeface="Arial" pitchFamily="34" charset="-122"/>
-                <a:cs typeface="Arial" pitchFamily="34" charset="-120"/>
+                <a:latin typeface="Helvetica Neue" pitchFamily="34" charset="0"/>
+                <a:ea typeface="Helvetica Neue" pitchFamily="34" charset="-122"/>
+                <a:cs typeface="Helvetica Neue" pitchFamily="34" charset="-120"/>
               </a:rPr>
               <a:t>Portfolios are narrative + craft—not only pretty pictures.</a:t>
             </a:r>
@@ -1927,9 +1944,9 @@
                 <a:solidFill>
                   <a:srgbClr val="0F172A"/>
                 </a:solidFill>
-                <a:latin typeface="Arial" pitchFamily="34" charset="0"/>
-                <a:ea typeface="Arial" pitchFamily="34" charset="-122"/>
-                <a:cs typeface="Arial" pitchFamily="34" charset="-120"/>
+                <a:latin typeface="Helvetica Neue" pitchFamily="34" charset="0"/>
+                <a:ea typeface="Helvetica Neue" pitchFamily="34" charset="-122"/>
+                <a:cs typeface="Helvetica Neue" pitchFamily="34" charset="-120"/>
               </a:rPr>
               <a:t>作品集是敘事與工藝，不只是漂亮畫面。</a:t>
             </a:r>
@@ -1948,9 +1965,9 @@
                 <a:solidFill>
                   <a:srgbClr val="0F172A"/>
                 </a:solidFill>
-                <a:latin typeface="Arial" pitchFamily="34" charset="0"/>
-                <a:ea typeface="Arial" pitchFamily="34" charset="-122"/>
-                <a:cs typeface="Arial" pitchFamily="34" charset="-120"/>
+                <a:latin typeface="Helvetica Neue" pitchFamily="34" charset="0"/>
+                <a:ea typeface="Helvetica Neue" pitchFamily="34" charset="-122"/>
+                <a:cs typeface="Helvetica Neue" pitchFamily="34" charset="-120"/>
               </a:rPr>
               <a:t>Restructuring order, grid, and tone is repetitive; it steals time from concept work.</a:t>
             </a:r>
@@ -1969,9 +1986,9 @@
                 <a:solidFill>
                   <a:srgbClr val="0F172A"/>
                 </a:solidFill>
-                <a:latin typeface="Arial" pitchFamily="34" charset="0"/>
-                <a:ea typeface="Arial" pitchFamily="34" charset="-122"/>
-                <a:cs typeface="Arial" pitchFamily="34" charset="-120"/>
+                <a:latin typeface="Helvetica Neue" pitchFamily="34" charset="0"/>
+                <a:ea typeface="Helvetica Neue" pitchFamily="34" charset="-122"/>
+                <a:cs typeface="Helvetica Neue" pitchFamily="34" charset="-120"/>
               </a:rPr>
               <a:t>重排順序、網格、色調很耗時，擠壓概念發想時間。</a:t>
             </a:r>
@@ -1990,9 +2007,9 @@
                 <a:solidFill>
                   <a:srgbClr val="0F172A"/>
                 </a:solidFill>
-                <a:latin typeface="Arial" pitchFamily="34" charset="0"/>
-                <a:ea typeface="Arial" pitchFamily="34" charset="-122"/>
-                <a:cs typeface="Arial" pitchFamily="34" charset="-120"/>
+                <a:latin typeface="Helvetica Neue" pitchFamily="34" charset="0"/>
+                <a:ea typeface="Helvetica Neue" pitchFamily="34" charset="-122"/>
+                <a:cs typeface="Helvetica Neue" pitchFamily="34" charset="-120"/>
               </a:rPr>
               <a:t>We need a tool that assists without replacing designer judgment.</a:t>
             </a:r>
@@ -2011,9 +2028,9 @@
                 <a:solidFill>
                   <a:srgbClr val="0F172A"/>
                 </a:solidFill>
-                <a:latin typeface="Arial" pitchFamily="34" charset="0"/>
-                <a:ea typeface="Arial" pitchFamily="34" charset="-122"/>
-                <a:cs typeface="Arial" pitchFamily="34" charset="-120"/>
+                <a:latin typeface="Helvetica Neue" pitchFamily="34" charset="0"/>
+                <a:ea typeface="Helvetica Neue" pitchFamily="34" charset="-122"/>
+                <a:cs typeface="Helvetica Neue" pitchFamily="34" charset="-120"/>
               </a:rPr>
               <a:t>需要「輔助」設計師判斷的工具，而非取代。</a:t>
             </a:r>
@@ -2082,9 +2099,9 @@
                 <a:solidFill>
                   <a:srgbClr val="4F46E5"/>
                 </a:solidFill>
-                <a:latin typeface="Arial" pitchFamily="34" charset="0"/>
-                <a:ea typeface="Arial" pitchFamily="34" charset="-122"/>
-                <a:cs typeface="Arial" pitchFamily="34" charset="-120"/>
+                <a:latin typeface="Helvetica Neue" pitchFamily="34" charset="0"/>
+                <a:ea typeface="Helvetica Neue" pitchFamily="34" charset="-122"/>
+                <a:cs typeface="Helvetica Neue" pitchFamily="34" charset="-120"/>
               </a:rPr>
               <a:t>Concept 核心概念</a:t>
             </a:r>
@@ -2121,9 +2138,9 @@
                 <a:solidFill>
                   <a:srgbClr val="64748B"/>
                 </a:solidFill>
-                <a:latin typeface="Arial" pitchFamily="34" charset="0"/>
-                <a:ea typeface="Arial" pitchFamily="34" charset="-122"/>
-                <a:cs typeface="Arial" pitchFamily="34" charset="-120"/>
+                <a:latin typeface="Helvetica Neue" pitchFamily="34" charset="0"/>
+                <a:ea typeface="Helvetica Neue" pitchFamily="34" charset="-122"/>
+                <a:cs typeface="Helvetica Neue" pitchFamily="34" charset="-120"/>
               </a:rPr>
               <a:t>Re-interpret, don’t replace</a:t>
             </a:r>
@@ -2164,9 +2181,9 @@
                 <a:solidFill>
                   <a:srgbClr val="0F172A"/>
                 </a:solidFill>
-                <a:latin typeface="Arial" pitchFamily="34" charset="0"/>
-                <a:ea typeface="Arial" pitchFamily="34" charset="-122"/>
-                <a:cs typeface="Arial" pitchFamily="34" charset="-120"/>
+                <a:latin typeface="Helvetica Neue" pitchFamily="34" charset="0"/>
+                <a:ea typeface="Helvetica Neue" pitchFamily="34" charset="-122"/>
+                <a:cs typeface="Helvetica Neue" pitchFamily="34" charset="-120"/>
               </a:rPr>
               <a:t>Re-interpret SVG/PDF with clear intent: palette, style, canvas, narrative order.</a:t>
             </a:r>
@@ -2185,9 +2202,9 @@
                 <a:solidFill>
                   <a:srgbClr val="0F172A"/>
                 </a:solidFill>
-                <a:latin typeface="Arial" pitchFamily="34" charset="0"/>
-                <a:ea typeface="Arial" pitchFamily="34" charset="-122"/>
-                <a:cs typeface="Arial" pitchFamily="34" charset="-120"/>
+                <a:latin typeface="Helvetica Neue" pitchFamily="34" charset="0"/>
+                <a:ea typeface="Helvetica Neue" pitchFamily="34" charset="-122"/>
+                <a:cs typeface="Helvetica Neue" pitchFamily="34" charset="-120"/>
               </a:rPr>
               <a:t>以色系、風格、畫布、敘事順序重新詮釋既有稿件。</a:t>
             </a:r>
@@ -2206,9 +2223,9 @@
                 <a:solidFill>
                   <a:srgbClr val="0F172A"/>
                 </a:solidFill>
-                <a:latin typeface="Arial" pitchFamily="34" charset="0"/>
-                <a:ea typeface="Arial" pitchFamily="34" charset="-122"/>
-                <a:cs typeface="Arial" pitchFamily="34" charset="-120"/>
+                <a:latin typeface="Helvetica Neue" pitchFamily="34" charset="0"/>
+                <a:ea typeface="Helvetica Neue" pitchFamily="34" charset="-122"/>
+                <a:cs typeface="Helvetica Neue" pitchFamily="34" charset="-120"/>
               </a:rPr>
               <a:t>Three variants per page → designer chooses (studio critique loop).</a:t>
             </a:r>
@@ -2227,9 +2244,9 @@
                 <a:solidFill>
                   <a:srgbClr val="0F172A"/>
                 </a:solidFill>
-                <a:latin typeface="Arial" pitchFamily="34" charset="0"/>
-                <a:ea typeface="Arial" pitchFamily="34" charset="-122"/>
-                <a:cs typeface="Arial" pitchFamily="34" charset="-120"/>
+                <a:latin typeface="Helvetica Neue" pitchFamily="34" charset="0"/>
+                <a:ea typeface="Helvetica Neue" pitchFamily="34" charset="-122"/>
+                <a:cs typeface="Helvetica Neue" pitchFamily="34" charset="-120"/>
               </a:rPr>
               <a:t>每頁三種版本 → 設計師選擇，貼近工作室評圖流程。</a:t>
             </a:r>
@@ -2248,9 +2265,9 @@
                 <a:solidFill>
                   <a:srgbClr val="0F172A"/>
                 </a:solidFill>
-                <a:latin typeface="Arial" pitchFamily="34" charset="0"/>
-                <a:ea typeface="Arial" pitchFamily="34" charset="-122"/>
-                <a:cs typeface="Arial" pitchFamily="34" charset="-120"/>
+                <a:latin typeface="Helvetica Neue" pitchFamily="34" charset="0"/>
+                <a:ea typeface="Helvetica Neue" pitchFamily="34" charset="-122"/>
+                <a:cs typeface="Helvetica Neue" pitchFamily="34" charset="-120"/>
               </a:rPr>
               <a:t>Export SVG (edit further) or merged PDF (share / print).</a:t>
             </a:r>
@@ -2269,9 +2286,9 @@
                 <a:solidFill>
                   <a:srgbClr val="0F172A"/>
                 </a:solidFill>
-                <a:latin typeface="Arial" pitchFamily="34" charset="0"/>
-                <a:ea typeface="Arial" pitchFamily="34" charset="-122"/>
-                <a:cs typeface="Arial" pitchFamily="34" charset="-120"/>
+                <a:latin typeface="Helvetica Neue" pitchFamily="34" charset="0"/>
+                <a:ea typeface="Helvetica Neue" pitchFamily="34" charset="-122"/>
+                <a:cs typeface="Helvetica Neue" pitchFamily="34" charset="-120"/>
               </a:rPr>
               <a:t>匯出向量 SVG 或合併 PDF，便於再編輯與交付。</a:t>
             </a:r>
@@ -2340,9 +2357,9 @@
                 <a:solidFill>
                   <a:srgbClr val="4F46E5"/>
                 </a:solidFill>
-                <a:latin typeface="Arial" pitchFamily="34" charset="0"/>
-                <a:ea typeface="Arial" pitchFamily="34" charset="-122"/>
-                <a:cs typeface="Arial" pitchFamily="34" charset="-120"/>
+                <a:latin typeface="Helvetica Neue" pitchFamily="34" charset="0"/>
+                <a:ea typeface="Helvetica Neue" pitchFamily="34" charset="-122"/>
+                <a:cs typeface="Helvetica Neue" pitchFamily="34" charset="-120"/>
               </a:rPr>
               <a:t>In visual communication 在視傳流程中</a:t>
             </a:r>
@@ -2379,9 +2396,9 @@
                 <a:solidFill>
                   <a:srgbClr val="64748B"/>
                 </a:solidFill>
-                <a:latin typeface="Arial" pitchFamily="34" charset="0"/>
-                <a:ea typeface="Arial" pitchFamily="34" charset="-122"/>
-                <a:cs typeface="Arial" pitchFamily="34" charset="-120"/>
+                <a:latin typeface="Helvetica Neue" pitchFamily="34" charset="0"/>
+                <a:ea typeface="Helvetica Neue" pitchFamily="34" charset="-122"/>
+                <a:cs typeface="Helvetica Neue" pitchFamily="34" charset="-120"/>
               </a:rPr>
               <a:t>How designers can use this tool</a:t>
             </a:r>
@@ -2398,7 +2415,7 @@
         <p:spPr>
           <a:xfrm>
             <a:off x="548640" y="1600200"/>
-            <a:ext cx="8046720" cy="3474720"/>
+            <a:ext cx="8046720" cy="3840480"/>
           </a:xfrm>
           <a:prstGeom prst="rect">
             <a:avLst/>
@@ -2422,9 +2439,9 @@
                 <a:solidFill>
                   <a:srgbClr val="0F172A"/>
                 </a:solidFill>
-                <a:latin typeface="Arial" pitchFamily="34" charset="0"/>
-                <a:ea typeface="Arial" pitchFamily="34" charset="-122"/>
-                <a:cs typeface="Arial" pitchFamily="34" charset="-120"/>
+                <a:latin typeface="Helvetica Neue" pitchFamily="34" charset="0"/>
+                <a:ea typeface="Helvetica Neue" pitchFamily="34" charset="-122"/>
+                <a:cs typeface="Helvetica Neue" pitchFamily="34" charset="-120"/>
               </a:rPr>
               <a:t>Direction exploration: color + style with immediate preview feedback.</a:t>
             </a:r>
@@ -2443,9 +2460,9 @@
                 <a:solidFill>
                   <a:srgbClr val="0F172A"/>
                 </a:solidFill>
-                <a:latin typeface="Arial" pitchFamily="34" charset="0"/>
-                <a:ea typeface="Arial" pitchFamily="34" charset="-122"/>
-                <a:cs typeface="Arial" pitchFamily="34" charset="-120"/>
+                <a:latin typeface="Helvetica Neue" pitchFamily="34" charset="0"/>
+                <a:ea typeface="Helvetica Neue" pitchFamily="34" charset="-122"/>
+                <a:cs typeface="Helvetica Neue" pitchFamily="34" charset="-120"/>
               </a:rPr>
               <a:t>方向探索：色彩與風格搭配，即時預覽回饋。</a:t>
             </a:r>
@@ -2464,9 +2481,9 @@
                 <a:solidFill>
                   <a:srgbClr val="0F172A"/>
                 </a:solidFill>
-                <a:latin typeface="Arial" pitchFamily="34" charset="0"/>
-                <a:ea typeface="Arial" pitchFamily="34" charset="-122"/>
-                <a:cs typeface="Arial" pitchFamily="34" charset="-120"/>
+                <a:latin typeface="Helvetica Neue" pitchFamily="34" charset="0"/>
+                <a:ea typeface="Helvetica Neue" pitchFamily="34" charset="-122"/>
+                <a:cs typeface="Helvetica Neue" pitchFamily="34" charset="-120"/>
               </a:rPr>
               <a:t>Layout sketching: grid remix + optional tile nudge.</a:t>
             </a:r>
@@ -2485,9 +2502,9 @@
                 <a:solidFill>
                   <a:srgbClr val="0F172A"/>
                 </a:solidFill>
-                <a:latin typeface="Arial" pitchFamily="34" charset="0"/>
-                <a:ea typeface="Arial" pitchFamily="34" charset="-122"/>
-                <a:cs typeface="Arial" pitchFamily="34" charset="-120"/>
+                <a:latin typeface="Helvetica Neue" pitchFamily="34" charset="0"/>
+                <a:ea typeface="Helvetica Neue" pitchFamily="34" charset="-122"/>
+                <a:cs typeface="Helvetica Neue" pitchFamily="34" charset="-120"/>
               </a:rPr>
               <a:t>版面草圖：網格重排與區塊微調。</a:t>
             </a:r>
@@ -2506,9 +2523,9 @@
                 <a:solidFill>
                   <a:srgbClr val="0F172A"/>
                 </a:solidFill>
-                <a:latin typeface="Arial" pitchFamily="34" charset="0"/>
-                <a:ea typeface="Arial" pitchFamily="34" charset="-122"/>
-                <a:cs typeface="Arial" pitchFamily="34" charset="-120"/>
+                <a:latin typeface="Helvetica Neue" pitchFamily="34" charset="0"/>
+                <a:ea typeface="Helvetica Neue" pitchFamily="34" charset="-122"/>
+                <a:cs typeface="Helvetica Neue" pitchFamily="34" charset="-120"/>
               </a:rPr>
               <a:t>Presentation packaging: reorder pages, unified look for different audiences.</a:t>
             </a:r>
@@ -2527,11 +2544,53 @@
                 <a:solidFill>
                   <a:srgbClr val="0F172A"/>
                 </a:solidFill>
-                <a:latin typeface="Arial" pitchFamily="34" charset="0"/>
-                <a:ea typeface="Arial" pitchFamily="34" charset="-122"/>
-                <a:cs typeface="Arial" pitchFamily="34" charset="-120"/>
+                <a:latin typeface="Helvetica Neue" pitchFamily="34" charset="0"/>
+                <a:ea typeface="Helvetica Neue" pitchFamily="34" charset="-122"/>
+                <a:cs typeface="Helvetica Neue" pitchFamily="34" charset="-120"/>
               </a:rPr>
               <a:t>展示包裝：調整頁序與整體視覺，面向不同觀眾。</a:t>
+            </a:r>
+            <a:endParaRPr lang="en-US" sz="1600" dirty="0"/>
+          </a:p>
+          <a:p>
+            <a:pPr marL="342900" indent="-342900">
+              <a:lnSpc>
+                <a:spcPct val="115000"/>
+              </a:lnSpc>
+              <a:buSzPct val="100000"/>
+              <a:buChar char="•"/>
+            </a:pPr>
+            <a:r>
+              <a:rPr lang="en-US" sz="1600" dirty="0">
+                <a:solidFill>
+                  <a:srgbClr val="0F172A"/>
+                </a:solidFill>
+                <a:latin typeface="Helvetica Neue" pitchFamily="34" charset="0"/>
+                <a:ea typeface="Helvetica Neue" pitchFamily="34" charset="-122"/>
+                <a:cs typeface="Helvetica Neue" pitchFamily="34" charset="-120"/>
+              </a:rPr>
+              <a:t>Workflow: Upload → set intent (palette/style/canvas/narrative/grid) → review per page → choose variant → export SVG/PDF.</a:t>
+            </a:r>
+            <a:endParaRPr lang="en-US" sz="1600" dirty="0"/>
+          </a:p>
+          <a:p>
+            <a:pPr marL="342900" indent="-342900">
+              <a:lnSpc>
+                <a:spcPct val="115000"/>
+              </a:lnSpc>
+              <a:buSzPct val="100000"/>
+              <a:buChar char="•"/>
+            </a:pPr>
+            <a:r>
+              <a:rPr lang="en-US" sz="1500" dirty="0">
+                <a:solidFill>
+                  <a:srgbClr val="0F172A"/>
+                </a:solidFill>
+                <a:latin typeface="Helvetica Neue" pitchFamily="34" charset="0"/>
+                <a:ea typeface="Helvetica Neue" pitchFamily="34" charset="-122"/>
+                <a:cs typeface="Helvetica Neue" pitchFamily="34" charset="-120"/>
+              </a:rPr>
+              <a:t>流程：上傳 → 設定意圖（色系/風格/畫布/敘事/網格）→ 逐頁審閱 → 選擇版本 → 匯出 SVG/PDF。</a:t>
             </a:r>
             <a:endParaRPr lang="en-US" sz="1600" dirty="0"/>
           </a:p>
@@ -2598,9 +2657,9 @@
                 <a:solidFill>
                   <a:srgbClr val="4F46E5"/>
                 </a:solidFill>
-                <a:latin typeface="Arial" pitchFamily="34" charset="0"/>
-                <a:ea typeface="Arial" pitchFamily="34" charset="-122"/>
-                <a:cs typeface="Arial" pitchFamily="34" charset="-120"/>
+                <a:latin typeface="Helvetica Neue" pitchFamily="34" charset="0"/>
+                <a:ea typeface="Helvetica Neue" pitchFamily="34" charset="-122"/>
+                <a:cs typeface="Helvetica Neue" pitchFamily="34" charset="-120"/>
               </a:rPr>
               <a:t>Design thinking 設計思維</a:t>
             </a:r>
@@ -2637,11 +2696,11 @@
                 <a:solidFill>
                   <a:srgbClr val="64748B"/>
                 </a:solidFill>
-                <a:latin typeface="Arial" pitchFamily="34" charset="0"/>
-                <a:ea typeface="Arial" pitchFamily="34" charset="-122"/>
-                <a:cs typeface="Arial" pitchFamily="34" charset="-120"/>
-              </a:rPr>
-              <a:t>Human–AI collaboration frame</a:t>
+                <a:latin typeface="Helvetica Neue" pitchFamily="34" charset="0"/>
+                <a:ea typeface="Helvetica Neue" pitchFamily="34" charset="-122"/>
+                <a:cs typeface="Helvetica Neue" pitchFamily="34" charset="-120"/>
+              </a:rPr>
+              <a:t>From layout pain → clear workflow</a:t>
             </a:r>
             <a:endParaRPr lang="en-US" sz="1300" dirty="0"/>
           </a:p>
@@ -2656,7 +2715,7 @@
         <p:spPr>
           <a:xfrm>
             <a:off x="548640" y="1600200"/>
-            <a:ext cx="8046720" cy="3840480"/>
+            <a:ext cx="8046720" cy="4206240"/>
           </a:xfrm>
           <a:prstGeom prst="rect">
             <a:avLst/>
@@ -2680,11 +2739,11 @@
                 <a:solidFill>
                   <a:srgbClr val="0F172A"/>
                 </a:solidFill>
-                <a:latin typeface="Arial" pitchFamily="34" charset="0"/>
-                <a:ea typeface="Arial" pitchFamily="34" charset="-122"/>
-                <a:cs typeface="Arial" pitchFamily="34" charset="-120"/>
-              </a:rPr>
-              <a:t>Empathize: fear of “black box” AI → keep designer in control.</a:t>
+                <a:latin typeface="Helvetica Neue" pitchFamily="34" charset="0"/>
+                <a:ea typeface="Helvetica Neue" pitchFamily="34" charset="-122"/>
+                <a:cs typeface="Helvetica Neue" pitchFamily="34" charset="-120"/>
+              </a:rPr>
+              <a:t>Empathize: designers lose time to repetitive layout work (order, grid, spacing).</a:t>
             </a:r>
             <a:endParaRPr lang="en-US" sz="1600" dirty="0"/>
           </a:p>
@@ -2701,11 +2760,11 @@
                 <a:solidFill>
                   <a:srgbClr val="0F172A"/>
                 </a:solidFill>
-                <a:latin typeface="Arial" pitchFamily="34" charset="0"/>
-                <a:ea typeface="Arial" pitchFamily="34" charset="-122"/>
-                <a:cs typeface="Arial" pitchFamily="34" charset="-120"/>
-              </a:rPr>
-              <a:t>同理：怕黑箱 AI → 決策權留在設計師。</a:t>
+                <a:latin typeface="Helvetica Neue" pitchFamily="34" charset="0"/>
+                <a:ea typeface="Helvetica Neue" pitchFamily="34" charset="-122"/>
+                <a:cs typeface="Helvetica Neue" pitchFamily="34" charset="-120"/>
+              </a:rPr>
+              <a:t>同理：設計師把時間花在重複排版（頁序、網格、字距）上。</a:t>
             </a:r>
             <a:endParaRPr lang="en-US" sz="1600" dirty="0"/>
           </a:p>
@@ -2722,11 +2781,11 @@
                 <a:solidFill>
                   <a:srgbClr val="0F172A"/>
                 </a:solidFill>
-                <a:latin typeface="Arial" pitchFamily="34" charset="0"/>
-                <a:ea typeface="Arial" pitchFamily="34" charset="-122"/>
-                <a:cs typeface="Arial" pitchFamily="34" charset="-120"/>
-              </a:rPr>
-              <a:t>Define: automate packaging &amp; variation, not final authorship.</a:t>
+                <a:latin typeface="Helvetica Neue" pitchFamily="34" charset="0"/>
+                <a:ea typeface="Helvetica Neue" pitchFamily="34" charset="-122"/>
+                <a:cs typeface="Helvetica Neue" pitchFamily="34" charset="-120"/>
+              </a:rPr>
+              <a:t>Define: assist decisions, not replace authorship — keep designer in control.</a:t>
             </a:r>
             <a:endParaRPr lang="en-US" sz="1600" dirty="0"/>
           </a:p>
@@ -2743,11 +2802,11 @@
                 <a:solidFill>
                   <a:srgbClr val="0F172A"/>
                 </a:solidFill>
-                <a:latin typeface="Arial" pitchFamily="34" charset="0"/>
-                <a:ea typeface="Arial" pitchFamily="34" charset="-122"/>
-                <a:cs typeface="Arial" pitchFamily="34" charset="-120"/>
-              </a:rPr>
-              <a:t>定義：自動化包裝與變體，而非最終創作權。</a:t>
+                <a:latin typeface="Helvetica Neue" pitchFamily="34" charset="0"/>
+                <a:ea typeface="Helvetica Neue" pitchFamily="34" charset="-122"/>
+                <a:cs typeface="Helvetica Neue" pitchFamily="34" charset="-120"/>
+              </a:rPr>
+              <a:t>定義：協助決策而不是取代創作權 — 讓設計師保持控制。</a:t>
             </a:r>
             <a:endParaRPr lang="en-US" sz="1600" dirty="0"/>
           </a:p>
@@ -2764,11 +2823,11 @@
                 <a:solidFill>
                   <a:srgbClr val="0F172A"/>
                 </a:solidFill>
-                <a:latin typeface="Arial" pitchFamily="34" charset="0"/>
-                <a:ea typeface="Arial" pitchFamily="34" charset="-122"/>
-                <a:cs typeface="Arial" pitchFamily="34" charset="-120"/>
-              </a:rPr>
-              <a:t>Ideate → Prototype: wizard + dock preview + 3 variants + bilingual UI.</a:t>
+                <a:latin typeface="Helvetica Neue" pitchFamily="34" charset="0"/>
+                <a:ea typeface="Helvetica Neue" pitchFamily="34" charset="-122"/>
+                <a:cs typeface="Helvetica Neue" pitchFamily="34" charset="-120"/>
+              </a:rPr>
+              <a:t>Ideate: wizard + persistent dock + only 3 variants per page for faster comparison.</a:t>
             </a:r>
             <a:endParaRPr lang="en-US" sz="1600" dirty="0"/>
           </a:p>
@@ -2785,11 +2844,11 @@
                 <a:solidFill>
                   <a:srgbClr val="0F172A"/>
                 </a:solidFill>
-                <a:latin typeface="Arial" pitchFamily="34" charset="0"/>
-                <a:ea typeface="Arial" pitchFamily="34" charset="-122"/>
-                <a:cs typeface="Arial" pitchFamily="34" charset="-120"/>
-              </a:rPr>
-              <a:t>發想與原型：精靈流程、側欄預覽、三版本、雙語介面。</a:t>
+                <a:latin typeface="Helvetica Neue" pitchFamily="34" charset="0"/>
+                <a:ea typeface="Helvetica Neue" pitchFamily="34" charset="-122"/>
+                <a:cs typeface="Helvetica Neue" pitchFamily="34" charset="-120"/>
+              </a:rPr>
+              <a:t>發想：精靈流程 + 持續側欄預覽 + 每頁僅 3 個版本，提升比對效率。</a:t>
             </a:r>
             <a:endParaRPr lang="en-US" sz="1600" dirty="0"/>
           </a:p>
@@ -2806,11 +2865,11 @@
                 <a:solidFill>
                   <a:srgbClr val="0F172A"/>
                 </a:solidFill>
-                <a:latin typeface="Arial" pitchFamily="34" charset="0"/>
-                <a:ea typeface="Arial" pitchFamily="34" charset="-122"/>
-                <a:cs typeface="Arial" pitchFamily="34" charset="-120"/>
-              </a:rPr>
-              <a:t>Test: preview clarity, export reliability, edge-case grids (e.g. 1×2).</a:t>
+                <a:latin typeface="Helvetica Neue" pitchFamily="34" charset="0"/>
+                <a:ea typeface="Helvetica Neue" pitchFamily="34" charset="-122"/>
+                <a:cs typeface="Helvetica Neue" pitchFamily="34" charset="-120"/>
+              </a:rPr>
+              <a:t>Prototype: bilingual UI, grid remix, tile nudge, before/after compare — designed for readability.</a:t>
             </a:r>
             <a:endParaRPr lang="en-US" sz="1600" dirty="0"/>
           </a:p>
@@ -2827,11 +2886,53 @@
                 <a:solidFill>
                   <a:srgbClr val="0F172A"/>
                 </a:solidFill>
-                <a:latin typeface="Arial" pitchFamily="34" charset="0"/>
-                <a:ea typeface="Arial" pitchFamily="34" charset="-122"/>
-                <a:cs typeface="Arial" pitchFamily="34" charset="-120"/>
-              </a:rPr>
-              <a:t>測試：預覽可讀性、匯出穩定性、特殊網格情境。</a:t>
+                <a:latin typeface="Helvetica Neue" pitchFamily="34" charset="0"/>
+                <a:ea typeface="Helvetica Neue" pitchFamily="34" charset="-122"/>
+                <a:cs typeface="Helvetica Neue" pitchFamily="34" charset="-120"/>
+              </a:rPr>
+              <a:t>原型：雙語介面、網格重排、區塊微調、Before/After 對比 — 以可讀性為核心排版。</a:t>
+            </a:r>
+            <a:endParaRPr lang="en-US" sz="1600" dirty="0"/>
+          </a:p>
+          <a:p>
+            <a:pPr marL="342900" indent="-342900">
+              <a:lnSpc>
+                <a:spcPct val="115000"/>
+              </a:lnSpc>
+              <a:buSzPct val="100000"/>
+              <a:buChar char="•"/>
+            </a:pPr>
+            <a:r>
+              <a:rPr lang="en-US" sz="1600" dirty="0">
+                <a:solidFill>
+                  <a:srgbClr val="0F172A"/>
+                </a:solidFill>
+                <a:latin typeface="Helvetica Neue" pitchFamily="34" charset="0"/>
+                <a:ea typeface="Helvetica Neue" pitchFamily="34" charset="-122"/>
+                <a:cs typeface="Helvetica Neue" pitchFamily="34" charset="-120"/>
+              </a:rPr>
+              <a:t>Test: keep previews synchronized across steps and ensure typography hierarchy stays stable.</a:t>
+            </a:r>
+            <a:endParaRPr lang="en-US" sz="1600" dirty="0"/>
+          </a:p>
+          <a:p>
+            <a:pPr marL="342900" indent="-342900">
+              <a:lnSpc>
+                <a:spcPct val="115000"/>
+              </a:lnSpc>
+              <a:buSzPct val="100000"/>
+              <a:buChar char="•"/>
+            </a:pPr>
+            <a:r>
+              <a:rPr lang="en-US" sz="1500" dirty="0">
+                <a:solidFill>
+                  <a:srgbClr val="0F172A"/>
+                </a:solidFill>
+                <a:latin typeface="Helvetica Neue" pitchFamily="34" charset="0"/>
+                <a:ea typeface="Helvetica Neue" pitchFamily="34" charset="-122"/>
+                <a:cs typeface="Helvetica Neue" pitchFamily="34" charset="-120"/>
+              </a:rPr>
+              <a:t>測試：讓步驟間預覽同步、並確保字體層級在界面中保持穩定。</a:t>
             </a:r>
             <a:endParaRPr lang="en-US" sz="1600" dirty="0"/>
           </a:p>
@@ -2898,11 +2999,11 @@
                 <a:solidFill>
                   <a:srgbClr val="4F46E5"/>
                 </a:solidFill>
-                <a:latin typeface="Arial" pitchFamily="34" charset="0"/>
-                <a:ea typeface="Arial" pitchFamily="34" charset="-122"/>
-                <a:cs typeface="Arial" pitchFamily="34" charset="-120"/>
-              </a:rPr>
-              <a:t>Key UI/UX decisions 介面決策</a:t>
+                <a:latin typeface="Helvetica Neue" pitchFamily="34" charset="0"/>
+                <a:ea typeface="Helvetica Neue" pitchFamily="34" charset="-122"/>
+                <a:cs typeface="Helvetica Neue" pitchFamily="34" charset="-120"/>
+              </a:rPr>
+              <a:t>Design system principles 版面設計原則</a:t>
             </a:r>
             <a:endParaRPr lang="en-US" sz="2800" dirty="0"/>
           </a:p>
@@ -2937,11 +3038,11 @@
                 <a:solidFill>
                   <a:srgbClr val="64748B"/>
                 </a:solidFill>
-                <a:latin typeface="Arial" pitchFamily="34" charset="0"/>
-                <a:ea typeface="Arial" pitchFamily="34" charset="-122"/>
-                <a:cs typeface="Arial" pitchFamily="34" charset="-120"/>
-              </a:rPr>
-              <a:t>What we built and why</a:t>
+                <a:latin typeface="Helvetica Neue" pitchFamily="34" charset="0"/>
+                <a:ea typeface="Helvetica Neue" pitchFamily="34" charset="-122"/>
+                <a:cs typeface="Helvetica Neue" pitchFamily="34" charset="-120"/>
+              </a:rPr>
+              <a:t>Aesthetic consistency, faster decisions</a:t>
             </a:r>
             <a:endParaRPr lang="en-US" sz="1300" dirty="0"/>
           </a:p>
@@ -2962,16 +3063,16 @@
           </p:nvPr>
         </p:nvGraphicFramePr>
         <p:xfrm>
-          <a:off x="457200" y="1508760"/>
-          <a:ext cx="8229600" cy="914400"/>
+          <a:off x="411480" y="1508760"/>
+          <a:ext cx="8321040" cy="914400"/>
         </p:xfrm>
         <a:graphic>
           <a:graphicData uri="http://schemas.openxmlformats.org/drawingml/2006/table">
             <a:tbl>
               <a:tblPr/>
               <a:tblGrid>
-                <a:gridCol w="2377440"/>
-                <a:gridCol w="5852160"/>
+                <a:gridCol w="2194560"/>
+                <a:gridCol w="6126480"/>
               </a:tblGrid>
               <a:tr h="0">
                 <a:tc>
@@ -2988,7 +3089,7 @@
                             <a:srgbClr val="0F172A"/>
                           </a:solidFill>
                         </a:rPr>
-                        <a:t>Decision 決策</a:t>
+                        <a:t>Principle 原則</a:t>
                       </a:r>
                       <a:endParaRPr lang="en-US" sz="1200" dirty="0"/>
                     </a:p>
@@ -3049,7 +3150,7 @@
                             <a:srgbClr val="0F172A"/>
                           </a:solidFill>
                         </a:rPr>
-                        <a:t>Rationale 理由</a:t>
+                        <a:t>How it appears in UI 具體呈現在介面</a:t>
                       </a:r>
                       <a:endParaRPr lang="en-US" sz="1200" dirty="0"/>
                     </a:p>
@@ -3112,7 +3213,7 @@
                             <a:srgbClr val="000000"/>
                           </a:solidFill>
                         </a:rPr>
-                        <a:t>Stepper wizard 步驟精靈</a:t>
+                        <a:t>Whitespace 留白</a:t>
                       </a:r>
                       <a:endParaRPr lang="en-US" sz="1200" dirty="0"/>
                     </a:p>
@@ -3170,7 +3271,7 @@
                             <a:srgbClr val="000000"/>
                           </a:solidFill>
                         </a:rPr>
-                        <a:t>Lower cognitive load; one task per step.</a:t>
+                        <a:t>Cards use padding + gap; dock preview keeps focus.</a:t>
                       </a:r>
                       <a:endParaRPr lang="en-US" sz="1200" dirty="0"/>
                     </a:p>
@@ -3230,7 +3331,7 @@
                             <a:srgbClr val="000000"/>
                           </a:solidFill>
                         </a:rPr>
-                        <a:t>Preview dock 即時預覽</a:t>
+                        <a:t>Visual hierarchy 視覺層級</a:t>
                       </a:r>
                       <a:endParaRPr lang="en-US" sz="1200" dirty="0"/>
                     </a:p>
@@ -3288,7 +3389,7 @@
                             <a:srgbClr val="000000"/>
                           </a:solidFill>
                         </a:rPr>
-                        <a:t>Tight feedback loop while editing options.</a:t>
+                        <a:t>Purple titles + muted body; consistent left alignment.</a:t>
                       </a:r>
                       <a:endParaRPr lang="en-US" sz="1200" dirty="0"/>
                     </a:p>
@@ -3348,7 +3449,7 @@
                             <a:srgbClr val="000000"/>
                           </a:solidFill>
                         </a:rPr>
-                        <a:t>Bilingual toggle 雙語切換</a:t>
+                        <a:t>Grid as sketch tool 網格即草圖</a:t>
                       </a:r>
                       <a:endParaRPr lang="en-US" sz="1200" dirty="0"/>
                     </a:p>
@@ -3406,7 +3507,7 @@
                             <a:srgbClr val="000000"/>
                           </a:solidFill>
                         </a:rPr>
-                        <a:t>Course + real mixed-locale users.</a:t>
+                        <a:t>2×2 / 1×2 / 2×1 presets + tile nudge for composition iteration.</a:t>
                       </a:r>
                       <a:endParaRPr lang="en-US" sz="1200" dirty="0"/>
                     </a:p>
@@ -3466,7 +3567,7 @@
                             <a:srgbClr val="000000"/>
                           </a:solidFill>
                         </a:rPr>
-                        <a:t>3 variants 三版本</a:t>
+                        <a:t>Color contrast 對比與可讀性</a:t>
                       </a:r>
                       <a:endParaRPr lang="en-US" sz="1200" dirty="0"/>
                     </a:p>
@@ -3524,7 +3625,7 @@
                             <a:srgbClr val="000000"/>
                           </a:solidFill>
                         </a:rPr>
-                        <a:t>Enough to compare; avoids choice overload.</a:t>
+                        <a:t>Before/After modes separate hue vs layout for decision confidence.</a:t>
                       </a:r>
                       <a:endParaRPr lang="en-US" sz="1200" dirty="0"/>
                     </a:p>
@@ -3584,7 +3685,7 @@
                             <a:srgbClr val="000000"/>
                           </a:solidFill>
                         </a:rPr>
-                        <a:t>Before/After modes</a:t>
+                        <a:t>Bilingual clarity 雙語清晰</a:t>
                       </a:r>
                       <a:endParaRPr lang="en-US" sz="1200" dirty="0"/>
                     </a:p>
@@ -3642,125 +3743,7 @@
                             <a:srgbClr val="000000"/>
                           </a:solidFill>
                         </a:rPr>
-                        <a:t>Separate color vs. layout judgment.</a:t>
-                      </a:r>
-                      <a:endParaRPr lang="en-US" sz="1200" dirty="0"/>
-                    </a:p>
-                  </a:txBody>
-                  <a:tcPr marL="91440" marR="91440" marT="45720" marB="45720">
-                    <a:lnL w="6350" cap="flat" cmpd="sng" algn="ctr">
-                      <a:solidFill>
-                        <a:srgbClr val="CBD5E1"/>
-                      </a:solidFill>
-                      <a:prstDash val="solid"/>
-                      <a:round/>
-                      <a:headEnd type="none" w="med" len="med"/>
-                      <a:tailEnd type="none" w="med" len="med"/>
-                    </a:lnL>
-                    <a:lnR w="6350" cap="flat" cmpd="sng" algn="ctr">
-                      <a:solidFill>
-                        <a:srgbClr val="CBD5E1"/>
-                      </a:solidFill>
-                      <a:prstDash val="solid"/>
-                      <a:round/>
-                      <a:headEnd type="none" w="med" len="med"/>
-                      <a:tailEnd type="none" w="med" len="med"/>
-                    </a:lnR>
-                    <a:lnT w="6350" cap="flat" cmpd="sng" algn="ctr">
-                      <a:solidFill>
-                        <a:srgbClr val="CBD5E1"/>
-                      </a:solidFill>
-                      <a:prstDash val="solid"/>
-                      <a:round/>
-                      <a:headEnd type="none" w="med" len="med"/>
-                      <a:tailEnd type="none" w="med" len="med"/>
-                    </a:lnT>
-                    <a:lnB w="6350" cap="flat" cmpd="sng" algn="ctr">
-                      <a:solidFill>
-                        <a:srgbClr val="CBD5E1"/>
-                      </a:solidFill>
-                      <a:prstDash val="solid"/>
-                      <a:round/>
-                      <a:headEnd type="none" w="med" len="med"/>
-                      <a:tailEnd type="none" w="med" len="med"/>
-                    </a:lnB>
-                  </a:tcPr>
-                </a:tc>
-              </a:tr>
-              <a:tr h="0">
-                <a:tc>
-                  <a:txBody>
-                    <a:bodyPr/>
-                    <a:lstStyle/>
-                    <a:p>
-                      <a:pPr indent="0" marL="0">
-                        <a:buNone/>
-                      </a:pPr>
-                      <a:r>
-                        <a:rPr lang="en-US" sz="1200" dirty="0">
-                          <a:solidFill>
-                            <a:srgbClr val="000000"/>
-                          </a:solidFill>
-                        </a:rPr>
-                        <a:t>Grid thumbnails 網格示意</a:t>
-                      </a:r>
-                      <a:endParaRPr lang="en-US" sz="1200" dirty="0"/>
-                    </a:p>
-                  </a:txBody>
-                  <a:tcPr marL="91440" marR="91440" marT="45720" marB="45720">
-                    <a:lnL w="6350" cap="flat" cmpd="sng" algn="ctr">
-                      <a:solidFill>
-                        <a:srgbClr val="CBD5E1"/>
-                      </a:solidFill>
-                      <a:prstDash val="solid"/>
-                      <a:round/>
-                      <a:headEnd type="none" w="med" len="med"/>
-                      <a:tailEnd type="none" w="med" len="med"/>
-                    </a:lnL>
-                    <a:lnR w="6350" cap="flat" cmpd="sng" algn="ctr">
-                      <a:solidFill>
-                        <a:srgbClr val="CBD5E1"/>
-                      </a:solidFill>
-                      <a:prstDash val="solid"/>
-                      <a:round/>
-                      <a:headEnd type="none" w="med" len="med"/>
-                      <a:tailEnd type="none" w="med" len="med"/>
-                    </a:lnR>
-                    <a:lnT w="6350" cap="flat" cmpd="sng" algn="ctr">
-                      <a:solidFill>
-                        <a:srgbClr val="CBD5E1"/>
-                      </a:solidFill>
-                      <a:prstDash val="solid"/>
-                      <a:round/>
-                      <a:headEnd type="none" w="med" len="med"/>
-                      <a:tailEnd type="none" w="med" len="med"/>
-                    </a:lnT>
-                    <a:lnB w="6350" cap="flat" cmpd="sng" algn="ctr">
-                      <a:solidFill>
-                        <a:srgbClr val="CBD5E1"/>
-                      </a:solidFill>
-                      <a:prstDash val="solid"/>
-                      <a:round/>
-                      <a:headEnd type="none" w="med" len="med"/>
-                      <a:tailEnd type="none" w="med" len="med"/>
-                    </a:lnB>
-                  </a:tcPr>
-                </a:tc>
-                <a:tc>
-                  <a:txBody>
-                    <a:bodyPr/>
-                    <a:lstStyle/>
-                    <a:p>
-                      <a:pPr indent="0" marL="0">
-                        <a:buNone/>
-                      </a:pPr>
-                      <a:r>
-                        <a:rPr lang="en-US" sz="1200" dirty="0">
-                          <a:solidFill>
-                            <a:srgbClr val="000000"/>
-                          </a:solidFill>
-                        </a:rPr>
-                        <a:t>Scannable 2×2 / 1×2 / 2×1 layouts.</a:t>
+                        <a:t>Language toggle with persistent preference via localStorage.</a:t>
                       </a:r>
                       <a:endParaRPr lang="en-US" sz="1200" dirty="0"/>
                     </a:p>
@@ -3870,9 +3853,9 @@
                 <a:solidFill>
                   <a:srgbClr val="4F46E5"/>
                 </a:solidFill>
-                <a:latin typeface="Arial" pitchFamily="34" charset="0"/>
-                <a:ea typeface="Arial" pitchFamily="34" charset="-122"/>
-                <a:cs typeface="Arial" pitchFamily="34" charset="-120"/>
+                <a:latin typeface="Helvetica Neue" pitchFamily="34" charset="0"/>
+                <a:ea typeface="Helvetica Neue" pitchFamily="34" charset="-122"/>
+                <a:cs typeface="Helvetica Neue" pitchFamily="34" charset="-120"/>
               </a:rPr>
               <a:t>Demo script 演示腳本</a:t>
             </a:r>
@@ -3909,9 +3892,9 @@
                 <a:solidFill>
                   <a:srgbClr val="64748B"/>
                 </a:solidFill>
-                <a:latin typeface="Arial" pitchFamily="34" charset="0"/>
-                <a:ea typeface="Arial" pitchFamily="34" charset="-122"/>
-                <a:cs typeface="Arial" pitchFamily="34" charset="-120"/>
+                <a:latin typeface="Helvetica Neue" pitchFamily="34" charset="0"/>
+                <a:ea typeface="Helvetica Neue" pitchFamily="34" charset="-122"/>
+                <a:cs typeface="Helvetica Neue" pitchFamily="34" charset="-120"/>
               </a:rPr>
               <a:t>For your screen recording / video</a:t>
             </a:r>
@@ -3952,11 +3935,11 @@
                 <a:solidFill>
                   <a:srgbClr val="0F172A"/>
                 </a:solidFill>
-                <a:latin typeface="Arial" pitchFamily="34" charset="0"/>
-                <a:ea typeface="Arial" pitchFamily="34" charset="-122"/>
-                <a:cs typeface="Arial" pitchFamily="34" charset="-120"/>
-              </a:rPr>
-              <a:t>Toggle 中文 ↔ English in the header.</a:t>
+                <a:latin typeface="Helvetica Neue" pitchFamily="34" charset="0"/>
+                <a:ea typeface="Helvetica Neue" pitchFamily="34" charset="-122"/>
+                <a:cs typeface="Helvetica Neue" pitchFamily="34" charset="-120"/>
+              </a:rPr>
+              <a:t>Show bilingual toggle (中文 ↔ English).</a:t>
             </a:r>
             <a:endParaRPr lang="en-US" sz="1600" dirty="0"/>
           </a:p>
@@ -3973,11 +3956,11 @@
                 <a:solidFill>
                   <a:srgbClr val="0F172A"/>
                 </a:solidFill>
-                <a:latin typeface="Arial" pitchFamily="34" charset="0"/>
-                <a:ea typeface="Arial" pitchFamily="34" charset="-122"/>
-                <a:cs typeface="Arial" pitchFamily="34" charset="-120"/>
-              </a:rPr>
-              <a:t>Upload SVG or PDF → set palette, style, optional grid.</a:t>
+                <a:latin typeface="Helvetica Neue" pitchFamily="34" charset="0"/>
+                <a:ea typeface="Helvetica Neue" pitchFamily="34" charset="-122"/>
+                <a:cs typeface="Helvetica Neue" pitchFamily="34" charset="-120"/>
+              </a:rPr>
+              <a:t>Upload SVG/PDF → in the dock, change palette/style/grid and watch hierarchy update.</a:t>
             </a:r>
             <a:endParaRPr lang="en-US" sz="1600" dirty="0"/>
           </a:p>
@@ -3994,11 +3977,11 @@
                 <a:solidFill>
                   <a:srgbClr val="0F172A"/>
                 </a:solidFill>
-                <a:latin typeface="Arial" pitchFamily="34" charset="0"/>
-                <a:ea typeface="Arial" pitchFamily="34" charset="-122"/>
-                <a:cs typeface="Arial" pitchFamily="34" charset="-120"/>
-              </a:rPr>
-              <a:t>Optional: AI brief / style suggest (API key local only—never in repo).</a:t>
+                <a:latin typeface="Helvetica Neue" pitchFamily="34" charset="0"/>
+                <a:ea typeface="Helvetica Neue" pitchFamily="34" charset="-122"/>
+                <a:cs typeface="Helvetica Neue" pitchFamily="34" charset="-120"/>
+              </a:rPr>
+              <a:t>Switch Before/After modes to separate hue decisions from layout decisions.</a:t>
             </a:r>
             <a:endParaRPr lang="en-US" sz="1600" dirty="0"/>
           </a:p>
@@ -4015,11 +3998,11 @@
                 <a:solidFill>
                   <a:srgbClr val="0F172A"/>
                 </a:solidFill>
-                <a:latin typeface="Arial" pitchFamily="34" charset="0"/>
-                <a:ea typeface="Arial" pitchFamily="34" charset="-122"/>
-                <a:cs typeface="Arial" pitchFamily="34" charset="-120"/>
-              </a:rPr>
-              <a:t>Generate pages → pick a variant → WebGL preview &amp; compare.</a:t>
+                <a:latin typeface="Helvetica Neue" pitchFamily="34" charset="0"/>
+                <a:ea typeface="Helvetica Neue" pitchFamily="34" charset="-122"/>
+                <a:cs typeface="Helvetica Neue" pitchFamily="34" charset="-120"/>
+              </a:rPr>
+              <a:t>Pick one variant per page; show 1×2 / 2×1 presets for asymmetric composition.</a:t>
             </a:r>
             <a:endParaRPr lang="en-US" sz="1600" dirty="0"/>
           </a:p>
@@ -4036,11 +4019,11 @@
                 <a:solidFill>
                   <a:srgbClr val="0F172A"/>
                 </a:solidFill>
-                <a:latin typeface="Arial" pitchFamily="34" charset="0"/>
-                <a:ea typeface="Arial" pitchFamily="34" charset="-122"/>
-                <a:cs typeface="Arial" pitchFamily="34" charset="-120"/>
-              </a:rPr>
-              <a:t>Export PDF or per-page SVG.</a:t>
+                <a:latin typeface="Helvetica Neue" pitchFamily="34" charset="0"/>
+                <a:ea typeface="Helvetica Neue" pitchFamily="34" charset="-122"/>
+                <a:cs typeface="Helvetica Neue" pitchFamily="34" charset="-120"/>
+              </a:rPr>
+              <a:t>Export as merged PDF and per-page SVG for further visual refinement.</a:t>
             </a:r>
             <a:endParaRPr lang="en-US" sz="1600" dirty="0"/>
           </a:p>
@@ -4107,9 +4090,9 @@
                 <a:solidFill>
                   <a:srgbClr val="4F46E5"/>
                 </a:solidFill>
-                <a:latin typeface="Arial" pitchFamily="34" charset="0"/>
-                <a:ea typeface="Arial" pitchFamily="34" charset="-122"/>
-                <a:cs typeface="Arial" pitchFamily="34" charset="-120"/>
+                <a:latin typeface="Helvetica Neue" pitchFamily="34" charset="0"/>
+                <a:ea typeface="Helvetica Neue" pitchFamily="34" charset="-122"/>
+                <a:cs typeface="Helvetica Neue" pitchFamily="34" charset="-120"/>
               </a:rPr>
               <a:t>Reflection 反思</a:t>
             </a:r>
@@ -4146,11 +4129,11 @@
                 <a:solidFill>
                   <a:srgbClr val="64748B"/>
                 </a:solidFill>
-                <a:latin typeface="Arial" pitchFamily="34" charset="0"/>
-                <a:ea typeface="Arial" pitchFamily="34" charset="-122"/>
-                <a:cs typeface="Arial" pitchFamily="34" charset="-120"/>
-              </a:rPr>
-              <a:t>Next steps · 可改進方向</a:t>
+                <a:latin typeface="Helvetica Neue" pitchFamily="34" charset="0"/>
+                <a:ea typeface="Helvetica Neue" pitchFamily="34" charset="-122"/>
+                <a:cs typeface="Helvetica Neue" pitchFamily="34" charset="-120"/>
+              </a:rPr>
+              <a:t>Design focus · Next steps</a:t>
             </a:r>
             <a:endParaRPr lang="en-US" sz="1300" dirty="0"/>
           </a:p>
@@ -4165,7 +4148,7 @@
         <p:spPr>
           <a:xfrm>
             <a:off x="548640" y="1600200"/>
-            <a:ext cx="8046720" cy="3200400"/>
+            <a:ext cx="8046720" cy="3474720"/>
           </a:xfrm>
           <a:prstGeom prst="rect">
             <a:avLst/>
@@ -4189,11 +4172,11 @@
                 <a:solidFill>
                   <a:srgbClr val="0F172A"/>
                 </a:solidFill>
-                <a:latin typeface="Arial" pitchFamily="34" charset="0"/>
-                <a:ea typeface="Arial" pitchFamily="34" charset="-122"/>
-                <a:cs typeface="Arial" pitchFamily="34" charset="-120"/>
-              </a:rPr>
-              <a:t>What worked: fast iteration on look &amp; layout in the browser.</a:t>
+                <a:latin typeface="Helvetica Neue" pitchFamily="34" charset="0"/>
+                <a:ea typeface="Helvetica Neue" pitchFamily="34" charset="-122"/>
+                <a:cs typeface="Helvetica Neue" pitchFamily="34" charset="-120"/>
+              </a:rPr>
+              <a:t>What worked: clear type hierarchy + stable dock preview for confident decisions.</a:t>
             </a:r>
             <a:endParaRPr lang="en-US" sz="1600" dirty="0"/>
           </a:p>
@@ -4210,11 +4193,11 @@
                 <a:solidFill>
                   <a:srgbClr val="0F172A"/>
                 </a:solidFill>
-                <a:latin typeface="Arial" pitchFamily="34" charset="0"/>
-                <a:ea typeface="Arial" pitchFamily="34" charset="-122"/>
-                <a:cs typeface="Arial" pitchFamily="34" charset="-120"/>
-              </a:rPr>
-              <a:t>可改進：接入真實 AI 佈局模型、更細字體控制、無障礙稽核。</a:t>
+                <a:latin typeface="Helvetica Neue" pitchFamily="34" charset="0"/>
+                <a:ea typeface="Helvetica Neue" pitchFamily="34" charset="-122"/>
+                <a:cs typeface="Helvetica Neue" pitchFamily="34" charset="-120"/>
+              </a:rPr>
+              <a:t>有效之處：清晰字體層級 + 穩定 dock 預覽，讓決策更有把握。</a:t>
             </a:r>
             <a:endParaRPr lang="en-US" sz="1600" dirty="0"/>
           </a:p>
@@ -4231,11 +4214,11 @@
                 <a:solidFill>
                   <a:srgbClr val="0F172A"/>
                 </a:solidFill>
-                <a:latin typeface="Arial" pitchFamily="34" charset="0"/>
-                <a:ea typeface="Arial" pitchFamily="34" charset="-122"/>
-                <a:cs typeface="Arial" pitchFamily="34" charset="-120"/>
-              </a:rPr>
-              <a:t>Ethics: API keys only in .env.local; no training on uploads in this prototype.</a:t>
+                <a:latin typeface="Helvetica Neue" pitchFamily="34" charset="0"/>
+                <a:ea typeface="Helvetica Neue" pitchFamily="34" charset="-122"/>
+                <a:cs typeface="Helvetica Neue" pitchFamily="34" charset="-120"/>
+              </a:rPr>
+              <a:t>What to improve: finer typography controls and more layout-ready components.</a:t>
             </a:r>
             <a:endParaRPr lang="en-US" sz="1600" dirty="0"/>
           </a:p>
@@ -4252,11 +4235,53 @@
                 <a:solidFill>
                   <a:srgbClr val="0F172A"/>
                 </a:solidFill>
-                <a:latin typeface="Arial" pitchFamily="34" charset="0"/>
-                <a:ea typeface="Arial" pitchFamily="34" charset="-122"/>
-                <a:cs typeface="Arial" pitchFamily="34" charset="-120"/>
-              </a:rPr>
-              <a:t>倫理：金鑰僅存本機；本原型不上傳訓練。</a:t>
+                <a:latin typeface="Helvetica Neue" pitchFamily="34" charset="0"/>
+                <a:ea typeface="Helvetica Neue" pitchFamily="34" charset="-122"/>
+                <a:cs typeface="Helvetica Neue" pitchFamily="34" charset="-120"/>
+              </a:rPr>
+              <a:t>接續改進：更細字體控制與更多可直接用的版面元件。</a:t>
+            </a:r>
+            <a:endParaRPr lang="en-US" sz="1600" dirty="0"/>
+          </a:p>
+          <a:p>
+            <a:pPr marL="342900" indent="-342900">
+              <a:lnSpc>
+                <a:spcPct val="115000"/>
+              </a:lnSpc>
+              <a:buSzPct val="100000"/>
+              <a:buChar char="•"/>
+            </a:pPr>
+            <a:r>
+              <a:rPr lang="en-US" sz="1600" dirty="0">
+                <a:solidFill>
+                  <a:srgbClr val="0F172A"/>
+                </a:solidFill>
+                <a:latin typeface="Helvetica Neue" pitchFamily="34" charset="0"/>
+                <a:ea typeface="Helvetica Neue" pitchFamily="34" charset="-122"/>
+                <a:cs typeface="Helvetica Neue" pitchFamily="34" charset="-120"/>
+              </a:rPr>
+              <a:t>Ethics: API keys only in .env.local; no training on user uploads in this prototype.</a:t>
+            </a:r>
+            <a:endParaRPr lang="en-US" sz="1600" dirty="0"/>
+          </a:p>
+          <a:p>
+            <a:pPr marL="342900" indent="-342900">
+              <a:lnSpc>
+                <a:spcPct val="115000"/>
+              </a:lnSpc>
+              <a:buSzPct val="100000"/>
+              <a:buChar char="•"/>
+            </a:pPr>
+            <a:r>
+              <a:rPr lang="en-US" sz="1500" dirty="0">
+                <a:solidFill>
+                  <a:srgbClr val="0F172A"/>
+                </a:solidFill>
+                <a:latin typeface="Helvetica Neue" pitchFamily="34" charset="0"/>
+                <a:ea typeface="Helvetica Neue" pitchFamily="34" charset="-122"/>
+                <a:cs typeface="Helvetica Neue" pitchFamily="34" charset="-120"/>
+              </a:rPr>
+              <a:t>倫理：API 金鑰只在本機；此原型不對用戶上傳做訓練。</a:t>
             </a:r>
             <a:endParaRPr lang="en-US" sz="1600" dirty="0"/>
           </a:p>
@@ -4323,9 +4348,9 @@
                 <a:solidFill>
                   <a:srgbClr val="4F46E5"/>
                 </a:solidFill>
-                <a:latin typeface="Arial" pitchFamily="34" charset="0"/>
-                <a:ea typeface="Arial" pitchFamily="34" charset="-122"/>
-                <a:cs typeface="Arial" pitchFamily="34" charset="-120"/>
+                <a:latin typeface="Helvetica Neue" pitchFamily="34" charset="0"/>
+                <a:ea typeface="Helvetica Neue" pitchFamily="34" charset="-122"/>
+                <a:cs typeface="Helvetica Neue" pitchFamily="34" charset="-120"/>
               </a:rPr>
               <a:t>Appendix: Tech 技術附錄</a:t>
             </a:r>
@@ -4362,9 +4387,9 @@
                 <a:solidFill>
                   <a:srgbClr val="64748B"/>
                 </a:solidFill>
-                <a:latin typeface="Arial" pitchFamily="34" charset="0"/>
-                <a:ea typeface="Arial" pitchFamily="34" charset="-122"/>
-                <a:cs typeface="Arial" pitchFamily="34" charset="-120"/>
+                <a:latin typeface="Helvetica Neue" pitchFamily="34" charset="0"/>
+                <a:ea typeface="Helvetica Neue" pitchFamily="34" charset="-122"/>
+                <a:cs typeface="Helvetica Neue" pitchFamily="34" charset="-120"/>
               </a:rPr>
               <a:t>Brief — grading focus stays on design</a:t>
             </a:r>
@@ -4405,9 +4430,9 @@
                 <a:solidFill>
                   <a:srgbClr val="0F172A"/>
                 </a:solidFill>
-                <a:latin typeface="Arial" pitchFamily="34" charset="0"/>
-                <a:ea typeface="Arial" pitchFamily="34" charset="-122"/>
-                <a:cs typeface="Arial" pitchFamily="34" charset="-120"/>
+                <a:latin typeface="Helvetica Neue" pitchFamily="34" charset="0"/>
+                <a:ea typeface="Helvetica Neue" pitchFamily="34" charset="-122"/>
+                <a:cs typeface="Helvetica Neue" pitchFamily="34" charset="-120"/>
               </a:rPr>
               <a:t>Stack: Next.js, Tailwind, Zustand; optional Gemini for copy / vision / order.</a:t>
             </a:r>
@@ -4426,9 +4451,9 @@
                 <a:solidFill>
                   <a:srgbClr val="0F172A"/>
                 </a:solidFill>
-                <a:latin typeface="Arial" pitchFamily="34" charset="0"/>
-                <a:ea typeface="Arial" pitchFamily="34" charset="-122"/>
-                <a:cs typeface="Arial" pitchFamily="34" charset="-120"/>
+                <a:latin typeface="Helvetica Neue" pitchFamily="34" charset="0"/>
+                <a:ea typeface="Helvetica Neue" pitchFamily="34" charset="-122"/>
+                <a:cs typeface="Helvetica Neue" pitchFamily="34" charset="-120"/>
               </a:rPr>
               <a:t>API: Google AI Studio https://aistudio.google.com/apikey</a:t>
             </a:r>
@@ -4447,9 +4472,9 @@
                 <a:solidFill>
                   <a:srgbClr val="0F172A"/>
                 </a:solidFill>
-                <a:latin typeface="Arial" pitchFamily="34" charset="0"/>
-                <a:ea typeface="Arial" pitchFamily="34" charset="-122"/>
-                <a:cs typeface="Arial" pitchFamily="34" charset="-120"/>
+                <a:latin typeface="Helvetica Neue" pitchFamily="34" charset="0"/>
+                <a:ea typeface="Helvetica Neue" pitchFamily="34" charset="-122"/>
+                <a:cs typeface="Helvetica Neue" pitchFamily="34" charset="-120"/>
               </a:rPr>
               <a:t>Docs: https://ai.google.dev/gemini-api/docs</a:t>
             </a:r>
@@ -4468,9 +4493,9 @@
                 <a:solidFill>
                   <a:srgbClr val="0F172A"/>
                 </a:solidFill>
-                <a:latin typeface="Arial" pitchFamily="34" charset="0"/>
-                <a:ea typeface="Arial" pitchFamily="34" charset="-122"/>
-                <a:cs typeface="Arial" pitchFamily="34" charset="-120"/>
+                <a:latin typeface="Helvetica Neue" pitchFamily="34" charset="0"/>
+                <a:ea typeface="Helvetica Neue" pitchFamily="34" charset="-122"/>
+                <a:cs typeface="Helvetica Neue" pitchFamily="34" charset="-120"/>
               </a:rPr>
               <a:t>Repo: github.com/macaumonsoon/Portfolio-ReStyle-AI</a:t>
             </a:r>

</xml_diff>

<commit_message>
chore(presentation): update group members (names/IDs)
Made-with: Cursor
</commit_message>
<xml_diff>
--- a/presentation/Portfolio-ReStyle-AI-Design-Deck.pptx
+++ b/presentation/Portfolio-ReStyle-AI-Design-Deck.pptx
@@ -1774,7 +1774,7 @@
                 <a:ea typeface="Helvetica Neue" pitchFamily="34" charset="-122"/>
                 <a:cs typeface="Helvetica Neue" pitchFamily="34" charset="-120"/>
               </a:rPr>
-              <a:t>劉佳群 (Liu Jiaqun) · MCxxxxxx</a:t>
+              <a:t>劉佳群 (Liu Jiaqun) · MC569293</a:t>
             </a:r>
             <a:endParaRPr lang="en-US" sz="1400" dirty="0"/>
           </a:p>
@@ -2406,16 +2406,40 @@
           </a:p>
         </p:txBody>
       </p:sp>
-      <p:sp>
-        <p:nvSpPr>
-          <p:cNvPr id="4" name="Text 2"/>
+      <p:pic>
+        <p:nvPicPr>
+          <p:cNvPr id="4" name="Image 0" descr="/Users/guoxiaoyue/.cursor/projects/Users-guoxiaoyue-Downloads-cursor-Portfolio-ReStyle-AI/assets/__2026-03-30_15.46.38-49fcc9cf-c541-460f-b822-e381967fc6bf.png">    </p:cNvPr>
+          <p:cNvPicPr>
+            <a:picLocks noChangeAspect="1"/>
+          </p:cNvPicPr>
+          <p:nvPr/>
+        </p:nvPicPr>
+        <p:blipFill>
+          <a:blip r:embed="rId1"/>
+          <a:stretch>
+            <a:fillRect/>
+          </a:stretch>
+        </p:blipFill>
+        <p:spPr>
+          <a:xfrm>
+            <a:off x="4892040" y="1645920"/>
+            <a:ext cx="3977640" cy="2468880"/>
+          </a:xfrm>
+          <a:prstGeom prst="rect">
+            <a:avLst/>
+          </a:prstGeom>
+        </p:spPr>
+      </p:pic>
+      <p:sp>
+        <p:nvSpPr>
+          <p:cNvPr id="5" name="Text 2"/>
           <p:cNvSpPr/>
           <p:nvPr/>
         </p:nvSpPr>
         <p:spPr>
           <a:xfrm>
             <a:off x="548640" y="1600200"/>
-            <a:ext cx="8046720" cy="3840480"/>
+            <a:ext cx="4297680" cy="3840480"/>
           </a:xfrm>
           <a:prstGeom prst="rect">
             <a:avLst/>
@@ -2715,7 +2739,7 @@
         <p:spPr>
           <a:xfrm>
             <a:off x="548640" y="1600200"/>
-            <a:ext cx="8046720" cy="4206240"/>
+            <a:ext cx="8046720" cy="3429000"/>
           </a:xfrm>
           <a:prstGeom prst="rect">
             <a:avLst/>
@@ -2729,13 +2753,13 @@
           <a:p>
             <a:pPr marL="342900" indent="-342900">
               <a:lnSpc>
-                <a:spcPct val="115000"/>
+                <a:spcPct val="108000"/>
               </a:lnSpc>
               <a:buSzPct val="100000"/>
               <a:buChar char="•"/>
             </a:pPr>
             <a:r>
-              <a:rPr lang="en-US" sz="1600" dirty="0">
+              <a:rPr lang="en-US" sz="1400" dirty="0">
                 <a:solidFill>
                   <a:srgbClr val="0F172A"/>
                 </a:solidFill>
@@ -2743,20 +2767,20 @@
                 <a:ea typeface="Helvetica Neue" pitchFamily="34" charset="-122"/>
                 <a:cs typeface="Helvetica Neue" pitchFamily="34" charset="-120"/>
               </a:rPr>
-              <a:t>Empathize: designers lose time to repetitive layout work (order, grid, spacing).</a:t>
-            </a:r>
-            <a:endParaRPr lang="en-US" sz="1600" dirty="0"/>
+              <a:t>Empathize 同理：repetitive layout work (order/grid/spacing) steals time → designer stays in control.</a:t>
+            </a:r>
+            <a:endParaRPr lang="en-US" sz="1400" dirty="0"/>
           </a:p>
           <a:p>
             <a:pPr marL="342900" indent="-342900">
               <a:lnSpc>
-                <a:spcPct val="115000"/>
+                <a:spcPct val="108000"/>
               </a:lnSpc>
               <a:buSzPct val="100000"/>
               <a:buChar char="•"/>
             </a:pPr>
             <a:r>
-              <a:rPr lang="en-US" sz="1500" dirty="0">
+              <a:rPr lang="en-US" sz="1400" dirty="0">
                 <a:solidFill>
                   <a:srgbClr val="0F172A"/>
                 </a:solidFill>
@@ -2764,20 +2788,20 @@
                 <a:ea typeface="Helvetica Neue" pitchFamily="34" charset="-122"/>
                 <a:cs typeface="Helvetica Neue" pitchFamily="34" charset="-120"/>
               </a:rPr>
-              <a:t>同理：設計師把時間花在重複排版（頁序、網格、字距）上。</a:t>
-            </a:r>
-            <a:endParaRPr lang="en-US" sz="1600" dirty="0"/>
+              <a:t>Define 定義：assist decisions, not replace authorship — keep authorship and taste.</a:t>
+            </a:r>
+            <a:endParaRPr lang="en-US" sz="1400" dirty="0"/>
           </a:p>
           <a:p>
             <a:pPr marL="342900" indent="-342900">
               <a:lnSpc>
-                <a:spcPct val="115000"/>
+                <a:spcPct val="108000"/>
               </a:lnSpc>
               <a:buSzPct val="100000"/>
               <a:buChar char="•"/>
             </a:pPr>
             <a:r>
-              <a:rPr lang="en-US" sz="1600" dirty="0">
+              <a:rPr lang="en-US" sz="1400" dirty="0">
                 <a:solidFill>
                   <a:srgbClr val="0F172A"/>
                 </a:solidFill>
@@ -2785,20 +2809,20 @@
                 <a:ea typeface="Helvetica Neue" pitchFamily="34" charset="-122"/>
                 <a:cs typeface="Helvetica Neue" pitchFamily="34" charset="-120"/>
               </a:rPr>
-              <a:t>Define: assist decisions, not replace authorship — keep designer in control.</a:t>
-            </a:r>
-            <a:endParaRPr lang="en-US" sz="1600" dirty="0"/>
+              <a:t>Ideate 發想：wizard + persistent dock + only 3 variants per page → faster comparison.</a:t>
+            </a:r>
+            <a:endParaRPr lang="en-US" sz="1400" dirty="0"/>
           </a:p>
           <a:p>
             <a:pPr marL="342900" indent="-342900">
               <a:lnSpc>
-                <a:spcPct val="115000"/>
+                <a:spcPct val="108000"/>
               </a:lnSpc>
               <a:buSzPct val="100000"/>
               <a:buChar char="•"/>
             </a:pPr>
             <a:r>
-              <a:rPr lang="en-US" sz="1500" dirty="0">
+              <a:rPr lang="en-US" sz="1400" dirty="0">
                 <a:solidFill>
                   <a:srgbClr val="0F172A"/>
                 </a:solidFill>
@@ -2806,20 +2830,20 @@
                 <a:ea typeface="Helvetica Neue" pitchFamily="34" charset="-122"/>
                 <a:cs typeface="Helvetica Neue" pitchFamily="34" charset="-120"/>
               </a:rPr>
-              <a:t>定義：協助決策而不是取代創作權 — 讓設計師保持控制。</a:t>
-            </a:r>
-            <a:endParaRPr lang="en-US" sz="1600" dirty="0"/>
+              <a:t>Prototype 原型：bilingual UI + grid remix + tile nudge + before/after compare for readability.</a:t>
+            </a:r>
+            <a:endParaRPr lang="en-US" sz="1400" dirty="0"/>
           </a:p>
           <a:p>
             <a:pPr marL="342900" indent="-342900">
               <a:lnSpc>
-                <a:spcPct val="115000"/>
+                <a:spcPct val="108000"/>
               </a:lnSpc>
               <a:buSzPct val="100000"/>
               <a:buChar char="•"/>
             </a:pPr>
             <a:r>
-              <a:rPr lang="en-US" sz="1600" dirty="0">
+              <a:rPr lang="en-US" sz="1400" dirty="0">
                 <a:solidFill>
                   <a:srgbClr val="0F172A"/>
                 </a:solidFill>
@@ -2827,114 +2851,9 @@
                 <a:ea typeface="Helvetica Neue" pitchFamily="34" charset="-122"/>
                 <a:cs typeface="Helvetica Neue" pitchFamily="34" charset="-120"/>
               </a:rPr>
-              <a:t>Ideate: wizard + persistent dock + only 3 variants per page for faster comparison.</a:t>
-            </a:r>
-            <a:endParaRPr lang="en-US" sz="1600" dirty="0"/>
-          </a:p>
-          <a:p>
-            <a:pPr marL="342900" indent="-342900">
-              <a:lnSpc>
-                <a:spcPct val="115000"/>
-              </a:lnSpc>
-              <a:buSzPct val="100000"/>
-              <a:buChar char="•"/>
-            </a:pPr>
-            <a:r>
-              <a:rPr lang="en-US" sz="1500" dirty="0">
-                <a:solidFill>
-                  <a:srgbClr val="0F172A"/>
-                </a:solidFill>
-                <a:latin typeface="Helvetica Neue" pitchFamily="34" charset="0"/>
-                <a:ea typeface="Helvetica Neue" pitchFamily="34" charset="-122"/>
-                <a:cs typeface="Helvetica Neue" pitchFamily="34" charset="-120"/>
-              </a:rPr>
-              <a:t>發想：精靈流程 + 持續側欄預覽 + 每頁僅 3 個版本，提升比對效率。</a:t>
-            </a:r>
-            <a:endParaRPr lang="en-US" sz="1600" dirty="0"/>
-          </a:p>
-          <a:p>
-            <a:pPr marL="342900" indent="-342900">
-              <a:lnSpc>
-                <a:spcPct val="115000"/>
-              </a:lnSpc>
-              <a:buSzPct val="100000"/>
-              <a:buChar char="•"/>
-            </a:pPr>
-            <a:r>
-              <a:rPr lang="en-US" sz="1600" dirty="0">
-                <a:solidFill>
-                  <a:srgbClr val="0F172A"/>
-                </a:solidFill>
-                <a:latin typeface="Helvetica Neue" pitchFamily="34" charset="0"/>
-                <a:ea typeface="Helvetica Neue" pitchFamily="34" charset="-122"/>
-                <a:cs typeface="Helvetica Neue" pitchFamily="34" charset="-120"/>
-              </a:rPr>
-              <a:t>Prototype: bilingual UI, grid remix, tile nudge, before/after compare — designed for readability.</a:t>
-            </a:r>
-            <a:endParaRPr lang="en-US" sz="1600" dirty="0"/>
-          </a:p>
-          <a:p>
-            <a:pPr marL="342900" indent="-342900">
-              <a:lnSpc>
-                <a:spcPct val="115000"/>
-              </a:lnSpc>
-              <a:buSzPct val="100000"/>
-              <a:buChar char="•"/>
-            </a:pPr>
-            <a:r>
-              <a:rPr lang="en-US" sz="1500" dirty="0">
-                <a:solidFill>
-                  <a:srgbClr val="0F172A"/>
-                </a:solidFill>
-                <a:latin typeface="Helvetica Neue" pitchFamily="34" charset="0"/>
-                <a:ea typeface="Helvetica Neue" pitchFamily="34" charset="-122"/>
-                <a:cs typeface="Helvetica Neue" pitchFamily="34" charset="-120"/>
-              </a:rPr>
-              <a:t>原型：雙語介面、網格重排、區塊微調、Before/After 對比 — 以可讀性為核心排版。</a:t>
-            </a:r>
-            <a:endParaRPr lang="en-US" sz="1600" dirty="0"/>
-          </a:p>
-          <a:p>
-            <a:pPr marL="342900" indent="-342900">
-              <a:lnSpc>
-                <a:spcPct val="115000"/>
-              </a:lnSpc>
-              <a:buSzPct val="100000"/>
-              <a:buChar char="•"/>
-            </a:pPr>
-            <a:r>
-              <a:rPr lang="en-US" sz="1600" dirty="0">
-                <a:solidFill>
-                  <a:srgbClr val="0F172A"/>
-                </a:solidFill>
-                <a:latin typeface="Helvetica Neue" pitchFamily="34" charset="0"/>
-                <a:ea typeface="Helvetica Neue" pitchFamily="34" charset="-122"/>
-                <a:cs typeface="Helvetica Neue" pitchFamily="34" charset="-120"/>
-              </a:rPr>
-              <a:t>Test: keep previews synchronized across steps and ensure typography hierarchy stays stable.</a:t>
-            </a:r>
-            <a:endParaRPr lang="en-US" sz="1600" dirty="0"/>
-          </a:p>
-          <a:p>
-            <a:pPr marL="342900" indent="-342900">
-              <a:lnSpc>
-                <a:spcPct val="115000"/>
-              </a:lnSpc>
-              <a:buSzPct val="100000"/>
-              <a:buChar char="•"/>
-            </a:pPr>
-            <a:r>
-              <a:rPr lang="en-US" sz="1500" dirty="0">
-                <a:solidFill>
-                  <a:srgbClr val="0F172A"/>
-                </a:solidFill>
-                <a:latin typeface="Helvetica Neue" pitchFamily="34" charset="0"/>
-                <a:ea typeface="Helvetica Neue" pitchFamily="34" charset="-122"/>
-                <a:cs typeface="Helvetica Neue" pitchFamily="34" charset="-120"/>
-              </a:rPr>
-              <a:t>測試：讓步驟間預覽同步、並確保字體層級在界面中保持穩定。</a:t>
-            </a:r>
-            <a:endParaRPr lang="en-US" sz="1600" dirty="0"/>
+              <a:t>Test 測試：synchronize previews across steps and keep typography hierarchy stable (e.g. 1×2 grids).</a:t>
+            </a:r>
+            <a:endParaRPr lang="en-US" sz="1400" dirty="0"/>
           </a:p>
         </p:txBody>
       </p:sp>
@@ -3902,16 +3821,40 @@
           </a:p>
         </p:txBody>
       </p:sp>
-      <p:sp>
-        <p:nvSpPr>
-          <p:cNvPr id="4" name="Text 2"/>
+      <p:pic>
+        <p:nvPicPr>
+          <p:cNvPr id="4" name="Image 0" descr="/Users/guoxiaoyue/.cursor/projects/Users-guoxiaoyue-Downloads-cursor-Portfolio-ReStyle-AI/assets/__2026-03-30_15.46.25-614732c6-5924-43fb-88f9-746a1dc6626e.png">    </p:cNvPr>
+          <p:cNvPicPr>
+            <a:picLocks noChangeAspect="1"/>
+          </p:cNvPicPr>
+          <p:nvPr/>
+        </p:nvPicPr>
+        <p:blipFill>
+          <a:blip r:embed="rId1"/>
+          <a:stretch>
+            <a:fillRect/>
+          </a:stretch>
+        </p:blipFill>
+        <p:spPr>
+          <a:xfrm>
+            <a:off x="4892040" y="1645920"/>
+            <a:ext cx="3977640" cy="2468880"/>
+          </a:xfrm>
+          <a:prstGeom prst="rect">
+            <a:avLst/>
+          </a:prstGeom>
+        </p:spPr>
+      </p:pic>
+      <p:sp>
+        <p:nvSpPr>
+          <p:cNvPr id="5" name="Text 2"/>
           <p:cNvSpPr/>
           <p:nvPr/>
         </p:nvSpPr>
         <p:spPr>
           <a:xfrm>
             <a:off x="548640" y="1600200"/>
-            <a:ext cx="8046720" cy="3291840"/>
+            <a:ext cx="4297680" cy="3291840"/>
           </a:xfrm>
           <a:prstGeom prst="rect">
             <a:avLst/>

</xml_diff>

<commit_message>
style: apple glass UI + UX-flow deck update
Made-with: Cursor
</commit_message>
<xml_diff>
--- a/presentation/Portfolio-ReStyle-AI-Design-Deck.pptx
+++ b/presentation/Portfolio-ReStyle-AI-Design-Deck.pptx
@@ -14,9 +14,12 @@
     <p:sldId id="262" r:id="rId8"/>
     <p:sldId id="263" r:id="rId9"/>
     <p:sldId id="264" r:id="rId10"/>
+    <p:sldId id="265" r:id="rId11"/>
+    <p:sldId id="266" r:id="rId12"/>
+    <p:sldId id="267" r:id="rId13"/>
   </p:sldIdLst>
   <p:notesMasterIdLst>
-    <p:notesMasterId r:id="rId11"/>
+    <p:notesMasterId r:id="rId14"/>
   </p:notesMasterIdLst>
   <p:sldSz cx="9144000" cy="5143500"/>
   <p:notesSz cx="5143500" cy="9144000"/>
@@ -534,6 +537,270 @@
             <a:fld id="{F7021451-1387-4CA6-816F-3879F97B5CBC}" type="slidenum">
               <a:rPr lang="en-US"/>
               <a:t>1</a:t>
+            </a:fld>
+            <a:endParaRPr lang="en-US"/>
+          </a:p>
+        </p:txBody>
+      </p:sp>
+    </p:spTree>
+    <p:extLst>
+      <p:ext uri="{BB962C8B-B14F-4D97-AF65-F5344CB8AC3E}">
+        <p14:creationId xmlns:p14="http://schemas.microsoft.com/office/powerpoint/2010/main" val="1024086991"/>
+      </p:ext>
+    </p:extLst>
+  </p:cSld>
+  <p:clrMapOvr>
+    <a:masterClrMapping/>
+  </p:clrMapOvr>
+</p:notes>
+</file>
+
+<file path=ppt/notesSlides/notesSlide10.xml><?xml version="1.0" encoding="utf-8"?>
+<p:notes xmlns:a="http://schemas.openxmlformats.org/drawingml/2006/main" xmlns:r="http://schemas.openxmlformats.org/officeDocument/2006/relationships" xmlns:p="http://schemas.openxmlformats.org/presentationml/2006/main">
+  <p:cSld>
+    <p:spTree>
+      <p:nvGrpSpPr>
+        <p:cNvPr id="1" name=""/>
+        <p:cNvGrpSpPr/>
+        <p:nvPr/>
+      </p:nvGrpSpPr>
+      <p:grpSpPr>
+        <a:xfrm>
+          <a:off x="0" y="0"/>
+          <a:ext cx="0" cy="0"/>
+          <a:chOff x="0" y="0"/>
+          <a:chExt cx="0" cy="0"/>
+        </a:xfrm>
+      </p:grpSpPr>
+      <p:sp>
+        <p:nvSpPr>
+          <p:cNvPr id="2" name="Slide Image Placeholder 1"/>
+          <p:cNvSpPr>
+            <a:spLocks noGrp="1" noRot="1" noChangeAspect="1"/>
+          </p:cNvSpPr>
+          <p:nvPr>
+            <p:ph type="sldImg"/>
+          </p:nvPr>
+        </p:nvSpPr>
+        <p:spPr/>
+      </p:sp>
+      <p:sp>
+        <p:nvSpPr>
+          <p:cNvPr id="3" name="Notes Placeholder 2"/>
+          <p:cNvSpPr>
+            <a:spLocks noGrp="1"/>
+          </p:cNvSpPr>
+          <p:nvPr>
+            <p:ph type="body" idx="1"/>
+          </p:nvPr>
+        </p:nvSpPr>
+        <p:spPr/>
+        <p:txBody>
+          <a:bodyPr/>
+          <a:lstStyle/>
+          <a:p>
+            <a:r>
+              <a:rPr lang="en-US" dirty="0"/>
+              <a:t/>
+            </a:r>
+            <a:endParaRPr lang="en-US" dirty="0"/>
+          </a:p>
+        </p:txBody>
+      </p:sp>
+      <p:sp>
+        <p:nvSpPr>
+          <p:cNvPr id="4" name="Slide Number Placeholder 3"/>
+          <p:cNvSpPr>
+            <a:spLocks noGrp="1"/>
+          </p:cNvSpPr>
+          <p:nvPr>
+            <p:ph type="sldNum" sz="quarter" idx="10"/>
+          </p:nvPr>
+        </p:nvSpPr>
+        <p:spPr/>
+        <p:txBody>
+          <a:bodyPr/>
+          <a:lstStyle/>
+          <a:p>
+            <a:fld id="{F7021451-1387-4CA6-816F-3879F97B5CBC}" type="slidenum">
+              <a:rPr lang="en-US"/>
+              <a:t>10</a:t>
+            </a:fld>
+            <a:endParaRPr lang="en-US"/>
+          </a:p>
+        </p:txBody>
+      </p:sp>
+    </p:spTree>
+    <p:extLst>
+      <p:ext uri="{BB962C8B-B14F-4D97-AF65-F5344CB8AC3E}">
+        <p14:creationId xmlns:p14="http://schemas.microsoft.com/office/powerpoint/2010/main" val="1024086991"/>
+      </p:ext>
+    </p:extLst>
+  </p:cSld>
+  <p:clrMapOvr>
+    <a:masterClrMapping/>
+  </p:clrMapOvr>
+</p:notes>
+</file>
+
+<file path=ppt/notesSlides/notesSlide11.xml><?xml version="1.0" encoding="utf-8"?>
+<p:notes xmlns:a="http://schemas.openxmlformats.org/drawingml/2006/main" xmlns:r="http://schemas.openxmlformats.org/officeDocument/2006/relationships" xmlns:p="http://schemas.openxmlformats.org/presentationml/2006/main">
+  <p:cSld>
+    <p:spTree>
+      <p:nvGrpSpPr>
+        <p:cNvPr id="1" name=""/>
+        <p:cNvGrpSpPr/>
+        <p:nvPr/>
+      </p:nvGrpSpPr>
+      <p:grpSpPr>
+        <a:xfrm>
+          <a:off x="0" y="0"/>
+          <a:ext cx="0" cy="0"/>
+          <a:chOff x="0" y="0"/>
+          <a:chExt cx="0" cy="0"/>
+        </a:xfrm>
+      </p:grpSpPr>
+      <p:sp>
+        <p:nvSpPr>
+          <p:cNvPr id="2" name="Slide Image Placeholder 1"/>
+          <p:cNvSpPr>
+            <a:spLocks noGrp="1" noRot="1" noChangeAspect="1"/>
+          </p:cNvSpPr>
+          <p:nvPr>
+            <p:ph type="sldImg"/>
+          </p:nvPr>
+        </p:nvSpPr>
+        <p:spPr/>
+      </p:sp>
+      <p:sp>
+        <p:nvSpPr>
+          <p:cNvPr id="3" name="Notes Placeholder 2"/>
+          <p:cNvSpPr>
+            <a:spLocks noGrp="1"/>
+          </p:cNvSpPr>
+          <p:nvPr>
+            <p:ph type="body" idx="1"/>
+          </p:nvPr>
+        </p:nvSpPr>
+        <p:spPr/>
+        <p:txBody>
+          <a:bodyPr/>
+          <a:lstStyle/>
+          <a:p>
+            <a:r>
+              <a:rPr lang="en-US" dirty="0"/>
+              <a:t/>
+            </a:r>
+            <a:endParaRPr lang="en-US" dirty="0"/>
+          </a:p>
+        </p:txBody>
+      </p:sp>
+      <p:sp>
+        <p:nvSpPr>
+          <p:cNvPr id="4" name="Slide Number Placeholder 3"/>
+          <p:cNvSpPr>
+            <a:spLocks noGrp="1"/>
+          </p:cNvSpPr>
+          <p:nvPr>
+            <p:ph type="sldNum" sz="quarter" idx="10"/>
+          </p:nvPr>
+        </p:nvSpPr>
+        <p:spPr/>
+        <p:txBody>
+          <a:bodyPr/>
+          <a:lstStyle/>
+          <a:p>
+            <a:fld id="{F7021451-1387-4CA6-816F-3879F97B5CBC}" type="slidenum">
+              <a:rPr lang="en-US"/>
+              <a:t>11</a:t>
+            </a:fld>
+            <a:endParaRPr lang="en-US"/>
+          </a:p>
+        </p:txBody>
+      </p:sp>
+    </p:spTree>
+    <p:extLst>
+      <p:ext uri="{BB962C8B-B14F-4D97-AF65-F5344CB8AC3E}">
+        <p14:creationId xmlns:p14="http://schemas.microsoft.com/office/powerpoint/2010/main" val="1024086991"/>
+      </p:ext>
+    </p:extLst>
+  </p:cSld>
+  <p:clrMapOvr>
+    <a:masterClrMapping/>
+  </p:clrMapOvr>
+</p:notes>
+</file>
+
+<file path=ppt/notesSlides/notesSlide12.xml><?xml version="1.0" encoding="utf-8"?>
+<p:notes xmlns:a="http://schemas.openxmlformats.org/drawingml/2006/main" xmlns:r="http://schemas.openxmlformats.org/officeDocument/2006/relationships" xmlns:p="http://schemas.openxmlformats.org/presentationml/2006/main">
+  <p:cSld>
+    <p:spTree>
+      <p:nvGrpSpPr>
+        <p:cNvPr id="1" name=""/>
+        <p:cNvGrpSpPr/>
+        <p:nvPr/>
+      </p:nvGrpSpPr>
+      <p:grpSpPr>
+        <a:xfrm>
+          <a:off x="0" y="0"/>
+          <a:ext cx="0" cy="0"/>
+          <a:chOff x="0" y="0"/>
+          <a:chExt cx="0" cy="0"/>
+        </a:xfrm>
+      </p:grpSpPr>
+      <p:sp>
+        <p:nvSpPr>
+          <p:cNvPr id="2" name="Slide Image Placeholder 1"/>
+          <p:cNvSpPr>
+            <a:spLocks noGrp="1" noRot="1" noChangeAspect="1"/>
+          </p:cNvSpPr>
+          <p:nvPr>
+            <p:ph type="sldImg"/>
+          </p:nvPr>
+        </p:nvSpPr>
+        <p:spPr/>
+      </p:sp>
+      <p:sp>
+        <p:nvSpPr>
+          <p:cNvPr id="3" name="Notes Placeholder 2"/>
+          <p:cNvSpPr>
+            <a:spLocks noGrp="1"/>
+          </p:cNvSpPr>
+          <p:nvPr>
+            <p:ph type="body" idx="1"/>
+          </p:nvPr>
+        </p:nvSpPr>
+        <p:spPr/>
+        <p:txBody>
+          <a:bodyPr/>
+          <a:lstStyle/>
+          <a:p>
+            <a:r>
+              <a:rPr lang="en-US" dirty="0"/>
+              <a:t/>
+            </a:r>
+            <a:endParaRPr lang="en-US" dirty="0"/>
+          </a:p>
+        </p:txBody>
+      </p:sp>
+      <p:sp>
+        <p:nvSpPr>
+          <p:cNvPr id="4" name="Slide Number Placeholder 3"/>
+          <p:cNvSpPr>
+            <a:spLocks noGrp="1"/>
+          </p:cNvSpPr>
+          <p:nvPr>
+            <p:ph type="sldNum" sz="quarter" idx="10"/>
+          </p:nvPr>
+        </p:nvSpPr>
+        <p:spPr/>
+        <p:txBody>
+          <a:bodyPr/>
+          <a:lstStyle/>
+          <a:p>
+            <a:fld id="{F7021451-1387-4CA6-816F-3879F97B5CBC}" type="slidenum">
+              <a:rPr lang="en-US"/>
+              <a:t>12</a:t>
             </a:fld>
             <a:endParaRPr lang="en-US"/>
           </a:p>
@@ -1788,6 +2055,735 @@
 </p:sld>
 </file>
 
+<file path=ppt/slides/slide10.xml><?xml version="1.0" encoding="utf-8"?>
+<p:sld xmlns:a="http://schemas.openxmlformats.org/drawingml/2006/main" xmlns:r="http://schemas.openxmlformats.org/officeDocument/2006/relationships" xmlns:p="http://schemas.openxmlformats.org/presentationml/2006/main">
+  <p:cSld name="Slide 10">
+    <p:bg>
+      <p:bgPr>
+        <a:solidFill>
+          <a:srgbClr val="F8FAFC"/>
+        </a:solidFill>
+      </p:bgPr>
+    </p:bg>
+    <p:spTree>
+      <p:nvGrpSpPr>
+        <p:cNvPr id="1" name=""/>
+        <p:cNvGrpSpPr/>
+        <p:nvPr/>
+      </p:nvGrpSpPr>
+      <p:grpSpPr>
+        <a:xfrm>
+          <a:off x="0" y="0"/>
+          <a:ext cx="0" cy="0"/>
+          <a:chOff x="0" y="0"/>
+          <a:chExt cx="0" cy="0"/>
+        </a:xfrm>
+      </p:grpSpPr>
+      <p:sp>
+        <p:nvSpPr>
+          <p:cNvPr id="2" name="Text 0"/>
+          <p:cNvSpPr/>
+          <p:nvPr/>
+        </p:nvSpPr>
+        <p:spPr>
+          <a:xfrm>
+            <a:off x="548640" y="411480"/>
+            <a:ext cx="8046720" cy="777240"/>
+          </a:xfrm>
+          <a:prstGeom prst="rect">
+            <a:avLst/>
+          </a:prstGeom>
+          <a:noFill/>
+          <a:ln/>
+        </p:spPr>
+        <p:txBody>
+          <a:bodyPr wrap="square" rtlCol="0" anchor="ctr"/>
+          <a:lstStyle/>
+          <a:p>
+            <a:pPr indent="0" marL="0">
+              <a:buNone/>
+            </a:pPr>
+            <a:r>
+              <a:rPr lang="en-US" sz="2800" b="1" dirty="0">
+                <a:solidFill>
+                  <a:srgbClr val="4F46E5"/>
+                </a:solidFill>
+                <a:latin typeface="Helvetica Neue" pitchFamily="34" charset="0"/>
+                <a:ea typeface="Helvetica Neue" pitchFamily="34" charset="-122"/>
+                <a:cs typeface="Helvetica Neue" pitchFamily="34" charset="-120"/>
+              </a:rPr>
+              <a:t>Demo script 演示腳本</a:t>
+            </a:r>
+            <a:endParaRPr lang="en-US" sz="2800" dirty="0"/>
+          </a:p>
+        </p:txBody>
+      </p:sp>
+      <p:sp>
+        <p:nvSpPr>
+          <p:cNvPr id="3" name="Text 1"/>
+          <p:cNvSpPr/>
+          <p:nvPr/>
+        </p:nvSpPr>
+        <p:spPr>
+          <a:xfrm>
+            <a:off x="548640" y="1051560"/>
+            <a:ext cx="8046720" cy="365760"/>
+          </a:xfrm>
+          <a:prstGeom prst="rect">
+            <a:avLst/>
+          </a:prstGeom>
+          <a:noFill/>
+          <a:ln/>
+        </p:spPr>
+        <p:txBody>
+          <a:bodyPr wrap="square" rtlCol="0" anchor="ctr"/>
+          <a:lstStyle/>
+          <a:p>
+            <a:pPr indent="0" marL="0">
+              <a:buNone/>
+            </a:pPr>
+            <a:r>
+              <a:rPr lang="en-US" sz="1300" dirty="0">
+                <a:solidFill>
+                  <a:srgbClr val="64748B"/>
+                </a:solidFill>
+                <a:latin typeface="Helvetica Neue" pitchFamily="34" charset="0"/>
+                <a:ea typeface="Helvetica Neue" pitchFamily="34" charset="-122"/>
+                <a:cs typeface="Helvetica Neue" pitchFamily="34" charset="-120"/>
+              </a:rPr>
+              <a:t>For your screen recording / video</a:t>
+            </a:r>
+            <a:endParaRPr lang="en-US" sz="1300" dirty="0"/>
+          </a:p>
+        </p:txBody>
+      </p:sp>
+      <p:pic>
+        <p:nvPicPr>
+          <p:cNvPr id="4" name="Image 0" descr="/Users/guoxiaoyue/.cursor/projects/Users-guoxiaoyue-Downloads-cursor-Portfolio-ReStyle-AI/assets/__2026-03-30_15.38.54-735dd999-a21b-4719-af36-9994ea7d2a6c.png">    </p:cNvPr>
+          <p:cNvPicPr>
+            <a:picLocks noChangeAspect="1"/>
+          </p:cNvPicPr>
+          <p:nvPr/>
+        </p:nvPicPr>
+        <p:blipFill>
+          <a:blip r:embed="rId1"/>
+          <a:srcRect l="0" r="0" t="0" b="0"/>
+          <a:stretch/>
+        </p:blipFill>
+        <p:spPr>
+          <a:xfrm>
+            <a:off x="4800600" y="1508760"/>
+            <a:ext cx="4297680" cy="2423160"/>
+          </a:xfrm>
+          <a:prstGeom prst="rect">
+            <a:avLst/>
+          </a:prstGeom>
+        </p:spPr>
+      </p:pic>
+      <p:sp>
+        <p:nvSpPr>
+          <p:cNvPr id="5" name="Text 2"/>
+          <p:cNvSpPr/>
+          <p:nvPr/>
+        </p:nvSpPr>
+        <p:spPr>
+          <a:xfrm>
+            <a:off x="502920" y="1508760"/>
+            <a:ext cx="4251960" cy="4206240"/>
+          </a:xfrm>
+          <a:prstGeom prst="rect">
+            <a:avLst/>
+          </a:prstGeom>
+          <a:noFill/>
+          <a:ln/>
+        </p:spPr>
+        <p:txBody>
+          <a:bodyPr wrap="square" rtlCol="0" anchor="ctr"/>
+          <a:lstStyle/>
+          <a:p>
+            <a:pPr indent="0" marL="0">
+              <a:lnSpc>
+                <a:spcPct val="108000"/>
+              </a:lnSpc>
+              <a:buNone/>
+            </a:pPr>
+            <a:r>
+              <a:rPr lang="en-US" sz="1400" dirty="0">
+                <a:solidFill>
+                  <a:srgbClr val="0F172A"/>
+                </a:solidFill>
+                <a:latin typeface="Helvetica Neue" pitchFamily="34" charset="0"/>
+                <a:ea typeface="Helvetica Neue" pitchFamily="34" charset="-122"/>
+                <a:cs typeface="Helvetica Neue" pitchFamily="34" charset="-120"/>
+              </a:rPr>
+              <a:t>1. Show language toggle（中文 ↔ English）。</a:t>
+            </a:r>
+            <a:endParaRPr lang="en-US" sz="1400" dirty="0"/>
+          </a:p>
+          <a:p>
+            <a:pPr indent="0" marL="0">
+              <a:lnSpc>
+                <a:spcPct val="108000"/>
+              </a:lnSpc>
+              <a:buNone/>
+            </a:pPr>
+            <a:r>
+              <a:rPr lang="en-US" sz="1400" dirty="0">
+                <a:solidFill>
+                  <a:srgbClr val="0F172A"/>
+                </a:solidFill>
+                <a:latin typeface="Helvetica Neue" pitchFamily="34" charset="0"/>
+                <a:ea typeface="Helvetica Neue" pitchFamily="34" charset="-122"/>
+                <a:cs typeface="Helvetica Neue" pitchFamily="34" charset="-120"/>
+              </a:rPr>
+              <a:t>2. Upload SVG/PDF：在 Options dock 改色系/风格/网格并观察层级变化。</a:t>
+            </a:r>
+            <a:endParaRPr lang="en-US" sz="1400" dirty="0"/>
+          </a:p>
+          <a:p>
+            <a:pPr indent="0" marL="0">
+              <a:lnSpc>
+                <a:spcPct val="108000"/>
+              </a:lnSpc>
+              <a:buNone/>
+            </a:pPr>
+            <a:r>
+              <a:rPr lang="en-US" sz="1400" dirty="0">
+                <a:solidFill>
+                  <a:srgbClr val="0F172A"/>
+                </a:solidFill>
+                <a:latin typeface="Helvetica Neue" pitchFamily="34" charset="0"/>
+                <a:ea typeface="Helvetica Neue" pitchFamily="34" charset="-122"/>
+                <a:cs typeface="Helvetica Neue" pitchFamily="34" charset="-120"/>
+              </a:rPr>
+              <a:t>3. Use Before/After：分开看色相滤镜 vs 版式位移。</a:t>
+            </a:r>
+            <a:endParaRPr lang="en-US" sz="1400" dirty="0"/>
+          </a:p>
+          <a:p>
+            <a:pPr indent="0" marL="0">
+              <a:lnSpc>
+                <a:spcPct val="108000"/>
+              </a:lnSpc>
+              <a:buNone/>
+            </a:pPr>
+            <a:r>
+              <a:rPr lang="en-US" sz="1400" dirty="0">
+                <a:solidFill>
+                  <a:srgbClr val="0F172A"/>
+                </a:solidFill>
+                <a:latin typeface="Helvetica Neue" pitchFamily="34" charset="0"/>
+                <a:ea typeface="Helvetica Neue" pitchFamily="34" charset="-122"/>
+                <a:cs typeface="Helvetica Neue" pitchFamily="34" charset="-120"/>
+              </a:rPr>
+              <a:t>4. Select one variant per page（含 1×2 / 2×1 非对称预设）。</a:t>
+            </a:r>
+            <a:endParaRPr lang="en-US" sz="1400" dirty="0"/>
+          </a:p>
+          <a:p>
+            <a:pPr indent="0" marL="0">
+              <a:lnSpc>
+                <a:spcPct val="108000"/>
+              </a:lnSpc>
+              <a:buNone/>
+            </a:pPr>
+            <a:r>
+              <a:rPr lang="en-US" sz="1400" dirty="0">
+                <a:solidFill>
+                  <a:srgbClr val="0F172A"/>
+                </a:solidFill>
+                <a:latin typeface="Helvetica Neue" pitchFamily="34" charset="0"/>
+                <a:ea typeface="Helvetica Neue" pitchFamily="34" charset="-122"/>
+                <a:cs typeface="Helvetica Neue" pitchFamily="34" charset="-120"/>
+              </a:rPr>
+              <a:t>5. Export：合并 PDF + 每页 SVG（方便继续排版与微调）。</a:t>
+            </a:r>
+            <a:endParaRPr lang="en-US" sz="1400" dirty="0"/>
+          </a:p>
+        </p:txBody>
+      </p:sp>
+    </p:spTree>
+  </p:cSld>
+  <p:clrMapOvr>
+    <a:masterClrMapping/>
+  </p:clrMapOvr>
+</p:sld>
+</file>
+
+<file path=ppt/slides/slide11.xml><?xml version="1.0" encoding="utf-8"?>
+<p:sld xmlns:a="http://schemas.openxmlformats.org/drawingml/2006/main" xmlns:r="http://schemas.openxmlformats.org/officeDocument/2006/relationships" xmlns:p="http://schemas.openxmlformats.org/presentationml/2006/main">
+  <p:cSld name="Slide 11">
+    <p:bg>
+      <p:bgPr>
+        <a:solidFill>
+          <a:srgbClr val="F8FAFC"/>
+        </a:solidFill>
+      </p:bgPr>
+    </p:bg>
+    <p:spTree>
+      <p:nvGrpSpPr>
+        <p:cNvPr id="1" name=""/>
+        <p:cNvGrpSpPr/>
+        <p:nvPr/>
+      </p:nvGrpSpPr>
+      <p:grpSpPr>
+        <a:xfrm>
+          <a:off x="0" y="0"/>
+          <a:ext cx="0" cy="0"/>
+          <a:chOff x="0" y="0"/>
+          <a:chExt cx="0" cy="0"/>
+        </a:xfrm>
+      </p:grpSpPr>
+      <p:sp>
+        <p:nvSpPr>
+          <p:cNvPr id="2" name="Text 0"/>
+          <p:cNvSpPr/>
+          <p:nvPr/>
+        </p:nvSpPr>
+        <p:spPr>
+          <a:xfrm>
+            <a:off x="548640" y="411480"/>
+            <a:ext cx="8046720" cy="777240"/>
+          </a:xfrm>
+          <a:prstGeom prst="rect">
+            <a:avLst/>
+          </a:prstGeom>
+          <a:noFill/>
+          <a:ln/>
+        </p:spPr>
+        <p:txBody>
+          <a:bodyPr wrap="square" rtlCol="0" anchor="ctr"/>
+          <a:lstStyle/>
+          <a:p>
+            <a:pPr indent="0" marL="0">
+              <a:buNone/>
+            </a:pPr>
+            <a:r>
+              <a:rPr lang="en-US" sz="2800" b="1" dirty="0">
+                <a:solidFill>
+                  <a:srgbClr val="4F46E5"/>
+                </a:solidFill>
+                <a:latin typeface="Helvetica Neue" pitchFamily="34" charset="0"/>
+                <a:ea typeface="Helvetica Neue" pitchFamily="34" charset="-122"/>
+                <a:cs typeface="Helvetica Neue" pitchFamily="34" charset="-120"/>
+              </a:rPr>
+              <a:t>Reflection 反思</a:t>
+            </a:r>
+            <a:endParaRPr lang="en-US" sz="2800" dirty="0"/>
+          </a:p>
+        </p:txBody>
+      </p:sp>
+      <p:sp>
+        <p:nvSpPr>
+          <p:cNvPr id="3" name="Text 1"/>
+          <p:cNvSpPr/>
+          <p:nvPr/>
+        </p:nvSpPr>
+        <p:spPr>
+          <a:xfrm>
+            <a:off x="548640" y="1051560"/>
+            <a:ext cx="8046720" cy="365760"/>
+          </a:xfrm>
+          <a:prstGeom prst="rect">
+            <a:avLst/>
+          </a:prstGeom>
+          <a:noFill/>
+          <a:ln/>
+        </p:spPr>
+        <p:txBody>
+          <a:bodyPr wrap="square" rtlCol="0" anchor="ctr"/>
+          <a:lstStyle/>
+          <a:p>
+            <a:pPr indent="0" marL="0">
+              <a:buNone/>
+            </a:pPr>
+            <a:r>
+              <a:rPr lang="en-US" sz="1300" dirty="0">
+                <a:solidFill>
+                  <a:srgbClr val="64748B"/>
+                </a:solidFill>
+                <a:latin typeface="Helvetica Neue" pitchFamily="34" charset="0"/>
+                <a:ea typeface="Helvetica Neue" pitchFamily="34" charset="-122"/>
+                <a:cs typeface="Helvetica Neue" pitchFamily="34" charset="-120"/>
+              </a:rPr>
+              <a:t>Design focus · Next steps</a:t>
+            </a:r>
+            <a:endParaRPr lang="en-US" sz="1300" dirty="0"/>
+          </a:p>
+        </p:txBody>
+      </p:sp>
+      <p:sp>
+        <p:nvSpPr>
+          <p:cNvPr id="4" name="Text 2"/>
+          <p:cNvSpPr/>
+          <p:nvPr/>
+        </p:nvSpPr>
+        <p:spPr>
+          <a:xfrm>
+            <a:off x="548640" y="1600200"/>
+            <a:ext cx="8046720" cy="3474720"/>
+          </a:xfrm>
+          <a:prstGeom prst="rect">
+            <a:avLst/>
+          </a:prstGeom>
+          <a:noFill/>
+          <a:ln/>
+        </p:spPr>
+        <p:txBody>
+          <a:bodyPr wrap="square" rtlCol="0" anchor="ctr"/>
+          <a:lstStyle/>
+          <a:p>
+            <a:pPr marL="342900" indent="-342900">
+              <a:lnSpc>
+                <a:spcPct val="115000"/>
+              </a:lnSpc>
+              <a:buSzPct val="100000"/>
+              <a:buChar char="•"/>
+            </a:pPr>
+            <a:r>
+              <a:rPr lang="en-US" sz="1600" dirty="0">
+                <a:solidFill>
+                  <a:srgbClr val="0F172A"/>
+                </a:solidFill>
+                <a:latin typeface="Helvetica Neue" pitchFamily="34" charset="0"/>
+                <a:ea typeface="Helvetica Neue" pitchFamily="34" charset="-122"/>
+                <a:cs typeface="Helvetica Neue" pitchFamily="34" charset="-120"/>
+              </a:rPr>
+              <a:t>What worked: clear type hierarchy + stable dock preview for confident decisions.</a:t>
+            </a:r>
+            <a:endParaRPr lang="en-US" sz="1600" dirty="0"/>
+          </a:p>
+          <a:p>
+            <a:pPr marL="342900" indent="-342900">
+              <a:lnSpc>
+                <a:spcPct val="115000"/>
+              </a:lnSpc>
+              <a:buSzPct val="100000"/>
+              <a:buChar char="•"/>
+            </a:pPr>
+            <a:r>
+              <a:rPr lang="en-US" sz="1500" dirty="0">
+                <a:solidFill>
+                  <a:srgbClr val="0F172A"/>
+                </a:solidFill>
+                <a:latin typeface="Helvetica Neue" pitchFamily="34" charset="0"/>
+                <a:ea typeface="Helvetica Neue" pitchFamily="34" charset="-122"/>
+                <a:cs typeface="Helvetica Neue" pitchFamily="34" charset="-120"/>
+              </a:rPr>
+              <a:t>有效之處：清晰字體層級 + 穩定 dock 預覽，讓決策更有把握。</a:t>
+            </a:r>
+            <a:endParaRPr lang="en-US" sz="1600" dirty="0"/>
+          </a:p>
+          <a:p>
+            <a:pPr marL="342900" indent="-342900">
+              <a:lnSpc>
+                <a:spcPct val="115000"/>
+              </a:lnSpc>
+              <a:buSzPct val="100000"/>
+              <a:buChar char="•"/>
+            </a:pPr>
+            <a:r>
+              <a:rPr lang="en-US" sz="1600" dirty="0">
+                <a:solidFill>
+                  <a:srgbClr val="0F172A"/>
+                </a:solidFill>
+                <a:latin typeface="Helvetica Neue" pitchFamily="34" charset="0"/>
+                <a:ea typeface="Helvetica Neue" pitchFamily="34" charset="-122"/>
+                <a:cs typeface="Helvetica Neue" pitchFamily="34" charset="-120"/>
+              </a:rPr>
+              <a:t>What to improve: finer typography controls and more layout-ready components.</a:t>
+            </a:r>
+            <a:endParaRPr lang="en-US" sz="1600" dirty="0"/>
+          </a:p>
+          <a:p>
+            <a:pPr marL="342900" indent="-342900">
+              <a:lnSpc>
+                <a:spcPct val="115000"/>
+              </a:lnSpc>
+              <a:buSzPct val="100000"/>
+              <a:buChar char="•"/>
+            </a:pPr>
+            <a:r>
+              <a:rPr lang="en-US" sz="1500" dirty="0">
+                <a:solidFill>
+                  <a:srgbClr val="0F172A"/>
+                </a:solidFill>
+                <a:latin typeface="Helvetica Neue" pitchFamily="34" charset="0"/>
+                <a:ea typeface="Helvetica Neue" pitchFamily="34" charset="-122"/>
+                <a:cs typeface="Helvetica Neue" pitchFamily="34" charset="-120"/>
+              </a:rPr>
+              <a:t>接續改進：更細字體控制與更多可直接用的版面元件。</a:t>
+            </a:r>
+            <a:endParaRPr lang="en-US" sz="1600" dirty="0"/>
+          </a:p>
+          <a:p>
+            <a:pPr marL="342900" indent="-342900">
+              <a:lnSpc>
+                <a:spcPct val="115000"/>
+              </a:lnSpc>
+              <a:buSzPct val="100000"/>
+              <a:buChar char="•"/>
+            </a:pPr>
+            <a:r>
+              <a:rPr lang="en-US" sz="1600" dirty="0">
+                <a:solidFill>
+                  <a:srgbClr val="0F172A"/>
+                </a:solidFill>
+                <a:latin typeface="Helvetica Neue" pitchFamily="34" charset="0"/>
+                <a:ea typeface="Helvetica Neue" pitchFamily="34" charset="-122"/>
+                <a:cs typeface="Helvetica Neue" pitchFamily="34" charset="-120"/>
+              </a:rPr>
+              <a:t>Ethics: API keys only in .env.local; no training on user uploads in this prototype.</a:t>
+            </a:r>
+            <a:endParaRPr lang="en-US" sz="1600" dirty="0"/>
+          </a:p>
+          <a:p>
+            <a:pPr marL="342900" indent="-342900">
+              <a:lnSpc>
+                <a:spcPct val="115000"/>
+              </a:lnSpc>
+              <a:buSzPct val="100000"/>
+              <a:buChar char="•"/>
+            </a:pPr>
+            <a:r>
+              <a:rPr lang="en-US" sz="1500" dirty="0">
+                <a:solidFill>
+                  <a:srgbClr val="0F172A"/>
+                </a:solidFill>
+                <a:latin typeface="Helvetica Neue" pitchFamily="34" charset="0"/>
+                <a:ea typeface="Helvetica Neue" pitchFamily="34" charset="-122"/>
+                <a:cs typeface="Helvetica Neue" pitchFamily="34" charset="-120"/>
+              </a:rPr>
+              <a:t>倫理：API 金鑰只在本機；此原型不對用戶上傳做訓練。</a:t>
+            </a:r>
+            <a:endParaRPr lang="en-US" sz="1600" dirty="0"/>
+          </a:p>
+        </p:txBody>
+      </p:sp>
+    </p:spTree>
+  </p:cSld>
+  <p:clrMapOvr>
+    <a:masterClrMapping/>
+  </p:clrMapOvr>
+</p:sld>
+</file>
+
+<file path=ppt/slides/slide12.xml><?xml version="1.0" encoding="utf-8"?>
+<p:sld xmlns:a="http://schemas.openxmlformats.org/drawingml/2006/main" xmlns:r="http://schemas.openxmlformats.org/officeDocument/2006/relationships" xmlns:p="http://schemas.openxmlformats.org/presentationml/2006/main">
+  <p:cSld name="Slide 12">
+    <p:bg>
+      <p:bgPr>
+        <a:solidFill>
+          <a:srgbClr val="F8FAFC"/>
+        </a:solidFill>
+      </p:bgPr>
+    </p:bg>
+    <p:spTree>
+      <p:nvGrpSpPr>
+        <p:cNvPr id="1" name=""/>
+        <p:cNvGrpSpPr/>
+        <p:nvPr/>
+      </p:nvGrpSpPr>
+      <p:grpSpPr>
+        <a:xfrm>
+          <a:off x="0" y="0"/>
+          <a:ext cx="0" cy="0"/>
+          <a:chOff x="0" y="0"/>
+          <a:chExt cx="0" cy="0"/>
+        </a:xfrm>
+      </p:grpSpPr>
+      <p:sp>
+        <p:nvSpPr>
+          <p:cNvPr id="2" name="Text 0"/>
+          <p:cNvSpPr/>
+          <p:nvPr/>
+        </p:nvSpPr>
+        <p:spPr>
+          <a:xfrm>
+            <a:off x="548640" y="411480"/>
+            <a:ext cx="8046720" cy="777240"/>
+          </a:xfrm>
+          <a:prstGeom prst="rect">
+            <a:avLst/>
+          </a:prstGeom>
+          <a:noFill/>
+          <a:ln/>
+        </p:spPr>
+        <p:txBody>
+          <a:bodyPr wrap="square" rtlCol="0" anchor="ctr"/>
+          <a:lstStyle/>
+          <a:p>
+            <a:pPr indent="0" marL="0">
+              <a:buNone/>
+            </a:pPr>
+            <a:r>
+              <a:rPr lang="en-US" sz="2800" b="1" dirty="0">
+                <a:solidFill>
+                  <a:srgbClr val="4F46E5"/>
+                </a:solidFill>
+                <a:latin typeface="Helvetica Neue" pitchFamily="34" charset="0"/>
+                <a:ea typeface="Helvetica Neue" pitchFamily="34" charset="-122"/>
+                <a:cs typeface="Helvetica Neue" pitchFamily="34" charset="-120"/>
+              </a:rPr>
+              <a:t>Appendix: Tech 技術附錄</a:t>
+            </a:r>
+            <a:endParaRPr lang="en-US" sz="2800" dirty="0"/>
+          </a:p>
+        </p:txBody>
+      </p:sp>
+      <p:sp>
+        <p:nvSpPr>
+          <p:cNvPr id="3" name="Text 1"/>
+          <p:cNvSpPr/>
+          <p:nvPr/>
+        </p:nvSpPr>
+        <p:spPr>
+          <a:xfrm>
+            <a:off x="548640" y="1051560"/>
+            <a:ext cx="8046720" cy="365760"/>
+          </a:xfrm>
+          <a:prstGeom prst="rect">
+            <a:avLst/>
+          </a:prstGeom>
+          <a:noFill/>
+          <a:ln/>
+        </p:spPr>
+        <p:txBody>
+          <a:bodyPr wrap="square" rtlCol="0" anchor="ctr"/>
+          <a:lstStyle/>
+          <a:p>
+            <a:pPr indent="0" marL="0">
+              <a:buNone/>
+            </a:pPr>
+            <a:r>
+              <a:rPr lang="en-US" sz="1300" dirty="0">
+                <a:solidFill>
+                  <a:srgbClr val="64748B"/>
+                </a:solidFill>
+                <a:latin typeface="Helvetica Neue" pitchFamily="34" charset="0"/>
+                <a:ea typeface="Helvetica Neue" pitchFamily="34" charset="-122"/>
+                <a:cs typeface="Helvetica Neue" pitchFamily="34" charset="-120"/>
+              </a:rPr>
+              <a:t>Brief — grading focus stays on design</a:t>
+            </a:r>
+            <a:endParaRPr lang="en-US" sz="1300" dirty="0"/>
+          </a:p>
+        </p:txBody>
+      </p:sp>
+      <p:sp>
+        <p:nvSpPr>
+          <p:cNvPr id="4" name="Text 2"/>
+          <p:cNvSpPr/>
+          <p:nvPr/>
+        </p:nvSpPr>
+        <p:spPr>
+          <a:xfrm>
+            <a:off x="548640" y="1600200"/>
+            <a:ext cx="8046720" cy="2926080"/>
+          </a:xfrm>
+          <a:prstGeom prst="rect">
+            <a:avLst/>
+          </a:prstGeom>
+          <a:noFill/>
+          <a:ln/>
+        </p:spPr>
+        <p:txBody>
+          <a:bodyPr wrap="square" rtlCol="0" anchor="ctr"/>
+          <a:lstStyle/>
+          <a:p>
+            <a:pPr marL="342900" indent="-342900">
+              <a:lnSpc>
+                <a:spcPct val="115000"/>
+              </a:lnSpc>
+              <a:buSzPct val="100000"/>
+              <a:buChar char="•"/>
+            </a:pPr>
+            <a:r>
+              <a:rPr lang="en-US" sz="1600" dirty="0">
+                <a:solidFill>
+                  <a:srgbClr val="0F172A"/>
+                </a:solidFill>
+                <a:latin typeface="Helvetica Neue" pitchFamily="34" charset="0"/>
+                <a:ea typeface="Helvetica Neue" pitchFamily="34" charset="-122"/>
+                <a:cs typeface="Helvetica Neue" pitchFamily="34" charset="-120"/>
+              </a:rPr>
+              <a:t>Stack: Next.js, Tailwind, Zustand; optional Gemini for copy / vision / order.</a:t>
+            </a:r>
+            <a:endParaRPr lang="en-US" sz="1600" dirty="0"/>
+          </a:p>
+          <a:p>
+            <a:pPr marL="342900" indent="-342900">
+              <a:lnSpc>
+                <a:spcPct val="115000"/>
+              </a:lnSpc>
+              <a:buSzPct val="100000"/>
+              <a:buChar char="•"/>
+            </a:pPr>
+            <a:r>
+              <a:rPr lang="en-US" sz="1600" dirty="0">
+                <a:solidFill>
+                  <a:srgbClr val="0F172A"/>
+                </a:solidFill>
+                <a:latin typeface="Helvetica Neue" pitchFamily="34" charset="0"/>
+                <a:ea typeface="Helvetica Neue" pitchFamily="34" charset="-122"/>
+                <a:cs typeface="Helvetica Neue" pitchFamily="34" charset="-120"/>
+              </a:rPr>
+              <a:t>API: Google AI Studio https://aistudio.google.com/apikey</a:t>
+            </a:r>
+            <a:endParaRPr lang="en-US" sz="1600" dirty="0"/>
+          </a:p>
+          <a:p>
+            <a:pPr marL="342900" indent="-342900">
+              <a:lnSpc>
+                <a:spcPct val="115000"/>
+              </a:lnSpc>
+              <a:buSzPct val="100000"/>
+              <a:buChar char="•"/>
+            </a:pPr>
+            <a:r>
+              <a:rPr lang="en-US" sz="1600" dirty="0">
+                <a:solidFill>
+                  <a:srgbClr val="0F172A"/>
+                </a:solidFill>
+                <a:latin typeface="Helvetica Neue" pitchFamily="34" charset="0"/>
+                <a:ea typeface="Helvetica Neue" pitchFamily="34" charset="-122"/>
+                <a:cs typeface="Helvetica Neue" pitchFamily="34" charset="-120"/>
+              </a:rPr>
+              <a:t>Docs: https://ai.google.dev/gemini-api/docs</a:t>
+            </a:r>
+            <a:endParaRPr lang="en-US" sz="1600" dirty="0"/>
+          </a:p>
+          <a:p>
+            <a:pPr marL="342900" indent="-342900">
+              <a:lnSpc>
+                <a:spcPct val="115000"/>
+              </a:lnSpc>
+              <a:buSzPct val="100000"/>
+              <a:buChar char="•"/>
+            </a:pPr>
+            <a:r>
+              <a:rPr lang="en-US" sz="1600" dirty="0">
+                <a:solidFill>
+                  <a:srgbClr val="0F172A"/>
+                </a:solidFill>
+                <a:latin typeface="Helvetica Neue" pitchFamily="34" charset="0"/>
+                <a:ea typeface="Helvetica Neue" pitchFamily="34" charset="-122"/>
+                <a:cs typeface="Helvetica Neue" pitchFamily="34" charset="-120"/>
+              </a:rPr>
+              <a:t>Repo: github.com/macaumonsoon/Portfolio-ReStyle-AI</a:t>
+            </a:r>
+            <a:endParaRPr lang="en-US" sz="1600" dirty="0"/>
+          </a:p>
+        </p:txBody>
+      </p:sp>
+    </p:spTree>
+  </p:cSld>
+  <p:clrMapOvr>
+    <a:masterClrMapping/>
+  </p:clrMapOvr>
+</p:sld>
+</file>
+
 <file path=ppt/slides/slide2.xml><?xml version="1.0" encoding="utf-8"?>
 <p:sld xmlns:a="http://schemas.openxmlformats.org/drawingml/2006/main" xmlns:r="http://schemas.openxmlformats.org/officeDocument/2006/relationships" xmlns:p="http://schemas.openxmlformats.org/presentationml/2006/main">
   <p:cSld name="Slide 2">
@@ -2361,7 +3357,7 @@
                 <a:ea typeface="Helvetica Neue" pitchFamily="34" charset="-122"/>
                 <a:cs typeface="Helvetica Neue" pitchFamily="34" charset="-120"/>
               </a:rPr>
-              <a:t>In visual communication 在視傳流程中</a:t>
+              <a:t>UX Flow 1 上傳導入</a:t>
             </a:r>
             <a:endParaRPr lang="en-US" sz="2800" dirty="0"/>
           </a:p>
@@ -2400,7 +3396,7 @@
                 <a:ea typeface="Helvetica Neue" pitchFamily="34" charset="-122"/>
                 <a:cs typeface="Helvetica Neue" pitchFamily="34" charset="-120"/>
               </a:rPr>
-              <a:t>How designers can use this tool</a:t>
+              <a:t>Upload / PDF import</a:t>
             </a:r>
             <a:endParaRPr lang="en-US" sz="1300" dirty="0"/>
           </a:p>
@@ -2408,7 +3404,7 @@
       </p:sp>
       <p:pic>
         <p:nvPicPr>
-          <p:cNvPr id="4" name="Image 0" descr="/Users/guoxiaoyue/.cursor/projects/Users-guoxiaoyue-Downloads-cursor-Portfolio-ReStyle-AI/assets/__2026-03-30_15.46.38-49fcc9cf-c541-460f-b822-e381967fc6bf.png">    </p:cNvPr>
+          <p:cNvPr id="4" name="Image 0" descr="/Users/guoxiaoyue/.cursor/projects/Users-guoxiaoyue-Downloads-cursor-Portfolio-ReStyle-AI/assets/__2026-03-30_15.15.55-596f6acd-3360-49c6-8675-49394d0372f5.png">    </p:cNvPr>
           <p:cNvPicPr>
             <a:picLocks noChangeAspect="1"/>
           </p:cNvPicPr>
@@ -2416,14 +3412,13 @@
         </p:nvPicPr>
         <p:blipFill>
           <a:blip r:embed="rId1"/>
-          <a:stretch>
-            <a:fillRect/>
-          </a:stretch>
+          <a:srcRect l="0" r="0" t="0" b="0"/>
+          <a:stretch/>
         </p:blipFill>
         <p:spPr>
           <a:xfrm>
-            <a:off x="4892040" y="1645920"/>
-            <a:ext cx="3977640" cy="2468880"/>
+            <a:off x="4800600" y="1508760"/>
+            <a:ext cx="4297680" cy="4663440"/>
           </a:xfrm>
           <a:prstGeom prst="rect">
             <a:avLst/>
@@ -2438,8 +3433,8 @@
         </p:nvSpPr>
         <p:spPr>
           <a:xfrm>
-            <a:off x="548640" y="1600200"/>
-            <a:ext cx="4297680" cy="3840480"/>
+            <a:off x="502920" y="1554480"/>
+            <a:ext cx="4251960" cy="4754880"/>
           </a:xfrm>
           <a:prstGeom prst="rect">
             <a:avLst/>
@@ -2451,15 +3446,14 @@
           <a:bodyPr wrap="square" rtlCol="0" anchor="ctr"/>
           <a:lstStyle/>
           <a:p>
-            <a:pPr marL="342900" indent="-342900">
+            <a:pPr indent="0" marL="0">
               <a:lnSpc>
-                <a:spcPct val="115000"/>
+                <a:spcPct val="107000"/>
               </a:lnSpc>
-              <a:buSzPct val="100000"/>
-              <a:buChar char="•"/>
-            </a:pPr>
-            <a:r>
-              <a:rPr lang="en-US" sz="1600" dirty="0">
+              <a:buNone/>
+            </a:pPr>
+            <a:r>
+              <a:rPr lang="en-US" sz="1600" b="1" dirty="0">
                 <a:solidFill>
                   <a:srgbClr val="0F172A"/>
                 </a:solidFill>
@@ -2467,20 +3461,16 @@
                 <a:ea typeface="Helvetica Neue" pitchFamily="34" charset="-122"/>
                 <a:cs typeface="Helvetica Neue" pitchFamily="34" charset="-120"/>
               </a:rPr>
-              <a:t>Direction exploration: color + style with immediate preview feedback.</a:t>
-            </a:r>
-            <a:endParaRPr lang="en-US" sz="1600" dirty="0"/>
-          </a:p>
-          <a:p>
-            <a:pPr marL="342900" indent="-342900">
+              <a:t>Upload 上傳</a:t>
+            </a:r>
+            <a:pPr indent="0" marL="0">
               <a:lnSpc>
-                <a:spcPct val="115000"/>
+                <a:spcPct val="107000"/>
               </a:lnSpc>
-              <a:buSzPct val="100000"/>
-              <a:buChar char="•"/>
-            </a:pPr>
-            <a:r>
-              <a:rPr lang="en-US" sz="1500" dirty="0">
+              <a:buNone/>
+            </a:pPr>
+            <a:r>
+              <a:rPr lang="en-US" sz="1400" dirty="0">
                 <a:solidFill>
                   <a:srgbClr val="0F172A"/>
                 </a:solidFill>
@@ -2488,20 +3478,16 @@
                 <a:ea typeface="Helvetica Neue" pitchFamily="34" charset="-122"/>
                 <a:cs typeface="Helvetica Neue" pitchFamily="34" charset="-120"/>
               </a:rPr>
-              <a:t>方向探索：色彩與風格搭配，即時預覽回饋。</a:t>
-            </a:r>
-            <a:endParaRPr lang="en-US" sz="1600" dirty="0"/>
-          </a:p>
-          <a:p>
-            <a:pPr marL="342900" indent="-342900">
+              <a:t>• SVG：直接導入並分頁</a:t>
+            </a:r>
+            <a:pPr indent="0" marL="0">
               <a:lnSpc>
-                <a:spcPct val="115000"/>
+                <a:spcPct val="107000"/>
               </a:lnSpc>
-              <a:buSzPct val="100000"/>
-              <a:buChar char="•"/>
-            </a:pPr>
-            <a:r>
-              <a:rPr lang="en-US" sz="1600" dirty="0">
+              <a:buNone/>
+            </a:pPr>
+            <a:r>
+              <a:rPr lang="en-US" sz="1400" dirty="0">
                 <a:solidFill>
                   <a:srgbClr val="0F172A"/>
                 </a:solidFill>
@@ -2509,20 +3495,16 @@
                 <a:ea typeface="Helvetica Neue" pitchFamily="34" charset="-122"/>
                 <a:cs typeface="Helvetica Neue" pitchFamily="34" charset="-120"/>
               </a:rPr>
-              <a:t>Layout sketching: grid remix + optional tile nudge.</a:t>
-            </a:r>
-            <a:endParaRPr lang="en-US" sz="1600" dirty="0"/>
-          </a:p>
-          <a:p>
-            <a:pPr marL="342900" indent="-342900">
+              <a:t>• PDF：pdf.js 逐頁渲染，抽取文字座標（可在 Pages 編輯文字）</a:t>
+            </a:r>
+            <a:pPr indent="0" marL="0">
               <a:lnSpc>
-                <a:spcPct val="115000"/>
+                <a:spcPct val="107000"/>
               </a:lnSpc>
-              <a:buSzPct val="100000"/>
-              <a:buChar char="•"/>
-            </a:pPr>
-            <a:r>
-              <a:rPr lang="en-US" sz="1500" dirty="0">
+              <a:buNone/>
+            </a:pPr>
+            <a:r>
+              <a:rPr lang="en-US" sz="1400" dirty="0">
                 <a:solidFill>
                   <a:srgbClr val="0F172A"/>
                 </a:solidFill>
@@ -2530,91 +3512,7 @@
                 <a:ea typeface="Helvetica Neue" pitchFamily="34" charset="-122"/>
                 <a:cs typeface="Helvetica Neue" pitchFamily="34" charset="-120"/>
               </a:rPr>
-              <a:t>版面草圖：網格重排與區塊微調。</a:t>
-            </a:r>
-            <a:endParaRPr lang="en-US" sz="1600" dirty="0"/>
-          </a:p>
-          <a:p>
-            <a:pPr marL="342900" indent="-342900">
-              <a:lnSpc>
-                <a:spcPct val="115000"/>
-              </a:lnSpc>
-              <a:buSzPct val="100000"/>
-              <a:buChar char="•"/>
-            </a:pPr>
-            <a:r>
-              <a:rPr lang="en-US" sz="1600" dirty="0">
-                <a:solidFill>
-                  <a:srgbClr val="0F172A"/>
-                </a:solidFill>
-                <a:latin typeface="Helvetica Neue" pitchFamily="34" charset="0"/>
-                <a:ea typeface="Helvetica Neue" pitchFamily="34" charset="-122"/>
-                <a:cs typeface="Helvetica Neue" pitchFamily="34" charset="-120"/>
-              </a:rPr>
-              <a:t>Presentation packaging: reorder pages, unified look for different audiences.</a:t>
-            </a:r>
-            <a:endParaRPr lang="en-US" sz="1600" dirty="0"/>
-          </a:p>
-          <a:p>
-            <a:pPr marL="342900" indent="-342900">
-              <a:lnSpc>
-                <a:spcPct val="115000"/>
-              </a:lnSpc>
-              <a:buSzPct val="100000"/>
-              <a:buChar char="•"/>
-            </a:pPr>
-            <a:r>
-              <a:rPr lang="en-US" sz="1500" dirty="0">
-                <a:solidFill>
-                  <a:srgbClr val="0F172A"/>
-                </a:solidFill>
-                <a:latin typeface="Helvetica Neue" pitchFamily="34" charset="0"/>
-                <a:ea typeface="Helvetica Neue" pitchFamily="34" charset="-122"/>
-                <a:cs typeface="Helvetica Neue" pitchFamily="34" charset="-120"/>
-              </a:rPr>
-              <a:t>展示包裝：調整頁序與整體視覺，面向不同觀眾。</a:t>
-            </a:r>
-            <a:endParaRPr lang="en-US" sz="1600" dirty="0"/>
-          </a:p>
-          <a:p>
-            <a:pPr marL="342900" indent="-342900">
-              <a:lnSpc>
-                <a:spcPct val="115000"/>
-              </a:lnSpc>
-              <a:buSzPct val="100000"/>
-              <a:buChar char="•"/>
-            </a:pPr>
-            <a:r>
-              <a:rPr lang="en-US" sz="1600" dirty="0">
-                <a:solidFill>
-                  <a:srgbClr val="0F172A"/>
-                </a:solidFill>
-                <a:latin typeface="Helvetica Neue" pitchFamily="34" charset="0"/>
-                <a:ea typeface="Helvetica Neue" pitchFamily="34" charset="-122"/>
-                <a:cs typeface="Helvetica Neue" pitchFamily="34" charset="-120"/>
-              </a:rPr>
-              <a:t>Workflow: Upload → set intent (palette/style/canvas/narrative/grid) → review per page → choose variant → export SVG/PDF.</a:t>
-            </a:r>
-            <a:endParaRPr lang="en-US" sz="1600" dirty="0"/>
-          </a:p>
-          <a:p>
-            <a:pPr marL="342900" indent="-342900">
-              <a:lnSpc>
-                <a:spcPct val="115000"/>
-              </a:lnSpc>
-              <a:buSzPct val="100000"/>
-              <a:buChar char="•"/>
-            </a:pPr>
-            <a:r>
-              <a:rPr lang="en-US" sz="1500" dirty="0">
-                <a:solidFill>
-                  <a:srgbClr val="0F172A"/>
-                </a:solidFill>
-                <a:latin typeface="Helvetica Neue" pitchFamily="34" charset="0"/>
-                <a:ea typeface="Helvetica Neue" pitchFamily="34" charset="-122"/>
-                <a:cs typeface="Helvetica Neue" pitchFamily="34" charset="-120"/>
-              </a:rPr>
-              <a:t>流程：上傳 → 設定意圖（色系/風格/畫布/敘事/網格）→ 逐頁審閱 → 選擇版本 → 匯出 SVG/PDF。</a:t>
+              <a:t>目標：把作品轉成可重排、可選擇的結構。</a:t>
             </a:r>
             <a:endParaRPr lang="en-US" sz="1600" dirty="0"/>
           </a:p>
@@ -2685,7 +3583,7 @@
                 <a:ea typeface="Helvetica Neue" pitchFamily="34" charset="-122"/>
                 <a:cs typeface="Helvetica Neue" pitchFamily="34" charset="-120"/>
               </a:rPr>
-              <a:t>Design thinking 設計思維</a:t>
+              <a:t>UX Flow 2 選項 Options</a:t>
             </a:r>
             <a:endParaRPr lang="en-US" sz="2800" dirty="0"/>
           </a:p>
@@ -2724,22 +3622,45 @@
                 <a:ea typeface="Helvetica Neue" pitchFamily="34" charset="-122"/>
                 <a:cs typeface="Helvetica Neue" pitchFamily="34" charset="-120"/>
               </a:rPr>
-              <a:t>From layout pain → clear workflow</a:t>
+              <a:t>Palette / Style / Canvas / Narrative / Grid</a:t>
             </a:r>
             <a:endParaRPr lang="en-US" sz="1300" dirty="0"/>
           </a:p>
         </p:txBody>
       </p:sp>
-      <p:sp>
-        <p:nvSpPr>
-          <p:cNvPr id="4" name="Text 2"/>
+      <p:pic>
+        <p:nvPicPr>
+          <p:cNvPr id="4" name="Image 0" descr="/Users/guoxiaoyue/.cursor/projects/Users-guoxiaoyue-Downloads-cursor-Portfolio-ReStyle-AI/assets/__2026-03-30_15.46.38-49fcc9cf-c541-460f-b822-e381967fc6bf.png">    </p:cNvPr>
+          <p:cNvPicPr>
+            <a:picLocks noChangeAspect="1"/>
+          </p:cNvPicPr>
+          <p:nvPr/>
+        </p:nvPicPr>
+        <p:blipFill>
+          <a:blip r:embed="rId1"/>
+          <a:srcRect l="0" r="0" t="0" b="0"/>
+          <a:stretch/>
+        </p:blipFill>
+        <p:spPr>
+          <a:xfrm>
+            <a:off x="4800600" y="1508760"/>
+            <a:ext cx="4297680" cy="4663440"/>
+          </a:xfrm>
+          <a:prstGeom prst="rect">
+            <a:avLst/>
+          </a:prstGeom>
+        </p:spPr>
+      </p:pic>
+      <p:sp>
+        <p:nvSpPr>
+          <p:cNvPr id="5" name="Text 2"/>
           <p:cNvSpPr/>
           <p:nvPr/>
         </p:nvSpPr>
         <p:spPr>
           <a:xfrm>
-            <a:off x="548640" y="1600200"/>
-            <a:ext cx="8046720" cy="3429000"/>
+            <a:off x="502920" y="1554480"/>
+            <a:ext cx="4251960" cy="4754880"/>
           </a:xfrm>
           <a:prstGeom prst="rect">
             <a:avLst/>
@@ -2751,12 +3672,28 @@
           <a:bodyPr wrap="square" rtlCol="0" anchor="ctr"/>
           <a:lstStyle/>
           <a:p>
-            <a:pPr marL="342900" indent="-342900">
+            <a:pPr indent="0" marL="0">
               <a:lnSpc>
-                <a:spcPct val="108000"/>
+                <a:spcPct val="107000"/>
               </a:lnSpc>
-              <a:buSzPct val="100000"/>
-              <a:buChar char="•"/>
+              <a:buNone/>
+            </a:pPr>
+            <a:r>
+              <a:rPr lang="en-US" sz="1600" b="1" dirty="0">
+                <a:solidFill>
+                  <a:srgbClr val="0F172A"/>
+                </a:solidFill>
+                <a:latin typeface="Helvetica Neue" pitchFamily="34" charset="0"/>
+                <a:ea typeface="Helvetica Neue" pitchFamily="34" charset="-122"/>
+                <a:cs typeface="Helvetica Neue" pitchFamily="34" charset="-120"/>
+              </a:rPr>
+              <a:t>Options 選項</a:t>
+            </a:r>
+            <a:pPr indent="0" marL="0">
+              <a:lnSpc>
+                <a:spcPct val="107000"/>
+              </a:lnSpc>
+              <a:buNone/>
             </a:pPr>
             <a:r>
               <a:rPr lang="en-US" sz="1400" dirty="0">
@@ -2767,17 +3704,13 @@
                 <a:ea typeface="Helvetica Neue" pitchFamily="34" charset="-122"/>
                 <a:cs typeface="Helvetica Neue" pitchFamily="34" charset="-120"/>
               </a:rPr>
-              <a:t>Empathize 同理：repetitive layout work (order/grid/spacing) steals time → designer stays in control.</a:t>
-            </a:r>
-            <a:endParaRPr lang="en-US" sz="1400" dirty="0"/>
-          </a:p>
-          <a:p>
-            <a:pPr marL="342900" indent="-342900">
+              <a:t>• 色系 + 風格關鍵詞：即時濾鏡/字色方向</a:t>
+            </a:r>
+            <a:pPr indent="0" marL="0">
               <a:lnSpc>
-                <a:spcPct val="108000"/>
+                <a:spcPct val="107000"/>
               </a:lnSpc>
-              <a:buSzPct val="100000"/>
-              <a:buChar char="•"/>
+              <a:buNone/>
             </a:pPr>
             <a:r>
               <a:rPr lang="en-US" sz="1400" dirty="0">
@@ -2788,17 +3721,13 @@
                 <a:ea typeface="Helvetica Neue" pitchFamily="34" charset="-122"/>
                 <a:cs typeface="Helvetica Neue" pitchFamily="34" charset="-120"/>
               </a:rPr>
-              <a:t>Define 定義：assist decisions, not replace authorship — keep authorship and taste.</a:t>
-            </a:r>
-            <a:endParaRPr lang="en-US" sz="1400" dirty="0"/>
-          </a:p>
-          <a:p>
-            <a:pPr marL="342900" indent="-342900">
+              <a:t>• 畫布尺寸 + 敘事邏輯：影響版面比例與頁序</a:t>
+            </a:r>
+            <a:pPr indent="0" marL="0">
               <a:lnSpc>
-                <a:spcPct val="108000"/>
+                <a:spcPct val="107000"/>
               </a:lnSpc>
-              <a:buSzPct val="100000"/>
-              <a:buChar char="•"/>
+              <a:buNone/>
             </a:pPr>
             <a:r>
               <a:rPr lang="en-US" sz="1400" dirty="0">
@@ -2809,17 +3738,13 @@
                 <a:ea typeface="Helvetica Neue" pitchFamily="34" charset="-122"/>
                 <a:cs typeface="Helvetica Neue" pitchFamily="34" charset="-120"/>
               </a:rPr>
-              <a:t>Ideate 發想：wizard + persistent dock + only 3 variants per page → faster comparison.</a:t>
-            </a:r>
-            <a:endParaRPr lang="en-US" sz="1400" dirty="0"/>
-          </a:p>
-          <a:p>
-            <a:pPr marL="342900" indent="-342900">
+              <a:t>• 可選網格重排 + 網格塊微調：拖曳寫入讓構圖可控</a:t>
+            </a:r>
+            <a:pPr indent="0" marL="0">
               <a:lnSpc>
-                <a:spcPct val="108000"/>
+                <a:spcPct val="107000"/>
               </a:lnSpc>
-              <a:buSzPct val="100000"/>
-              <a:buChar char="•"/>
+              <a:buNone/>
             </a:pPr>
             <a:r>
               <a:rPr lang="en-US" sz="1400" dirty="0">
@@ -2830,30 +3755,9 @@
                 <a:ea typeface="Helvetica Neue" pitchFamily="34" charset="-122"/>
                 <a:cs typeface="Helvetica Neue" pitchFamily="34" charset="-120"/>
               </a:rPr>
-              <a:t>Prototype 原型：bilingual UI + grid remix + tile nudge + before/after compare for readability.</a:t>
-            </a:r>
-            <a:endParaRPr lang="en-US" sz="1400" dirty="0"/>
-          </a:p>
-          <a:p>
-            <a:pPr marL="342900" indent="-342900">
-              <a:lnSpc>
-                <a:spcPct val="108000"/>
-              </a:lnSpc>
-              <a:buSzPct val="100000"/>
-              <a:buChar char="•"/>
-            </a:pPr>
-            <a:r>
-              <a:rPr lang="en-US" sz="1400" dirty="0">
-                <a:solidFill>
-                  <a:srgbClr val="0F172A"/>
-                </a:solidFill>
-                <a:latin typeface="Helvetica Neue" pitchFamily="34" charset="0"/>
-                <a:ea typeface="Helvetica Neue" pitchFamily="34" charset="-122"/>
-                <a:cs typeface="Helvetica Neue" pitchFamily="34" charset="-120"/>
-              </a:rPr>
-              <a:t>Test 測試：synchronize previews across steps and keep typography hierarchy stable (e.g. 1×2 grids).</a:t>
-            </a:r>
-            <a:endParaRPr lang="en-US" sz="1400" dirty="0"/>
+              <a:t>目標：讓設計方向可視化、可比較、可迭代。</a:t>
+            </a:r>
+            <a:endParaRPr lang="en-US" sz="1600" dirty="0"/>
           </a:p>
         </p:txBody>
       </p:sp>
@@ -2922,7 +3826,7 @@
                 <a:ea typeface="Helvetica Neue" pitchFamily="34" charset="-122"/>
                 <a:cs typeface="Helvetica Neue" pitchFamily="34" charset="-120"/>
               </a:rPr>
-              <a:t>Design system principles 版面設計原則</a:t>
+              <a:t>UX Flow 3 頁面 Pages ×3</a:t>
             </a:r>
             <a:endParaRPr lang="en-US" sz="2800" dirty="0"/>
           </a:p>
@@ -2961,6 +3865,729 @@
                 <a:ea typeface="Helvetica Neue" pitchFamily="34" charset="-122"/>
                 <a:cs typeface="Helvetica Neue" pitchFamily="34" charset="-120"/>
               </a:rPr>
+              <a:t>Choose a variant per page</a:t>
+            </a:r>
+            <a:endParaRPr lang="en-US" sz="1300" dirty="0"/>
+          </a:p>
+        </p:txBody>
+      </p:sp>
+      <p:pic>
+        <p:nvPicPr>
+          <p:cNvPr id="4" name="Image 0" descr="/Users/guoxiaoyue/.cursor/projects/Users-guoxiaoyue-Downloads-cursor-Portfolio-ReStyle-AI/assets/__2026-03-30_15.15.55-596f6acd-3360-49c6-8675-49394d0372f5.png">    </p:cNvPr>
+          <p:cNvPicPr>
+            <a:picLocks noChangeAspect="1"/>
+          </p:cNvPicPr>
+          <p:nvPr/>
+        </p:nvPicPr>
+        <p:blipFill>
+          <a:blip r:embed="rId1"/>
+          <a:srcRect l="0" r="0" t="0" b="0"/>
+          <a:stretch/>
+        </p:blipFill>
+        <p:spPr>
+          <a:xfrm>
+            <a:off x="4800600" y="1508760"/>
+            <a:ext cx="4297680" cy="4663440"/>
+          </a:xfrm>
+          <a:prstGeom prst="rect">
+            <a:avLst/>
+          </a:prstGeom>
+        </p:spPr>
+      </p:pic>
+      <p:sp>
+        <p:nvSpPr>
+          <p:cNvPr id="5" name="Text 2"/>
+          <p:cNvSpPr/>
+          <p:nvPr/>
+        </p:nvSpPr>
+        <p:spPr>
+          <a:xfrm>
+            <a:off x="502920" y="1554480"/>
+            <a:ext cx="4251960" cy="4754880"/>
+          </a:xfrm>
+          <a:prstGeom prst="rect">
+            <a:avLst/>
+          </a:prstGeom>
+          <a:noFill/>
+          <a:ln/>
+        </p:spPr>
+        <p:txBody>
+          <a:bodyPr wrap="square" rtlCol="0" anchor="ctr"/>
+          <a:lstStyle/>
+          <a:p>
+            <a:pPr indent="0" marL="0">
+              <a:lnSpc>
+                <a:spcPct val="107000"/>
+              </a:lnSpc>
+              <a:buNone/>
+            </a:pPr>
+            <a:r>
+              <a:rPr lang="en-US" sz="1600" b="1" dirty="0">
+                <a:solidFill>
+                  <a:srgbClr val="0F172A"/>
+                </a:solidFill>
+                <a:latin typeface="Helvetica Neue" pitchFamily="34" charset="0"/>
+                <a:ea typeface="Helvetica Neue" pitchFamily="34" charset="-122"/>
+                <a:cs typeface="Helvetica Neue" pitchFamily="34" charset="-120"/>
+              </a:rPr>
+              <a:t>Pages 頁面×3</a:t>
+            </a:r>
+            <a:pPr indent="0" marL="0">
+              <a:lnSpc>
+                <a:spcPct val="107000"/>
+              </a:lnSpc>
+              <a:buNone/>
+            </a:pPr>
+            <a:r>
+              <a:rPr lang="en-US" sz="1400" dirty="0">
+                <a:solidFill>
+                  <a:srgbClr val="0F172A"/>
+                </a:solidFill>
+                <a:latin typeface="Helvetica Neue" pitchFamily="34" charset="0"/>
+                <a:ea typeface="Helvetica Neue" pitchFamily="34" charset="-122"/>
+                <a:cs typeface="Helvetica Neue" pitchFamily="34" charset="-120"/>
+              </a:rPr>
+              <a:t>• 每頁 3 個版本：先快速比對，再鎖定喜歡的構圖</a:t>
+            </a:r>
+            <a:pPr indent="0" marL="0">
+              <a:lnSpc>
+                <a:spcPct val="107000"/>
+              </a:lnSpc>
+              <a:buNone/>
+            </a:pPr>
+            <a:r>
+              <a:rPr lang="en-US" sz="1400" dirty="0">
+                <a:solidFill>
+                  <a:srgbClr val="0F172A"/>
+                </a:solidFill>
+                <a:latin typeface="Helvetica Neue" pitchFamily="34" charset="0"/>
+                <a:ea typeface="Helvetica Neue" pitchFamily="34" charset="-122"/>
+                <a:cs typeface="Helvetica Neue" pitchFamily="34" charset="-120"/>
+              </a:rPr>
+              <a:t>• Before/After：分開看色相（顏色）與位移（版式/構圖）</a:t>
+            </a:r>
+            <a:pPr indent="0" marL="0">
+              <a:lnSpc>
+                <a:spcPct val="107000"/>
+              </a:lnSpc>
+              <a:buNone/>
+            </a:pPr>
+            <a:r>
+              <a:rPr lang="en-US" sz="1400" dirty="0">
+                <a:solidFill>
+                  <a:srgbClr val="0F172A"/>
+                </a:solidFill>
+                <a:latin typeface="Helvetica Neue" pitchFamily="34" charset="0"/>
+                <a:ea typeface="Helvetica Neue" pitchFamily="34" charset="-122"/>
+                <a:cs typeface="Helvetica Neue" pitchFamily="34" charset="-120"/>
+              </a:rPr>
+              <a:t>• 支援 WebGL/2D 預覽：用同一套 SVG 來源保持一致</a:t>
+            </a:r>
+            <a:pPr indent="0" marL="0">
+              <a:lnSpc>
+                <a:spcPct val="107000"/>
+              </a:lnSpc>
+              <a:buNone/>
+            </a:pPr>
+            <a:r>
+              <a:rPr lang="en-US" sz="1400" dirty="0">
+                <a:solidFill>
+                  <a:srgbClr val="0F172A"/>
+                </a:solidFill>
+                <a:latin typeface="Helvetica Neue" pitchFamily="34" charset="0"/>
+                <a:ea typeface="Helvetica Neue" pitchFamily="34" charset="-122"/>
+                <a:cs typeface="Helvetica Neue" pitchFamily="34" charset="-120"/>
+              </a:rPr>
+              <a:t>目標：降低決策成本，加速版式定稿。</a:t>
+            </a:r>
+            <a:endParaRPr lang="en-US" sz="1600" dirty="0"/>
+          </a:p>
+        </p:txBody>
+      </p:sp>
+    </p:spTree>
+  </p:cSld>
+  <p:clrMapOvr>
+    <a:masterClrMapping/>
+  </p:clrMapOvr>
+</p:sld>
+</file>
+
+<file path=ppt/slides/slide7.xml><?xml version="1.0" encoding="utf-8"?>
+<p:sld xmlns:a="http://schemas.openxmlformats.org/drawingml/2006/main" xmlns:r="http://schemas.openxmlformats.org/officeDocument/2006/relationships" xmlns:p="http://schemas.openxmlformats.org/presentationml/2006/main">
+  <p:cSld name="Slide 7">
+    <p:bg>
+      <p:bgPr>
+        <a:solidFill>
+          <a:srgbClr val="F8FAFC"/>
+        </a:solidFill>
+      </p:bgPr>
+    </p:bg>
+    <p:spTree>
+      <p:nvGrpSpPr>
+        <p:cNvPr id="1" name=""/>
+        <p:cNvGrpSpPr/>
+        <p:nvPr/>
+      </p:nvGrpSpPr>
+      <p:grpSpPr>
+        <a:xfrm>
+          <a:off x="0" y="0"/>
+          <a:ext cx="0" cy="0"/>
+          <a:chOff x="0" y="0"/>
+          <a:chExt cx="0" cy="0"/>
+        </a:xfrm>
+      </p:grpSpPr>
+      <p:sp>
+        <p:nvSpPr>
+          <p:cNvPr id="2" name="Text 0"/>
+          <p:cNvSpPr/>
+          <p:nvPr/>
+        </p:nvSpPr>
+        <p:spPr>
+          <a:xfrm>
+            <a:off x="548640" y="411480"/>
+            <a:ext cx="8046720" cy="777240"/>
+          </a:xfrm>
+          <a:prstGeom prst="rect">
+            <a:avLst/>
+          </a:prstGeom>
+          <a:noFill/>
+          <a:ln/>
+        </p:spPr>
+        <p:txBody>
+          <a:bodyPr wrap="square" rtlCol="0" anchor="ctr"/>
+          <a:lstStyle/>
+          <a:p>
+            <a:pPr indent="0" marL="0">
+              <a:buNone/>
+            </a:pPr>
+            <a:r>
+              <a:rPr lang="en-US" sz="2800" b="1" dirty="0">
+                <a:solidFill>
+                  <a:srgbClr val="4F46E5"/>
+                </a:solidFill>
+                <a:latin typeface="Helvetica Neue" pitchFamily="34" charset="0"/>
+                <a:ea typeface="Helvetica Neue" pitchFamily="34" charset="-122"/>
+                <a:cs typeface="Helvetica Neue" pitchFamily="34" charset="-120"/>
+              </a:rPr>
+              <a:t>UX Flow 4 匯出 Export</a:t>
+            </a:r>
+            <a:endParaRPr lang="en-US" sz="2800" dirty="0"/>
+          </a:p>
+        </p:txBody>
+      </p:sp>
+      <p:sp>
+        <p:nvSpPr>
+          <p:cNvPr id="3" name="Text 1"/>
+          <p:cNvSpPr/>
+          <p:nvPr/>
+        </p:nvSpPr>
+        <p:spPr>
+          <a:xfrm>
+            <a:off x="548640" y="1051560"/>
+            <a:ext cx="8046720" cy="365760"/>
+          </a:xfrm>
+          <a:prstGeom prst="rect">
+            <a:avLst/>
+          </a:prstGeom>
+          <a:noFill/>
+          <a:ln/>
+        </p:spPr>
+        <p:txBody>
+          <a:bodyPr wrap="square" rtlCol="0" anchor="ctr"/>
+          <a:lstStyle/>
+          <a:p>
+            <a:pPr indent="0" marL="0">
+              <a:buNone/>
+            </a:pPr>
+            <a:r>
+              <a:rPr lang="en-US" sz="1300" dirty="0">
+                <a:solidFill>
+                  <a:srgbClr val="64748B"/>
+                </a:solidFill>
+                <a:latin typeface="Helvetica Neue" pitchFamily="34" charset="0"/>
+                <a:ea typeface="Helvetica Neue" pitchFamily="34" charset="-122"/>
+                <a:cs typeface="Helvetica Neue" pitchFamily="34" charset="-120"/>
+              </a:rPr>
+              <a:t>Deliverables: PDF / SVG</a:t>
+            </a:r>
+            <a:endParaRPr lang="en-US" sz="1300" dirty="0"/>
+          </a:p>
+        </p:txBody>
+      </p:sp>
+      <p:pic>
+        <p:nvPicPr>
+          <p:cNvPr id="4" name="Image 0" descr="/Users/guoxiaoyue/.cursor/projects/Users-guoxiaoyue-Downloads-cursor-Portfolio-ReStyle-AI/assets/__2026-03-30_15.15.55-596f6acd-3360-49c6-8675-49394d0372f5.png">    </p:cNvPr>
+          <p:cNvPicPr>
+            <a:picLocks noChangeAspect="1"/>
+          </p:cNvPicPr>
+          <p:nvPr/>
+        </p:nvPicPr>
+        <p:blipFill>
+          <a:blip r:embed="rId1"/>
+          <a:srcRect l="0" r="0" t="0" b="0"/>
+          <a:stretch/>
+        </p:blipFill>
+        <p:spPr>
+          <a:xfrm>
+            <a:off x="4800600" y="1508760"/>
+            <a:ext cx="4297680" cy="4663440"/>
+          </a:xfrm>
+          <a:prstGeom prst="rect">
+            <a:avLst/>
+          </a:prstGeom>
+        </p:spPr>
+      </p:pic>
+      <p:sp>
+        <p:nvSpPr>
+          <p:cNvPr id="5" name="Text 2"/>
+          <p:cNvSpPr/>
+          <p:nvPr/>
+        </p:nvSpPr>
+        <p:spPr>
+          <a:xfrm>
+            <a:off x="502920" y="1554480"/>
+            <a:ext cx="4251960" cy="4754880"/>
+          </a:xfrm>
+          <a:prstGeom prst="rect">
+            <a:avLst/>
+          </a:prstGeom>
+          <a:noFill/>
+          <a:ln/>
+        </p:spPr>
+        <p:txBody>
+          <a:bodyPr wrap="square" rtlCol="0" anchor="ctr"/>
+          <a:lstStyle/>
+          <a:p>
+            <a:pPr indent="0" marL="0">
+              <a:lnSpc>
+                <a:spcPct val="107000"/>
+              </a:lnSpc>
+              <a:buNone/>
+            </a:pPr>
+            <a:r>
+              <a:rPr lang="en-US" sz="1600" b="1" dirty="0">
+                <a:solidFill>
+                  <a:srgbClr val="0F172A"/>
+                </a:solidFill>
+                <a:latin typeface="Helvetica Neue" pitchFamily="34" charset="0"/>
+                <a:ea typeface="Helvetica Neue" pitchFamily="34" charset="-122"/>
+                <a:cs typeface="Helvetica Neue" pitchFamily="34" charset="-120"/>
+              </a:rPr>
+              <a:t>Export 匯出</a:t>
+            </a:r>
+            <a:pPr indent="0" marL="0">
+              <a:lnSpc>
+                <a:spcPct val="107000"/>
+              </a:lnSpc>
+              <a:buNone/>
+            </a:pPr>
+            <a:r>
+              <a:rPr lang="en-US" sz="1400" dirty="0">
+                <a:solidFill>
+                  <a:srgbClr val="0F172A"/>
+                </a:solidFill>
+                <a:latin typeface="Helvetica Neue" pitchFamily="34" charset="0"/>
+                <a:ea typeface="Helvetica Neue" pitchFamily="34" charset="-122"/>
+                <a:cs typeface="Helvetica Neue" pitchFamily="34" charset="-120"/>
+              </a:rPr>
+              <a:t>• 下載合併 PDF：適合分享與列印</a:t>
+            </a:r>
+            <a:pPr indent="0" marL="0">
+              <a:lnSpc>
+                <a:spcPct val="107000"/>
+              </a:lnSpc>
+              <a:buNone/>
+            </a:pPr>
+            <a:r>
+              <a:rPr lang="en-US" sz="1400" dirty="0">
+                <a:solidFill>
+                  <a:srgbClr val="0F172A"/>
+                </a:solidFill>
+                <a:latin typeface="Helvetica Neue" pitchFamily="34" charset="0"/>
+                <a:ea typeface="Helvetica Neue" pitchFamily="34" charset="-122"/>
+                <a:cs typeface="Helvetica Neue" pitchFamily="34" charset="-120"/>
+              </a:rPr>
+              <a:t>• 下載每頁 SVG：給 Figma/編輯器繼續精修</a:t>
+            </a:r>
+            <a:pPr indent="0" marL="0">
+              <a:lnSpc>
+                <a:spcPct val="107000"/>
+              </a:lnSpc>
+              <a:buNone/>
+            </a:pPr>
+            <a:r>
+              <a:rPr lang="en-US" sz="1400" dirty="0">
+                <a:solidFill>
+                  <a:srgbClr val="0F172A"/>
+                </a:solidFill>
+                <a:latin typeface="Helvetica Neue" pitchFamily="34" charset="0"/>
+                <a:ea typeface="Helvetica Neue" pitchFamily="34" charset="-122"/>
+                <a:cs typeface="Helvetica Neue" pitchFamily="34" charset="-120"/>
+              </a:rPr>
+              <a:t>• 匯出保留所選版本設定（包含網格重排/塊微調）。</a:t>
+            </a:r>
+            <a:pPr indent="0" marL="0">
+              <a:lnSpc>
+                <a:spcPct val="107000"/>
+              </a:lnSpc>
+              <a:buNone/>
+            </a:pPr>
+            <a:r>
+              <a:rPr lang="en-US" sz="1400" dirty="0">
+                <a:solidFill>
+                  <a:srgbClr val="0F172A"/>
+                </a:solidFill>
+                <a:latin typeface="Helvetica Neue" pitchFamily="34" charset="0"/>
+                <a:ea typeface="Helvetica Neue" pitchFamily="34" charset="-122"/>
+                <a:cs typeface="Helvetica Neue" pitchFamily="34" charset="-120"/>
+              </a:rPr>
+              <a:t>目標：把探索結果轉成可交付的設計稿。</a:t>
+            </a:r>
+            <a:endParaRPr lang="en-US" sz="1600" dirty="0"/>
+          </a:p>
+        </p:txBody>
+      </p:sp>
+    </p:spTree>
+  </p:cSld>
+  <p:clrMapOvr>
+    <a:masterClrMapping/>
+  </p:clrMapOvr>
+</p:sld>
+</file>
+
+<file path=ppt/slides/slide8.xml><?xml version="1.0" encoding="utf-8"?>
+<p:sld xmlns:a="http://schemas.openxmlformats.org/drawingml/2006/main" xmlns:r="http://schemas.openxmlformats.org/officeDocument/2006/relationships" xmlns:p="http://schemas.openxmlformats.org/presentationml/2006/main">
+  <p:cSld name="Slide 8">
+    <p:bg>
+      <p:bgPr>
+        <a:solidFill>
+          <a:srgbClr val="F8FAFC"/>
+        </a:solidFill>
+      </p:bgPr>
+    </p:bg>
+    <p:spTree>
+      <p:nvGrpSpPr>
+        <p:cNvPr id="1" name=""/>
+        <p:cNvGrpSpPr/>
+        <p:nvPr/>
+      </p:nvGrpSpPr>
+      <p:grpSpPr>
+        <a:xfrm>
+          <a:off x="0" y="0"/>
+          <a:ext cx="0" cy="0"/>
+          <a:chOff x="0" y="0"/>
+          <a:chExt cx="0" cy="0"/>
+        </a:xfrm>
+      </p:grpSpPr>
+      <p:sp>
+        <p:nvSpPr>
+          <p:cNvPr id="2" name="Text 0"/>
+          <p:cNvSpPr/>
+          <p:nvPr/>
+        </p:nvSpPr>
+        <p:spPr>
+          <a:xfrm>
+            <a:off x="548640" y="411480"/>
+            <a:ext cx="8046720" cy="777240"/>
+          </a:xfrm>
+          <a:prstGeom prst="rect">
+            <a:avLst/>
+          </a:prstGeom>
+          <a:noFill/>
+          <a:ln/>
+        </p:spPr>
+        <p:txBody>
+          <a:bodyPr wrap="square" rtlCol="0" anchor="ctr"/>
+          <a:lstStyle/>
+          <a:p>
+            <a:pPr indent="0" marL="0">
+              <a:buNone/>
+            </a:pPr>
+            <a:r>
+              <a:rPr lang="en-US" sz="2800" b="1" dirty="0">
+                <a:solidFill>
+                  <a:srgbClr val="4F46E5"/>
+                </a:solidFill>
+                <a:latin typeface="Helvetica Neue" pitchFamily="34" charset="0"/>
+                <a:ea typeface="Helvetica Neue" pitchFamily="34" charset="-122"/>
+                <a:cs typeface="Helvetica Neue" pitchFamily="34" charset="-120"/>
+              </a:rPr>
+              <a:t>Design thinking 設計思維</a:t>
+            </a:r>
+            <a:endParaRPr lang="en-US" sz="2800" dirty="0"/>
+          </a:p>
+        </p:txBody>
+      </p:sp>
+      <p:sp>
+        <p:nvSpPr>
+          <p:cNvPr id="3" name="Text 1"/>
+          <p:cNvSpPr/>
+          <p:nvPr/>
+        </p:nvSpPr>
+        <p:spPr>
+          <a:xfrm>
+            <a:off x="548640" y="1051560"/>
+            <a:ext cx="8046720" cy="365760"/>
+          </a:xfrm>
+          <a:prstGeom prst="rect">
+            <a:avLst/>
+          </a:prstGeom>
+          <a:noFill/>
+          <a:ln/>
+        </p:spPr>
+        <p:txBody>
+          <a:bodyPr wrap="square" rtlCol="0" anchor="ctr"/>
+          <a:lstStyle/>
+          <a:p>
+            <a:pPr indent="0" marL="0">
+              <a:buNone/>
+            </a:pPr>
+            <a:r>
+              <a:rPr lang="en-US" sz="1300" dirty="0">
+                <a:solidFill>
+                  <a:srgbClr val="64748B"/>
+                </a:solidFill>
+                <a:latin typeface="Helvetica Neue" pitchFamily="34" charset="0"/>
+                <a:ea typeface="Helvetica Neue" pitchFamily="34" charset="-122"/>
+                <a:cs typeface="Helvetica Neue" pitchFamily="34" charset="-120"/>
+              </a:rPr>
+              <a:t>From layout pain → clear workflow</a:t>
+            </a:r>
+            <a:endParaRPr lang="en-US" sz="1300" dirty="0"/>
+          </a:p>
+        </p:txBody>
+      </p:sp>
+      <p:sp>
+        <p:nvSpPr>
+          <p:cNvPr id="4" name="Text 2"/>
+          <p:cNvSpPr/>
+          <p:nvPr/>
+        </p:nvSpPr>
+        <p:spPr>
+          <a:xfrm>
+            <a:off x="548640" y="1600200"/>
+            <a:ext cx="8046720" cy="3429000"/>
+          </a:xfrm>
+          <a:prstGeom prst="rect">
+            <a:avLst/>
+          </a:prstGeom>
+          <a:noFill/>
+          <a:ln/>
+        </p:spPr>
+        <p:txBody>
+          <a:bodyPr wrap="square" rtlCol="0" anchor="ctr"/>
+          <a:lstStyle/>
+          <a:p>
+            <a:pPr marL="342900" indent="-342900">
+              <a:lnSpc>
+                <a:spcPct val="108000"/>
+              </a:lnSpc>
+              <a:buSzPct val="100000"/>
+              <a:buChar char="•"/>
+            </a:pPr>
+            <a:r>
+              <a:rPr lang="en-US" sz="1400" dirty="0">
+                <a:solidFill>
+                  <a:srgbClr val="0F172A"/>
+                </a:solidFill>
+                <a:latin typeface="Helvetica Neue" pitchFamily="34" charset="0"/>
+                <a:ea typeface="Helvetica Neue" pitchFamily="34" charset="-122"/>
+                <a:cs typeface="Helvetica Neue" pitchFamily="34" charset="-120"/>
+              </a:rPr>
+              <a:t>Empathize 同理：repetitive layout work (order/grid/spacing) steals time → designer stays in control.</a:t>
+            </a:r>
+            <a:endParaRPr lang="en-US" sz="1400" dirty="0"/>
+          </a:p>
+          <a:p>
+            <a:pPr marL="342900" indent="-342900">
+              <a:lnSpc>
+                <a:spcPct val="108000"/>
+              </a:lnSpc>
+              <a:buSzPct val="100000"/>
+              <a:buChar char="•"/>
+            </a:pPr>
+            <a:r>
+              <a:rPr lang="en-US" sz="1400" dirty="0">
+                <a:solidFill>
+                  <a:srgbClr val="0F172A"/>
+                </a:solidFill>
+                <a:latin typeface="Helvetica Neue" pitchFamily="34" charset="0"/>
+                <a:ea typeface="Helvetica Neue" pitchFamily="34" charset="-122"/>
+                <a:cs typeface="Helvetica Neue" pitchFamily="34" charset="-120"/>
+              </a:rPr>
+              <a:t>Define 定義：assist decisions, not replace authorship — keep authorship and taste.</a:t>
+            </a:r>
+            <a:endParaRPr lang="en-US" sz="1400" dirty="0"/>
+          </a:p>
+          <a:p>
+            <a:pPr marL="342900" indent="-342900">
+              <a:lnSpc>
+                <a:spcPct val="108000"/>
+              </a:lnSpc>
+              <a:buSzPct val="100000"/>
+              <a:buChar char="•"/>
+            </a:pPr>
+            <a:r>
+              <a:rPr lang="en-US" sz="1400" dirty="0">
+                <a:solidFill>
+                  <a:srgbClr val="0F172A"/>
+                </a:solidFill>
+                <a:latin typeface="Helvetica Neue" pitchFamily="34" charset="0"/>
+                <a:ea typeface="Helvetica Neue" pitchFamily="34" charset="-122"/>
+                <a:cs typeface="Helvetica Neue" pitchFamily="34" charset="-120"/>
+              </a:rPr>
+              <a:t>Ideate 發想：wizard + persistent dock + only 3 variants per page → faster comparison.</a:t>
+            </a:r>
+            <a:endParaRPr lang="en-US" sz="1400" dirty="0"/>
+          </a:p>
+          <a:p>
+            <a:pPr marL="342900" indent="-342900">
+              <a:lnSpc>
+                <a:spcPct val="108000"/>
+              </a:lnSpc>
+              <a:buSzPct val="100000"/>
+              <a:buChar char="•"/>
+            </a:pPr>
+            <a:r>
+              <a:rPr lang="en-US" sz="1400" dirty="0">
+                <a:solidFill>
+                  <a:srgbClr val="0F172A"/>
+                </a:solidFill>
+                <a:latin typeface="Helvetica Neue" pitchFamily="34" charset="0"/>
+                <a:ea typeface="Helvetica Neue" pitchFamily="34" charset="-122"/>
+                <a:cs typeface="Helvetica Neue" pitchFamily="34" charset="-120"/>
+              </a:rPr>
+              <a:t>Prototype 原型：bilingual UI + grid remix + tile nudge + before/after compare for readability.</a:t>
+            </a:r>
+            <a:endParaRPr lang="en-US" sz="1400" dirty="0"/>
+          </a:p>
+          <a:p>
+            <a:pPr marL="342900" indent="-342900">
+              <a:lnSpc>
+                <a:spcPct val="108000"/>
+              </a:lnSpc>
+              <a:buSzPct val="100000"/>
+              <a:buChar char="•"/>
+            </a:pPr>
+            <a:r>
+              <a:rPr lang="en-US" sz="1400" dirty="0">
+                <a:solidFill>
+                  <a:srgbClr val="0F172A"/>
+                </a:solidFill>
+                <a:latin typeface="Helvetica Neue" pitchFamily="34" charset="0"/>
+                <a:ea typeface="Helvetica Neue" pitchFamily="34" charset="-122"/>
+                <a:cs typeface="Helvetica Neue" pitchFamily="34" charset="-120"/>
+              </a:rPr>
+              <a:t>Test 測試：synchronize previews across steps and keep typography hierarchy stable (e.g. 1×2 grids).</a:t>
+            </a:r>
+            <a:endParaRPr lang="en-US" sz="1400" dirty="0"/>
+          </a:p>
+        </p:txBody>
+      </p:sp>
+    </p:spTree>
+  </p:cSld>
+  <p:clrMapOvr>
+    <a:masterClrMapping/>
+  </p:clrMapOvr>
+</p:sld>
+</file>
+
+<file path=ppt/slides/slide9.xml><?xml version="1.0" encoding="utf-8"?>
+<p:sld xmlns:a="http://schemas.openxmlformats.org/drawingml/2006/main" xmlns:r="http://schemas.openxmlformats.org/officeDocument/2006/relationships" xmlns:p="http://schemas.openxmlformats.org/presentationml/2006/main">
+  <p:cSld name="Slide 9">
+    <p:bg>
+      <p:bgPr>
+        <a:solidFill>
+          <a:srgbClr val="F8FAFC"/>
+        </a:solidFill>
+      </p:bgPr>
+    </p:bg>
+    <p:spTree>
+      <p:nvGrpSpPr>
+        <p:cNvPr id="1" name=""/>
+        <p:cNvGrpSpPr/>
+        <p:nvPr/>
+      </p:nvGrpSpPr>
+      <p:grpSpPr>
+        <a:xfrm>
+          <a:off x="0" y="0"/>
+          <a:ext cx="0" cy="0"/>
+          <a:chOff x="0" y="0"/>
+          <a:chExt cx="0" cy="0"/>
+        </a:xfrm>
+      </p:grpSpPr>
+      <p:sp>
+        <p:nvSpPr>
+          <p:cNvPr id="2" name="Text 0"/>
+          <p:cNvSpPr/>
+          <p:nvPr/>
+        </p:nvSpPr>
+        <p:spPr>
+          <a:xfrm>
+            <a:off x="548640" y="411480"/>
+            <a:ext cx="8046720" cy="777240"/>
+          </a:xfrm>
+          <a:prstGeom prst="rect">
+            <a:avLst/>
+          </a:prstGeom>
+          <a:noFill/>
+          <a:ln/>
+        </p:spPr>
+        <p:txBody>
+          <a:bodyPr wrap="square" rtlCol="0" anchor="ctr"/>
+          <a:lstStyle/>
+          <a:p>
+            <a:pPr indent="0" marL="0">
+              <a:buNone/>
+            </a:pPr>
+            <a:r>
+              <a:rPr lang="en-US" sz="2800" b="1" dirty="0">
+                <a:solidFill>
+                  <a:srgbClr val="4F46E5"/>
+                </a:solidFill>
+                <a:latin typeface="Helvetica Neue" pitchFamily="34" charset="0"/>
+                <a:ea typeface="Helvetica Neue" pitchFamily="34" charset="-122"/>
+                <a:cs typeface="Helvetica Neue" pitchFamily="34" charset="-120"/>
+              </a:rPr>
+              <a:t>Design system principles 版面設計原則</a:t>
+            </a:r>
+            <a:endParaRPr lang="en-US" sz="2800" dirty="0"/>
+          </a:p>
+        </p:txBody>
+      </p:sp>
+      <p:sp>
+        <p:nvSpPr>
+          <p:cNvPr id="3" name="Text 1"/>
+          <p:cNvSpPr/>
+          <p:nvPr/>
+        </p:nvSpPr>
+        <p:spPr>
+          <a:xfrm>
+            <a:off x="548640" y="1051560"/>
+            <a:ext cx="8046720" cy="365760"/>
+          </a:xfrm>
+          <a:prstGeom prst="rect">
+            <a:avLst/>
+          </a:prstGeom>
+          <a:noFill/>
+          <a:ln/>
+        </p:spPr>
+        <p:txBody>
+          <a:bodyPr wrap="square" rtlCol="0" anchor="ctr"/>
+          <a:lstStyle/>
+          <a:p>
+            <a:pPr indent="0" marL="0">
+              <a:buNone/>
+            </a:pPr>
+            <a:r>
+              <a:rPr lang="en-US" sz="1300" dirty="0">
+                <a:solidFill>
+                  <a:srgbClr val="64748B"/>
+                </a:solidFill>
+                <a:latin typeface="Helvetica Neue" pitchFamily="34" charset="0"/>
+                <a:ea typeface="Helvetica Neue" pitchFamily="34" charset="-122"/>
+                <a:cs typeface="Helvetica Neue" pitchFamily="34" charset="-120"/>
+              </a:rPr>
               <a:t>Aesthetic consistency, faster decisions</a:t>
             </a:r>
             <a:endParaRPr lang="en-US" sz="1300" dirty="0"/>
@@ -2969,7 +4596,7 @@
       </p:sp>
       <p:graphicFrame>
         <p:nvGraphicFramePr>
-          <p:cNvPr id="7" name="Table 0"/>
+          <p:cNvPr id="10" name="Table 0"/>
           <p:cNvGraphicFramePr>
             <a:graphicFrameLocks noGrp="1"/>
           </p:cNvGraphicFramePr>
@@ -3719,741 +5346,6 @@
 </p:sld>
 </file>
 
-<file path=ppt/slides/slide7.xml><?xml version="1.0" encoding="utf-8"?>
-<p:sld xmlns:a="http://schemas.openxmlformats.org/drawingml/2006/main" xmlns:r="http://schemas.openxmlformats.org/officeDocument/2006/relationships" xmlns:p="http://schemas.openxmlformats.org/presentationml/2006/main">
-  <p:cSld name="Slide 7">
-    <p:bg>
-      <p:bgPr>
-        <a:solidFill>
-          <a:srgbClr val="F8FAFC"/>
-        </a:solidFill>
-      </p:bgPr>
-    </p:bg>
-    <p:spTree>
-      <p:nvGrpSpPr>
-        <p:cNvPr id="1" name=""/>
-        <p:cNvGrpSpPr/>
-        <p:nvPr/>
-      </p:nvGrpSpPr>
-      <p:grpSpPr>
-        <a:xfrm>
-          <a:off x="0" y="0"/>
-          <a:ext cx="0" cy="0"/>
-          <a:chOff x="0" y="0"/>
-          <a:chExt cx="0" cy="0"/>
-        </a:xfrm>
-      </p:grpSpPr>
-      <p:sp>
-        <p:nvSpPr>
-          <p:cNvPr id="2" name="Text 0"/>
-          <p:cNvSpPr/>
-          <p:nvPr/>
-        </p:nvSpPr>
-        <p:spPr>
-          <a:xfrm>
-            <a:off x="548640" y="411480"/>
-            <a:ext cx="8046720" cy="777240"/>
-          </a:xfrm>
-          <a:prstGeom prst="rect">
-            <a:avLst/>
-          </a:prstGeom>
-          <a:noFill/>
-          <a:ln/>
-        </p:spPr>
-        <p:txBody>
-          <a:bodyPr wrap="square" rtlCol="0" anchor="ctr"/>
-          <a:lstStyle/>
-          <a:p>
-            <a:pPr indent="0" marL="0">
-              <a:buNone/>
-            </a:pPr>
-            <a:r>
-              <a:rPr lang="en-US" sz="2800" b="1" dirty="0">
-                <a:solidFill>
-                  <a:srgbClr val="4F46E5"/>
-                </a:solidFill>
-                <a:latin typeface="Helvetica Neue" pitchFamily="34" charset="0"/>
-                <a:ea typeface="Helvetica Neue" pitchFamily="34" charset="-122"/>
-                <a:cs typeface="Helvetica Neue" pitchFamily="34" charset="-120"/>
-              </a:rPr>
-              <a:t>Demo script 演示腳本</a:t>
-            </a:r>
-            <a:endParaRPr lang="en-US" sz="2800" dirty="0"/>
-          </a:p>
-        </p:txBody>
-      </p:sp>
-      <p:sp>
-        <p:nvSpPr>
-          <p:cNvPr id="3" name="Text 1"/>
-          <p:cNvSpPr/>
-          <p:nvPr/>
-        </p:nvSpPr>
-        <p:spPr>
-          <a:xfrm>
-            <a:off x="548640" y="1051560"/>
-            <a:ext cx="8046720" cy="365760"/>
-          </a:xfrm>
-          <a:prstGeom prst="rect">
-            <a:avLst/>
-          </a:prstGeom>
-          <a:noFill/>
-          <a:ln/>
-        </p:spPr>
-        <p:txBody>
-          <a:bodyPr wrap="square" rtlCol="0" anchor="ctr"/>
-          <a:lstStyle/>
-          <a:p>
-            <a:pPr indent="0" marL="0">
-              <a:buNone/>
-            </a:pPr>
-            <a:r>
-              <a:rPr lang="en-US" sz="1300" dirty="0">
-                <a:solidFill>
-                  <a:srgbClr val="64748B"/>
-                </a:solidFill>
-                <a:latin typeface="Helvetica Neue" pitchFamily="34" charset="0"/>
-                <a:ea typeface="Helvetica Neue" pitchFamily="34" charset="-122"/>
-                <a:cs typeface="Helvetica Neue" pitchFamily="34" charset="-120"/>
-              </a:rPr>
-              <a:t>For your screen recording / video</a:t>
-            </a:r>
-            <a:endParaRPr lang="en-US" sz="1300" dirty="0"/>
-          </a:p>
-        </p:txBody>
-      </p:sp>
-      <p:pic>
-        <p:nvPicPr>
-          <p:cNvPr id="4" name="Image 0" descr="/Users/guoxiaoyue/.cursor/projects/Users-guoxiaoyue-Downloads-cursor-Portfolio-ReStyle-AI/assets/__2026-03-30_15.46.25-614732c6-5924-43fb-88f9-746a1dc6626e.png">    </p:cNvPr>
-          <p:cNvPicPr>
-            <a:picLocks noChangeAspect="1"/>
-          </p:cNvPicPr>
-          <p:nvPr/>
-        </p:nvPicPr>
-        <p:blipFill>
-          <a:blip r:embed="rId1"/>
-          <a:stretch>
-            <a:fillRect/>
-          </a:stretch>
-        </p:blipFill>
-        <p:spPr>
-          <a:xfrm>
-            <a:off x="4892040" y="1645920"/>
-            <a:ext cx="3977640" cy="2468880"/>
-          </a:xfrm>
-          <a:prstGeom prst="rect">
-            <a:avLst/>
-          </a:prstGeom>
-        </p:spPr>
-      </p:pic>
-      <p:sp>
-        <p:nvSpPr>
-          <p:cNvPr id="5" name="Text 2"/>
-          <p:cNvSpPr/>
-          <p:nvPr/>
-        </p:nvSpPr>
-        <p:spPr>
-          <a:xfrm>
-            <a:off x="548640" y="1600200"/>
-            <a:ext cx="4297680" cy="3291840"/>
-          </a:xfrm>
-          <a:prstGeom prst="rect">
-            <a:avLst/>
-          </a:prstGeom>
-          <a:noFill/>
-          <a:ln/>
-        </p:spPr>
-        <p:txBody>
-          <a:bodyPr wrap="square" rtlCol="0" anchor="ctr"/>
-          <a:lstStyle/>
-          <a:p>
-            <a:pPr marL="342900" indent="-342900">
-              <a:lnSpc>
-                <a:spcPct val="115000"/>
-              </a:lnSpc>
-              <a:buSzPct val="100000"/>
-              <a:buChar char="•"/>
-            </a:pPr>
-            <a:r>
-              <a:rPr lang="en-US" sz="1600" dirty="0">
-                <a:solidFill>
-                  <a:srgbClr val="0F172A"/>
-                </a:solidFill>
-                <a:latin typeface="Helvetica Neue" pitchFamily="34" charset="0"/>
-                <a:ea typeface="Helvetica Neue" pitchFamily="34" charset="-122"/>
-                <a:cs typeface="Helvetica Neue" pitchFamily="34" charset="-120"/>
-              </a:rPr>
-              <a:t>Show bilingual toggle (中文 ↔ English).</a:t>
-            </a:r>
-            <a:endParaRPr lang="en-US" sz="1600" dirty="0"/>
-          </a:p>
-          <a:p>
-            <a:pPr marL="342900" indent="-342900">
-              <a:lnSpc>
-                <a:spcPct val="115000"/>
-              </a:lnSpc>
-              <a:buSzPct val="100000"/>
-              <a:buChar char="•"/>
-            </a:pPr>
-            <a:r>
-              <a:rPr lang="en-US" sz="1600" dirty="0">
-                <a:solidFill>
-                  <a:srgbClr val="0F172A"/>
-                </a:solidFill>
-                <a:latin typeface="Helvetica Neue" pitchFamily="34" charset="0"/>
-                <a:ea typeface="Helvetica Neue" pitchFamily="34" charset="-122"/>
-                <a:cs typeface="Helvetica Neue" pitchFamily="34" charset="-120"/>
-              </a:rPr>
-              <a:t>Upload SVG/PDF → in the dock, change palette/style/grid and watch hierarchy update.</a:t>
-            </a:r>
-            <a:endParaRPr lang="en-US" sz="1600" dirty="0"/>
-          </a:p>
-          <a:p>
-            <a:pPr marL="342900" indent="-342900">
-              <a:lnSpc>
-                <a:spcPct val="115000"/>
-              </a:lnSpc>
-              <a:buSzPct val="100000"/>
-              <a:buChar char="•"/>
-            </a:pPr>
-            <a:r>
-              <a:rPr lang="en-US" sz="1600" dirty="0">
-                <a:solidFill>
-                  <a:srgbClr val="0F172A"/>
-                </a:solidFill>
-                <a:latin typeface="Helvetica Neue" pitchFamily="34" charset="0"/>
-                <a:ea typeface="Helvetica Neue" pitchFamily="34" charset="-122"/>
-                <a:cs typeface="Helvetica Neue" pitchFamily="34" charset="-120"/>
-              </a:rPr>
-              <a:t>Switch Before/After modes to separate hue decisions from layout decisions.</a:t>
-            </a:r>
-            <a:endParaRPr lang="en-US" sz="1600" dirty="0"/>
-          </a:p>
-          <a:p>
-            <a:pPr marL="342900" indent="-342900">
-              <a:lnSpc>
-                <a:spcPct val="115000"/>
-              </a:lnSpc>
-              <a:buSzPct val="100000"/>
-              <a:buChar char="•"/>
-            </a:pPr>
-            <a:r>
-              <a:rPr lang="en-US" sz="1600" dirty="0">
-                <a:solidFill>
-                  <a:srgbClr val="0F172A"/>
-                </a:solidFill>
-                <a:latin typeface="Helvetica Neue" pitchFamily="34" charset="0"/>
-                <a:ea typeface="Helvetica Neue" pitchFamily="34" charset="-122"/>
-                <a:cs typeface="Helvetica Neue" pitchFamily="34" charset="-120"/>
-              </a:rPr>
-              <a:t>Pick one variant per page; show 1×2 / 2×1 presets for asymmetric composition.</a:t>
-            </a:r>
-            <a:endParaRPr lang="en-US" sz="1600" dirty="0"/>
-          </a:p>
-          <a:p>
-            <a:pPr marL="342900" indent="-342900">
-              <a:lnSpc>
-                <a:spcPct val="115000"/>
-              </a:lnSpc>
-              <a:buSzPct val="100000"/>
-              <a:buChar char="•"/>
-            </a:pPr>
-            <a:r>
-              <a:rPr lang="en-US" sz="1600" dirty="0">
-                <a:solidFill>
-                  <a:srgbClr val="0F172A"/>
-                </a:solidFill>
-                <a:latin typeface="Helvetica Neue" pitchFamily="34" charset="0"/>
-                <a:ea typeface="Helvetica Neue" pitchFamily="34" charset="-122"/>
-                <a:cs typeface="Helvetica Neue" pitchFamily="34" charset="-120"/>
-              </a:rPr>
-              <a:t>Export as merged PDF and per-page SVG for further visual refinement.</a:t>
-            </a:r>
-            <a:endParaRPr lang="en-US" sz="1600" dirty="0"/>
-          </a:p>
-        </p:txBody>
-      </p:sp>
-    </p:spTree>
-  </p:cSld>
-  <p:clrMapOvr>
-    <a:masterClrMapping/>
-  </p:clrMapOvr>
-</p:sld>
-</file>
-
-<file path=ppt/slides/slide8.xml><?xml version="1.0" encoding="utf-8"?>
-<p:sld xmlns:a="http://schemas.openxmlformats.org/drawingml/2006/main" xmlns:r="http://schemas.openxmlformats.org/officeDocument/2006/relationships" xmlns:p="http://schemas.openxmlformats.org/presentationml/2006/main">
-  <p:cSld name="Slide 8">
-    <p:bg>
-      <p:bgPr>
-        <a:solidFill>
-          <a:srgbClr val="F8FAFC"/>
-        </a:solidFill>
-      </p:bgPr>
-    </p:bg>
-    <p:spTree>
-      <p:nvGrpSpPr>
-        <p:cNvPr id="1" name=""/>
-        <p:cNvGrpSpPr/>
-        <p:nvPr/>
-      </p:nvGrpSpPr>
-      <p:grpSpPr>
-        <a:xfrm>
-          <a:off x="0" y="0"/>
-          <a:ext cx="0" cy="0"/>
-          <a:chOff x="0" y="0"/>
-          <a:chExt cx="0" cy="0"/>
-        </a:xfrm>
-      </p:grpSpPr>
-      <p:sp>
-        <p:nvSpPr>
-          <p:cNvPr id="2" name="Text 0"/>
-          <p:cNvSpPr/>
-          <p:nvPr/>
-        </p:nvSpPr>
-        <p:spPr>
-          <a:xfrm>
-            <a:off x="548640" y="411480"/>
-            <a:ext cx="8046720" cy="777240"/>
-          </a:xfrm>
-          <a:prstGeom prst="rect">
-            <a:avLst/>
-          </a:prstGeom>
-          <a:noFill/>
-          <a:ln/>
-        </p:spPr>
-        <p:txBody>
-          <a:bodyPr wrap="square" rtlCol="0" anchor="ctr"/>
-          <a:lstStyle/>
-          <a:p>
-            <a:pPr indent="0" marL="0">
-              <a:buNone/>
-            </a:pPr>
-            <a:r>
-              <a:rPr lang="en-US" sz="2800" b="1" dirty="0">
-                <a:solidFill>
-                  <a:srgbClr val="4F46E5"/>
-                </a:solidFill>
-                <a:latin typeface="Helvetica Neue" pitchFamily="34" charset="0"/>
-                <a:ea typeface="Helvetica Neue" pitchFamily="34" charset="-122"/>
-                <a:cs typeface="Helvetica Neue" pitchFamily="34" charset="-120"/>
-              </a:rPr>
-              <a:t>Reflection 反思</a:t>
-            </a:r>
-            <a:endParaRPr lang="en-US" sz="2800" dirty="0"/>
-          </a:p>
-        </p:txBody>
-      </p:sp>
-      <p:sp>
-        <p:nvSpPr>
-          <p:cNvPr id="3" name="Text 1"/>
-          <p:cNvSpPr/>
-          <p:nvPr/>
-        </p:nvSpPr>
-        <p:spPr>
-          <a:xfrm>
-            <a:off x="548640" y="1051560"/>
-            <a:ext cx="8046720" cy="365760"/>
-          </a:xfrm>
-          <a:prstGeom prst="rect">
-            <a:avLst/>
-          </a:prstGeom>
-          <a:noFill/>
-          <a:ln/>
-        </p:spPr>
-        <p:txBody>
-          <a:bodyPr wrap="square" rtlCol="0" anchor="ctr"/>
-          <a:lstStyle/>
-          <a:p>
-            <a:pPr indent="0" marL="0">
-              <a:buNone/>
-            </a:pPr>
-            <a:r>
-              <a:rPr lang="en-US" sz="1300" dirty="0">
-                <a:solidFill>
-                  <a:srgbClr val="64748B"/>
-                </a:solidFill>
-                <a:latin typeface="Helvetica Neue" pitchFamily="34" charset="0"/>
-                <a:ea typeface="Helvetica Neue" pitchFamily="34" charset="-122"/>
-                <a:cs typeface="Helvetica Neue" pitchFamily="34" charset="-120"/>
-              </a:rPr>
-              <a:t>Design focus · Next steps</a:t>
-            </a:r>
-            <a:endParaRPr lang="en-US" sz="1300" dirty="0"/>
-          </a:p>
-        </p:txBody>
-      </p:sp>
-      <p:sp>
-        <p:nvSpPr>
-          <p:cNvPr id="4" name="Text 2"/>
-          <p:cNvSpPr/>
-          <p:nvPr/>
-        </p:nvSpPr>
-        <p:spPr>
-          <a:xfrm>
-            <a:off x="548640" y="1600200"/>
-            <a:ext cx="8046720" cy="3474720"/>
-          </a:xfrm>
-          <a:prstGeom prst="rect">
-            <a:avLst/>
-          </a:prstGeom>
-          <a:noFill/>
-          <a:ln/>
-        </p:spPr>
-        <p:txBody>
-          <a:bodyPr wrap="square" rtlCol="0" anchor="ctr"/>
-          <a:lstStyle/>
-          <a:p>
-            <a:pPr marL="342900" indent="-342900">
-              <a:lnSpc>
-                <a:spcPct val="115000"/>
-              </a:lnSpc>
-              <a:buSzPct val="100000"/>
-              <a:buChar char="•"/>
-            </a:pPr>
-            <a:r>
-              <a:rPr lang="en-US" sz="1600" dirty="0">
-                <a:solidFill>
-                  <a:srgbClr val="0F172A"/>
-                </a:solidFill>
-                <a:latin typeface="Helvetica Neue" pitchFamily="34" charset="0"/>
-                <a:ea typeface="Helvetica Neue" pitchFamily="34" charset="-122"/>
-                <a:cs typeface="Helvetica Neue" pitchFamily="34" charset="-120"/>
-              </a:rPr>
-              <a:t>What worked: clear type hierarchy + stable dock preview for confident decisions.</a:t>
-            </a:r>
-            <a:endParaRPr lang="en-US" sz="1600" dirty="0"/>
-          </a:p>
-          <a:p>
-            <a:pPr marL="342900" indent="-342900">
-              <a:lnSpc>
-                <a:spcPct val="115000"/>
-              </a:lnSpc>
-              <a:buSzPct val="100000"/>
-              <a:buChar char="•"/>
-            </a:pPr>
-            <a:r>
-              <a:rPr lang="en-US" sz="1500" dirty="0">
-                <a:solidFill>
-                  <a:srgbClr val="0F172A"/>
-                </a:solidFill>
-                <a:latin typeface="Helvetica Neue" pitchFamily="34" charset="0"/>
-                <a:ea typeface="Helvetica Neue" pitchFamily="34" charset="-122"/>
-                <a:cs typeface="Helvetica Neue" pitchFamily="34" charset="-120"/>
-              </a:rPr>
-              <a:t>有效之處：清晰字體層級 + 穩定 dock 預覽，讓決策更有把握。</a:t>
-            </a:r>
-            <a:endParaRPr lang="en-US" sz="1600" dirty="0"/>
-          </a:p>
-          <a:p>
-            <a:pPr marL="342900" indent="-342900">
-              <a:lnSpc>
-                <a:spcPct val="115000"/>
-              </a:lnSpc>
-              <a:buSzPct val="100000"/>
-              <a:buChar char="•"/>
-            </a:pPr>
-            <a:r>
-              <a:rPr lang="en-US" sz="1600" dirty="0">
-                <a:solidFill>
-                  <a:srgbClr val="0F172A"/>
-                </a:solidFill>
-                <a:latin typeface="Helvetica Neue" pitchFamily="34" charset="0"/>
-                <a:ea typeface="Helvetica Neue" pitchFamily="34" charset="-122"/>
-                <a:cs typeface="Helvetica Neue" pitchFamily="34" charset="-120"/>
-              </a:rPr>
-              <a:t>What to improve: finer typography controls and more layout-ready components.</a:t>
-            </a:r>
-            <a:endParaRPr lang="en-US" sz="1600" dirty="0"/>
-          </a:p>
-          <a:p>
-            <a:pPr marL="342900" indent="-342900">
-              <a:lnSpc>
-                <a:spcPct val="115000"/>
-              </a:lnSpc>
-              <a:buSzPct val="100000"/>
-              <a:buChar char="•"/>
-            </a:pPr>
-            <a:r>
-              <a:rPr lang="en-US" sz="1500" dirty="0">
-                <a:solidFill>
-                  <a:srgbClr val="0F172A"/>
-                </a:solidFill>
-                <a:latin typeface="Helvetica Neue" pitchFamily="34" charset="0"/>
-                <a:ea typeface="Helvetica Neue" pitchFamily="34" charset="-122"/>
-                <a:cs typeface="Helvetica Neue" pitchFamily="34" charset="-120"/>
-              </a:rPr>
-              <a:t>接續改進：更細字體控制與更多可直接用的版面元件。</a:t>
-            </a:r>
-            <a:endParaRPr lang="en-US" sz="1600" dirty="0"/>
-          </a:p>
-          <a:p>
-            <a:pPr marL="342900" indent="-342900">
-              <a:lnSpc>
-                <a:spcPct val="115000"/>
-              </a:lnSpc>
-              <a:buSzPct val="100000"/>
-              <a:buChar char="•"/>
-            </a:pPr>
-            <a:r>
-              <a:rPr lang="en-US" sz="1600" dirty="0">
-                <a:solidFill>
-                  <a:srgbClr val="0F172A"/>
-                </a:solidFill>
-                <a:latin typeface="Helvetica Neue" pitchFamily="34" charset="0"/>
-                <a:ea typeface="Helvetica Neue" pitchFamily="34" charset="-122"/>
-                <a:cs typeface="Helvetica Neue" pitchFamily="34" charset="-120"/>
-              </a:rPr>
-              <a:t>Ethics: API keys only in .env.local; no training on user uploads in this prototype.</a:t>
-            </a:r>
-            <a:endParaRPr lang="en-US" sz="1600" dirty="0"/>
-          </a:p>
-          <a:p>
-            <a:pPr marL="342900" indent="-342900">
-              <a:lnSpc>
-                <a:spcPct val="115000"/>
-              </a:lnSpc>
-              <a:buSzPct val="100000"/>
-              <a:buChar char="•"/>
-            </a:pPr>
-            <a:r>
-              <a:rPr lang="en-US" sz="1500" dirty="0">
-                <a:solidFill>
-                  <a:srgbClr val="0F172A"/>
-                </a:solidFill>
-                <a:latin typeface="Helvetica Neue" pitchFamily="34" charset="0"/>
-                <a:ea typeface="Helvetica Neue" pitchFamily="34" charset="-122"/>
-                <a:cs typeface="Helvetica Neue" pitchFamily="34" charset="-120"/>
-              </a:rPr>
-              <a:t>倫理：API 金鑰只在本機；此原型不對用戶上傳做訓練。</a:t>
-            </a:r>
-            <a:endParaRPr lang="en-US" sz="1600" dirty="0"/>
-          </a:p>
-        </p:txBody>
-      </p:sp>
-    </p:spTree>
-  </p:cSld>
-  <p:clrMapOvr>
-    <a:masterClrMapping/>
-  </p:clrMapOvr>
-</p:sld>
-</file>
-
-<file path=ppt/slides/slide9.xml><?xml version="1.0" encoding="utf-8"?>
-<p:sld xmlns:a="http://schemas.openxmlformats.org/drawingml/2006/main" xmlns:r="http://schemas.openxmlformats.org/officeDocument/2006/relationships" xmlns:p="http://schemas.openxmlformats.org/presentationml/2006/main">
-  <p:cSld name="Slide 9">
-    <p:bg>
-      <p:bgPr>
-        <a:solidFill>
-          <a:srgbClr val="F8FAFC"/>
-        </a:solidFill>
-      </p:bgPr>
-    </p:bg>
-    <p:spTree>
-      <p:nvGrpSpPr>
-        <p:cNvPr id="1" name=""/>
-        <p:cNvGrpSpPr/>
-        <p:nvPr/>
-      </p:nvGrpSpPr>
-      <p:grpSpPr>
-        <a:xfrm>
-          <a:off x="0" y="0"/>
-          <a:ext cx="0" cy="0"/>
-          <a:chOff x="0" y="0"/>
-          <a:chExt cx="0" cy="0"/>
-        </a:xfrm>
-      </p:grpSpPr>
-      <p:sp>
-        <p:nvSpPr>
-          <p:cNvPr id="2" name="Text 0"/>
-          <p:cNvSpPr/>
-          <p:nvPr/>
-        </p:nvSpPr>
-        <p:spPr>
-          <a:xfrm>
-            <a:off x="548640" y="411480"/>
-            <a:ext cx="8046720" cy="777240"/>
-          </a:xfrm>
-          <a:prstGeom prst="rect">
-            <a:avLst/>
-          </a:prstGeom>
-          <a:noFill/>
-          <a:ln/>
-        </p:spPr>
-        <p:txBody>
-          <a:bodyPr wrap="square" rtlCol="0" anchor="ctr"/>
-          <a:lstStyle/>
-          <a:p>
-            <a:pPr indent="0" marL="0">
-              <a:buNone/>
-            </a:pPr>
-            <a:r>
-              <a:rPr lang="en-US" sz="2800" b="1" dirty="0">
-                <a:solidFill>
-                  <a:srgbClr val="4F46E5"/>
-                </a:solidFill>
-                <a:latin typeface="Helvetica Neue" pitchFamily="34" charset="0"/>
-                <a:ea typeface="Helvetica Neue" pitchFamily="34" charset="-122"/>
-                <a:cs typeface="Helvetica Neue" pitchFamily="34" charset="-120"/>
-              </a:rPr>
-              <a:t>Appendix: Tech 技術附錄</a:t>
-            </a:r>
-            <a:endParaRPr lang="en-US" sz="2800" dirty="0"/>
-          </a:p>
-        </p:txBody>
-      </p:sp>
-      <p:sp>
-        <p:nvSpPr>
-          <p:cNvPr id="3" name="Text 1"/>
-          <p:cNvSpPr/>
-          <p:nvPr/>
-        </p:nvSpPr>
-        <p:spPr>
-          <a:xfrm>
-            <a:off x="548640" y="1051560"/>
-            <a:ext cx="8046720" cy="365760"/>
-          </a:xfrm>
-          <a:prstGeom prst="rect">
-            <a:avLst/>
-          </a:prstGeom>
-          <a:noFill/>
-          <a:ln/>
-        </p:spPr>
-        <p:txBody>
-          <a:bodyPr wrap="square" rtlCol="0" anchor="ctr"/>
-          <a:lstStyle/>
-          <a:p>
-            <a:pPr indent="0" marL="0">
-              <a:buNone/>
-            </a:pPr>
-            <a:r>
-              <a:rPr lang="en-US" sz="1300" dirty="0">
-                <a:solidFill>
-                  <a:srgbClr val="64748B"/>
-                </a:solidFill>
-                <a:latin typeface="Helvetica Neue" pitchFamily="34" charset="0"/>
-                <a:ea typeface="Helvetica Neue" pitchFamily="34" charset="-122"/>
-                <a:cs typeface="Helvetica Neue" pitchFamily="34" charset="-120"/>
-              </a:rPr>
-              <a:t>Brief — grading focus stays on design</a:t>
-            </a:r>
-            <a:endParaRPr lang="en-US" sz="1300" dirty="0"/>
-          </a:p>
-        </p:txBody>
-      </p:sp>
-      <p:sp>
-        <p:nvSpPr>
-          <p:cNvPr id="4" name="Text 2"/>
-          <p:cNvSpPr/>
-          <p:nvPr/>
-        </p:nvSpPr>
-        <p:spPr>
-          <a:xfrm>
-            <a:off x="548640" y="1600200"/>
-            <a:ext cx="8046720" cy="2926080"/>
-          </a:xfrm>
-          <a:prstGeom prst="rect">
-            <a:avLst/>
-          </a:prstGeom>
-          <a:noFill/>
-          <a:ln/>
-        </p:spPr>
-        <p:txBody>
-          <a:bodyPr wrap="square" rtlCol="0" anchor="ctr"/>
-          <a:lstStyle/>
-          <a:p>
-            <a:pPr marL="342900" indent="-342900">
-              <a:lnSpc>
-                <a:spcPct val="115000"/>
-              </a:lnSpc>
-              <a:buSzPct val="100000"/>
-              <a:buChar char="•"/>
-            </a:pPr>
-            <a:r>
-              <a:rPr lang="en-US" sz="1600" dirty="0">
-                <a:solidFill>
-                  <a:srgbClr val="0F172A"/>
-                </a:solidFill>
-                <a:latin typeface="Helvetica Neue" pitchFamily="34" charset="0"/>
-                <a:ea typeface="Helvetica Neue" pitchFamily="34" charset="-122"/>
-                <a:cs typeface="Helvetica Neue" pitchFamily="34" charset="-120"/>
-              </a:rPr>
-              <a:t>Stack: Next.js, Tailwind, Zustand; optional Gemini for copy / vision / order.</a:t>
-            </a:r>
-            <a:endParaRPr lang="en-US" sz="1600" dirty="0"/>
-          </a:p>
-          <a:p>
-            <a:pPr marL="342900" indent="-342900">
-              <a:lnSpc>
-                <a:spcPct val="115000"/>
-              </a:lnSpc>
-              <a:buSzPct val="100000"/>
-              <a:buChar char="•"/>
-            </a:pPr>
-            <a:r>
-              <a:rPr lang="en-US" sz="1600" dirty="0">
-                <a:solidFill>
-                  <a:srgbClr val="0F172A"/>
-                </a:solidFill>
-                <a:latin typeface="Helvetica Neue" pitchFamily="34" charset="0"/>
-                <a:ea typeface="Helvetica Neue" pitchFamily="34" charset="-122"/>
-                <a:cs typeface="Helvetica Neue" pitchFamily="34" charset="-120"/>
-              </a:rPr>
-              <a:t>API: Google AI Studio https://aistudio.google.com/apikey</a:t>
-            </a:r>
-            <a:endParaRPr lang="en-US" sz="1600" dirty="0"/>
-          </a:p>
-          <a:p>
-            <a:pPr marL="342900" indent="-342900">
-              <a:lnSpc>
-                <a:spcPct val="115000"/>
-              </a:lnSpc>
-              <a:buSzPct val="100000"/>
-              <a:buChar char="•"/>
-            </a:pPr>
-            <a:r>
-              <a:rPr lang="en-US" sz="1600" dirty="0">
-                <a:solidFill>
-                  <a:srgbClr val="0F172A"/>
-                </a:solidFill>
-                <a:latin typeface="Helvetica Neue" pitchFamily="34" charset="0"/>
-                <a:ea typeface="Helvetica Neue" pitchFamily="34" charset="-122"/>
-                <a:cs typeface="Helvetica Neue" pitchFamily="34" charset="-120"/>
-              </a:rPr>
-              <a:t>Docs: https://ai.google.dev/gemini-api/docs</a:t>
-            </a:r>
-            <a:endParaRPr lang="en-US" sz="1600" dirty="0"/>
-          </a:p>
-          <a:p>
-            <a:pPr marL="342900" indent="-342900">
-              <a:lnSpc>
-                <a:spcPct val="115000"/>
-              </a:lnSpc>
-              <a:buSzPct val="100000"/>
-              <a:buChar char="•"/>
-            </a:pPr>
-            <a:r>
-              <a:rPr lang="en-US" sz="1600" dirty="0">
-                <a:solidFill>
-                  <a:srgbClr val="0F172A"/>
-                </a:solidFill>
-                <a:latin typeface="Helvetica Neue" pitchFamily="34" charset="0"/>
-                <a:ea typeface="Helvetica Neue" pitchFamily="34" charset="-122"/>
-                <a:cs typeface="Helvetica Neue" pitchFamily="34" charset="-120"/>
-              </a:rPr>
-              <a:t>Repo: github.com/macaumonsoon/Portfolio-ReStyle-AI</a:t>
-            </a:r>
-            <a:endParaRPr lang="en-US" sz="1600" dirty="0"/>
-          </a:p>
-        </p:txBody>
-      </p:sp>
-    </p:spTree>
-  </p:cSld>
-  <p:clrMapOvr>
-    <a:masterClrMapping/>
-  </p:clrMapOvr>
-</p:sld>
-</file>
-
 <file path=ppt/theme/theme1.xml><?xml version="1.0" encoding="utf-8"?>
 <a:theme xmlns:a="http://schemas.openxmlformats.org/drawingml/2006/main" name="Office Theme">
   <a:themeElements>

</xml_diff>

<commit_message>
fix(presentation): ensure bilingual pairing on slide text
Made-with: Cursor
</commit_message>
<xml_diff>
--- a/presentation/Portfolio-ReStyle-AI-Design-Deck.pptx
+++ b/presentation/Portfolio-ReStyle-AI-Design-Deck.pptx
@@ -2216,7 +2216,7 @@
                 <a:ea typeface="Helvetica Neue" pitchFamily="34" charset="-122"/>
                 <a:cs typeface="Helvetica Neue" pitchFamily="34" charset="-120"/>
               </a:rPr>
-              <a:t>1. Show language toggle（中文 ↔ English）。</a:t>
+              <a:t>1. Show language toggle（中文 ↔ English）。/ 展示雙語切換（中文 ↔ English）。</a:t>
             </a:r>
             <a:endParaRPr lang="en-US" sz="1400" dirty="0"/>
           </a:p>
@@ -2236,7 +2236,7 @@
                 <a:ea typeface="Helvetica Neue" pitchFamily="34" charset="-122"/>
                 <a:cs typeface="Helvetica Neue" pitchFamily="34" charset="-120"/>
               </a:rPr>
-              <a:t>2. Upload SVG/PDF：在 Options dock 改色系/风格/网格并观察层级变化。</a:t>
+              <a:t>2. Upload SVG/PDF and change palette/style/grid in the Options dock. / 上傳 SVG/PDF 並在 Options dock 改色系/風格/網格。</a:t>
             </a:r>
             <a:endParaRPr lang="en-US" sz="1400" dirty="0"/>
           </a:p>
@@ -2256,7 +2256,7 @@
                 <a:ea typeface="Helvetica Neue" pitchFamily="34" charset="-122"/>
                 <a:cs typeface="Helvetica Neue" pitchFamily="34" charset="-120"/>
               </a:rPr>
-              <a:t>3. Use Before/After：分开看色相滤镜 vs 版式位移。</a:t>
+              <a:t>3. Use Before/After to separate hue decisions from layout decisions. / 使用 Before/After 分開看色相決策與版式決策。</a:t>
             </a:r>
             <a:endParaRPr lang="en-US" sz="1400" dirty="0"/>
           </a:p>
@@ -2276,7 +2276,7 @@
                 <a:ea typeface="Helvetica Neue" pitchFamily="34" charset="-122"/>
                 <a:cs typeface="Helvetica Neue" pitchFamily="34" charset="-120"/>
               </a:rPr>
-              <a:t>4. Select one variant per page（含 1×2 / 2×1 非对称预设）。</a:t>
+              <a:t>4. Select one variant per page (including 1×2 / 2×1 asymmetric presets). / 每頁選一個版本（含 1×2 / 2×1 非對稱預設）。</a:t>
             </a:r>
             <a:endParaRPr lang="en-US" sz="1400" dirty="0"/>
           </a:p>
@@ -2296,7 +2296,7 @@
                 <a:ea typeface="Helvetica Neue" pitchFamily="34" charset="-122"/>
                 <a:cs typeface="Helvetica Neue" pitchFamily="34" charset="-120"/>
               </a:rPr>
-              <a:t>5. Export：合并 PDF + 每页 SVG（方便继续排版与微调）。</a:t>
+              <a:t>5. Export merged PDF + per-page SVG for further refinement. / 匯出合併 PDF + 每頁 SVG 供後續精修。</a:t>
             </a:r>
             <a:endParaRPr lang="en-US" sz="1400" dirty="0"/>
           </a:p>
@@ -2449,7 +2449,7 @@
                 <a:ea typeface="Helvetica Neue" pitchFamily="34" charset="-122"/>
                 <a:cs typeface="Helvetica Neue" pitchFamily="34" charset="-120"/>
               </a:rPr>
-              <a:t>What worked: clear type hierarchy + stable dock preview for confident decisions.</a:t>
+              <a:t>What worked: clear type hierarchy + stable dock preview for confident decisions. / 有效之處：清晰字體層級 + 穩定 dock 預覽，讓決策更有把握。</a:t>
             </a:r>
             <a:endParaRPr lang="en-US" sz="1600" dirty="0"/>
           </a:p>
@@ -2470,7 +2470,7 @@
                 <a:ea typeface="Helvetica Neue" pitchFamily="34" charset="-122"/>
                 <a:cs typeface="Helvetica Neue" pitchFamily="34" charset="-120"/>
               </a:rPr>
-              <a:t>有效之處：清晰字體層級 + 穩定 dock 預覽，讓決策更有把握。</a:t>
+              <a:t>What to improve: finer typography controls and more layout-ready components. / 接續改進：更細字體控制與更多可直接用的版面元件。</a:t>
             </a:r>
             <a:endParaRPr lang="en-US" sz="1600" dirty="0"/>
           </a:p>
@@ -2483,7 +2483,7 @@
               <a:buChar char="•"/>
             </a:pPr>
             <a:r>
-              <a:rPr lang="en-US" sz="1600" dirty="0">
+              <a:rPr lang="en-US" sz="1500" dirty="0">
                 <a:solidFill>
                   <a:srgbClr val="0F172A"/>
                 </a:solidFill>
@@ -2491,70 +2491,7 @@
                 <a:ea typeface="Helvetica Neue" pitchFamily="34" charset="-122"/>
                 <a:cs typeface="Helvetica Neue" pitchFamily="34" charset="-120"/>
               </a:rPr>
-              <a:t>What to improve: finer typography controls and more layout-ready components.</a:t>
-            </a:r>
-            <a:endParaRPr lang="en-US" sz="1600" dirty="0"/>
-          </a:p>
-          <a:p>
-            <a:pPr marL="342900" indent="-342900">
-              <a:lnSpc>
-                <a:spcPct val="115000"/>
-              </a:lnSpc>
-              <a:buSzPct val="100000"/>
-              <a:buChar char="•"/>
-            </a:pPr>
-            <a:r>
-              <a:rPr lang="en-US" sz="1500" dirty="0">
-                <a:solidFill>
-                  <a:srgbClr val="0F172A"/>
-                </a:solidFill>
-                <a:latin typeface="Helvetica Neue" pitchFamily="34" charset="0"/>
-                <a:ea typeface="Helvetica Neue" pitchFamily="34" charset="-122"/>
-                <a:cs typeface="Helvetica Neue" pitchFamily="34" charset="-120"/>
-              </a:rPr>
-              <a:t>接續改進：更細字體控制與更多可直接用的版面元件。</a:t>
-            </a:r>
-            <a:endParaRPr lang="en-US" sz="1600" dirty="0"/>
-          </a:p>
-          <a:p>
-            <a:pPr marL="342900" indent="-342900">
-              <a:lnSpc>
-                <a:spcPct val="115000"/>
-              </a:lnSpc>
-              <a:buSzPct val="100000"/>
-              <a:buChar char="•"/>
-            </a:pPr>
-            <a:r>
-              <a:rPr lang="en-US" sz="1600" dirty="0">
-                <a:solidFill>
-                  <a:srgbClr val="0F172A"/>
-                </a:solidFill>
-                <a:latin typeface="Helvetica Neue" pitchFamily="34" charset="0"/>
-                <a:ea typeface="Helvetica Neue" pitchFamily="34" charset="-122"/>
-                <a:cs typeface="Helvetica Neue" pitchFamily="34" charset="-120"/>
-              </a:rPr>
-              <a:t>Ethics: API keys only in .env.local; no training on user uploads in this prototype.</a:t>
-            </a:r>
-            <a:endParaRPr lang="en-US" sz="1600" dirty="0"/>
-          </a:p>
-          <a:p>
-            <a:pPr marL="342900" indent="-342900">
-              <a:lnSpc>
-                <a:spcPct val="115000"/>
-              </a:lnSpc>
-              <a:buSzPct val="100000"/>
-              <a:buChar char="•"/>
-            </a:pPr>
-            <a:r>
-              <a:rPr lang="en-US" sz="1500" dirty="0">
-                <a:solidFill>
-                  <a:srgbClr val="0F172A"/>
-                </a:solidFill>
-                <a:latin typeface="Helvetica Neue" pitchFamily="34" charset="0"/>
-                <a:ea typeface="Helvetica Neue" pitchFamily="34" charset="-122"/>
-                <a:cs typeface="Helvetica Neue" pitchFamily="34" charset="-120"/>
-              </a:rPr>
-              <a:t>倫理：API 金鑰只在本機；此原型不對用戶上傳做訓練。</a:t>
+              <a:t>Ethics: API keys only in .env.local; no training on user uploads in this prototype. / 倫理：API 金鑰只在本機；此原型不對用戶上傳做訓練。</a:t>
             </a:r>
             <a:endParaRPr lang="en-US" sz="1600" dirty="0"/>
           </a:p>
@@ -2707,7 +2644,7 @@
                 <a:ea typeface="Helvetica Neue" pitchFamily="34" charset="-122"/>
                 <a:cs typeface="Helvetica Neue" pitchFamily="34" charset="-120"/>
               </a:rPr>
-              <a:t>Stack: Next.js, Tailwind, Zustand; optional Gemini for copy / vision / order.</a:t>
+              <a:t>Stack: Next.js, Tailwind, Zustand; optional Gemini for copy / vision / order. / 技術：Next.js、Tailwind、Zustand；可選 Gemini 用於文案/視覺/排序。</a:t>
             </a:r>
             <a:endParaRPr lang="en-US" sz="1600" dirty="0"/>
           </a:p>
@@ -2728,7 +2665,7 @@
                 <a:ea typeface="Helvetica Neue" pitchFamily="34" charset="-122"/>
                 <a:cs typeface="Helvetica Neue" pitchFamily="34" charset="-120"/>
               </a:rPr>
-              <a:t>API: Google AI Studio https://aistudio.google.com/apikey</a:t>
+              <a:t>API: Google AI Studio https://aistudio.google.com/apikey / API：Google AI Studio（https://aistudio.google.com/apikey）</a:t>
             </a:r>
             <a:endParaRPr lang="en-US" sz="1600" dirty="0"/>
           </a:p>
@@ -2749,7 +2686,7 @@
                 <a:ea typeface="Helvetica Neue" pitchFamily="34" charset="-122"/>
                 <a:cs typeface="Helvetica Neue" pitchFamily="34" charset="-120"/>
               </a:rPr>
-              <a:t>Docs: https://ai.google.dev/gemini-api/docs</a:t>
+              <a:t>Docs: https://ai.google.dev/gemini-api/docs / 文件：https://ai.google.dev/gemini-api/docs</a:t>
             </a:r>
             <a:endParaRPr lang="en-US" sz="1600" dirty="0"/>
           </a:p>
@@ -2770,7 +2707,7 @@
                 <a:ea typeface="Helvetica Neue" pitchFamily="34" charset="-122"/>
                 <a:cs typeface="Helvetica Neue" pitchFamily="34" charset="-120"/>
               </a:rPr>
-              <a:t>Repo: github.com/macaumonsoon/Portfolio-ReStyle-AI</a:t>
+              <a:t>Repo: github.com/macaumonsoon/Portfolio-ReStyle-AI / 專案程式庫：https://github.com/macaumonsoon/Portfolio-ReStyle-AI</a:t>
             </a:r>
             <a:endParaRPr lang="en-US" sz="1600" dirty="0"/>
           </a:p>
@@ -2923,7 +2860,7 @@
                 <a:ea typeface="Helvetica Neue" pitchFamily="34" charset="-122"/>
                 <a:cs typeface="Helvetica Neue" pitchFamily="34" charset="-120"/>
               </a:rPr>
-              <a:t>Portfolios are narrative + craft—not only pretty pictures.</a:t>
+              <a:t>Portfolios are narrative + craft—not only pretty pictures. / 作品集是敘事與工藝，不只是漂亮畫面。</a:t>
             </a:r>
             <a:endParaRPr lang="en-US" sz="1600" dirty="0"/>
           </a:p>
@@ -2944,7 +2881,7 @@
                 <a:ea typeface="Helvetica Neue" pitchFamily="34" charset="-122"/>
                 <a:cs typeface="Helvetica Neue" pitchFamily="34" charset="-120"/>
               </a:rPr>
-              <a:t>作品集是敘事與工藝，不只是漂亮畫面。</a:t>
+              <a:t>Restructuring order, grid, and tone is repetitive; it steals time from concept work. / 重排順序、網格、色調很耗時，擠壓概念發想時間。</a:t>
             </a:r>
             <a:endParaRPr lang="en-US" sz="1600" dirty="0"/>
           </a:p>
@@ -2957,7 +2894,7 @@
               <a:buChar char="•"/>
             </a:pPr>
             <a:r>
-              <a:rPr lang="en-US" sz="1600" dirty="0">
+              <a:rPr lang="en-US" sz="1500" dirty="0">
                 <a:solidFill>
                   <a:srgbClr val="0F172A"/>
                 </a:solidFill>
@@ -2965,70 +2902,7 @@
                 <a:ea typeface="Helvetica Neue" pitchFamily="34" charset="-122"/>
                 <a:cs typeface="Helvetica Neue" pitchFamily="34" charset="-120"/>
               </a:rPr>
-              <a:t>Restructuring order, grid, and tone is repetitive; it steals time from concept work.</a:t>
-            </a:r>
-            <a:endParaRPr lang="en-US" sz="1600" dirty="0"/>
-          </a:p>
-          <a:p>
-            <a:pPr marL="342900" indent="-342900">
-              <a:lnSpc>
-                <a:spcPct val="115000"/>
-              </a:lnSpc>
-              <a:buSzPct val="100000"/>
-              <a:buChar char="•"/>
-            </a:pPr>
-            <a:r>
-              <a:rPr lang="en-US" sz="1500" dirty="0">
-                <a:solidFill>
-                  <a:srgbClr val="0F172A"/>
-                </a:solidFill>
-                <a:latin typeface="Helvetica Neue" pitchFamily="34" charset="0"/>
-                <a:ea typeface="Helvetica Neue" pitchFamily="34" charset="-122"/>
-                <a:cs typeface="Helvetica Neue" pitchFamily="34" charset="-120"/>
-              </a:rPr>
-              <a:t>重排順序、網格、色調很耗時，擠壓概念發想時間。</a:t>
-            </a:r>
-            <a:endParaRPr lang="en-US" sz="1600" dirty="0"/>
-          </a:p>
-          <a:p>
-            <a:pPr marL="342900" indent="-342900">
-              <a:lnSpc>
-                <a:spcPct val="115000"/>
-              </a:lnSpc>
-              <a:buSzPct val="100000"/>
-              <a:buChar char="•"/>
-            </a:pPr>
-            <a:r>
-              <a:rPr lang="en-US" sz="1600" dirty="0">
-                <a:solidFill>
-                  <a:srgbClr val="0F172A"/>
-                </a:solidFill>
-                <a:latin typeface="Helvetica Neue" pitchFamily="34" charset="0"/>
-                <a:ea typeface="Helvetica Neue" pitchFamily="34" charset="-122"/>
-                <a:cs typeface="Helvetica Neue" pitchFamily="34" charset="-120"/>
-              </a:rPr>
-              <a:t>We need a tool that assists without replacing designer judgment.</a:t>
-            </a:r>
-            <a:endParaRPr lang="en-US" sz="1600" dirty="0"/>
-          </a:p>
-          <a:p>
-            <a:pPr marL="342900" indent="-342900">
-              <a:lnSpc>
-                <a:spcPct val="115000"/>
-              </a:lnSpc>
-              <a:buSzPct val="100000"/>
-              <a:buChar char="•"/>
-            </a:pPr>
-            <a:r>
-              <a:rPr lang="en-US" sz="1500" dirty="0">
-                <a:solidFill>
-                  <a:srgbClr val="0F172A"/>
-                </a:solidFill>
-                <a:latin typeface="Helvetica Neue" pitchFamily="34" charset="0"/>
-                <a:ea typeface="Helvetica Neue" pitchFamily="34" charset="-122"/>
-                <a:cs typeface="Helvetica Neue" pitchFamily="34" charset="-120"/>
-              </a:rPr>
-              <a:t>需要「輔助」設計師判斷的工具，而非取代。</a:t>
+              <a:t>We need a tool that assists without replacing designer judgment. / 需要「輔助」設計師判斷的工具，而非取代。</a:t>
             </a:r>
             <a:endParaRPr lang="en-US" sz="1600" dirty="0"/>
           </a:p>
@@ -3181,7 +3055,7 @@
                 <a:ea typeface="Helvetica Neue" pitchFamily="34" charset="-122"/>
                 <a:cs typeface="Helvetica Neue" pitchFamily="34" charset="-120"/>
               </a:rPr>
-              <a:t>Re-interpret SVG/PDF with clear intent: palette, style, canvas, narrative order.</a:t>
+              <a:t>Re-interpret SVG/PDF with clear intent: palette, style, canvas, narrative order. / 以色系、風格、畫布、敘事順序重新詮釋既有稿件。</a:t>
             </a:r>
             <a:endParaRPr lang="en-US" sz="1600" dirty="0"/>
           </a:p>
@@ -3202,7 +3076,7 @@
                 <a:ea typeface="Helvetica Neue" pitchFamily="34" charset="-122"/>
                 <a:cs typeface="Helvetica Neue" pitchFamily="34" charset="-120"/>
               </a:rPr>
-              <a:t>以色系、風格、畫布、敘事順序重新詮釋既有稿件。</a:t>
+              <a:t>Three variants per page → designer chooses (studio critique loop). / 每頁三種版本 → 設計師選擇，貼近工作室評圖流程。</a:t>
             </a:r>
             <a:endParaRPr lang="en-US" sz="1600" dirty="0"/>
           </a:p>
@@ -3215,7 +3089,7 @@
               <a:buChar char="•"/>
             </a:pPr>
             <a:r>
-              <a:rPr lang="en-US" sz="1600" dirty="0">
+              <a:rPr lang="en-US" sz="1500" dirty="0">
                 <a:solidFill>
                   <a:srgbClr val="0F172A"/>
                 </a:solidFill>
@@ -3223,70 +3097,7 @@
                 <a:ea typeface="Helvetica Neue" pitchFamily="34" charset="-122"/>
                 <a:cs typeface="Helvetica Neue" pitchFamily="34" charset="-120"/>
               </a:rPr>
-              <a:t>Three variants per page → designer chooses (studio critique loop).</a:t>
-            </a:r>
-            <a:endParaRPr lang="en-US" sz="1600" dirty="0"/>
-          </a:p>
-          <a:p>
-            <a:pPr marL="342900" indent="-342900">
-              <a:lnSpc>
-                <a:spcPct val="115000"/>
-              </a:lnSpc>
-              <a:buSzPct val="100000"/>
-              <a:buChar char="•"/>
-            </a:pPr>
-            <a:r>
-              <a:rPr lang="en-US" sz="1500" dirty="0">
-                <a:solidFill>
-                  <a:srgbClr val="0F172A"/>
-                </a:solidFill>
-                <a:latin typeface="Helvetica Neue" pitchFamily="34" charset="0"/>
-                <a:ea typeface="Helvetica Neue" pitchFamily="34" charset="-122"/>
-                <a:cs typeface="Helvetica Neue" pitchFamily="34" charset="-120"/>
-              </a:rPr>
-              <a:t>每頁三種版本 → 設計師選擇，貼近工作室評圖流程。</a:t>
-            </a:r>
-            <a:endParaRPr lang="en-US" sz="1600" dirty="0"/>
-          </a:p>
-          <a:p>
-            <a:pPr marL="342900" indent="-342900">
-              <a:lnSpc>
-                <a:spcPct val="115000"/>
-              </a:lnSpc>
-              <a:buSzPct val="100000"/>
-              <a:buChar char="•"/>
-            </a:pPr>
-            <a:r>
-              <a:rPr lang="en-US" sz="1600" dirty="0">
-                <a:solidFill>
-                  <a:srgbClr val="0F172A"/>
-                </a:solidFill>
-                <a:latin typeface="Helvetica Neue" pitchFamily="34" charset="0"/>
-                <a:ea typeface="Helvetica Neue" pitchFamily="34" charset="-122"/>
-                <a:cs typeface="Helvetica Neue" pitchFamily="34" charset="-120"/>
-              </a:rPr>
-              <a:t>Export SVG (edit further) or merged PDF (share / print).</a:t>
-            </a:r>
-            <a:endParaRPr lang="en-US" sz="1600" dirty="0"/>
-          </a:p>
-          <a:p>
-            <a:pPr marL="342900" indent="-342900">
-              <a:lnSpc>
-                <a:spcPct val="115000"/>
-              </a:lnSpc>
-              <a:buSzPct val="100000"/>
-              <a:buChar char="•"/>
-            </a:pPr>
-            <a:r>
-              <a:rPr lang="en-US" sz="1500" dirty="0">
-                <a:solidFill>
-                  <a:srgbClr val="0F172A"/>
-                </a:solidFill>
-                <a:latin typeface="Helvetica Neue" pitchFamily="34" charset="0"/>
-                <a:ea typeface="Helvetica Neue" pitchFamily="34" charset="-122"/>
-                <a:cs typeface="Helvetica Neue" pitchFamily="34" charset="-120"/>
-              </a:rPr>
-              <a:t>匯出向量 SVG 或合併 PDF，便於再編輯與交付。</a:t>
+              <a:t>Export SVG (edit further) or merged PDF (share / print). / 匯出向量 SVG 或合併 PDF，便於再編輯與交付。</a:t>
             </a:r>
             <a:endParaRPr lang="en-US" sz="1600" dirty="0"/>
           </a:p>
@@ -3448,7 +3259,7 @@
           <a:p>
             <a:pPr indent="0" marL="0">
               <a:lnSpc>
-                <a:spcPct val="107000"/>
+                <a:spcPct val="105000"/>
               </a:lnSpc>
               <a:buNone/>
             </a:pPr>
@@ -3465,12 +3276,12 @@
             </a:r>
             <a:pPr indent="0" marL="0">
               <a:lnSpc>
-                <a:spcPct val="107000"/>
+                <a:spcPct val="105000"/>
               </a:lnSpc>
               <a:buNone/>
             </a:pPr>
             <a:r>
-              <a:rPr lang="en-US" sz="1400" dirty="0">
+              <a:rPr lang="en-US" sz="1300" dirty="0">
                 <a:solidFill>
                   <a:srgbClr val="0F172A"/>
                 </a:solidFill>
@@ -3478,16 +3289,16 @@
                 <a:ea typeface="Helvetica Neue" pitchFamily="34" charset="-122"/>
                 <a:cs typeface="Helvetica Neue" pitchFamily="34" charset="-120"/>
               </a:rPr>
-              <a:t>• SVG：直接導入並分頁</a:t>
+              <a:t>• SVG：直接導入並分頁 (SVG import &amp; page split)</a:t>
             </a:r>
             <a:pPr indent="0" marL="0">
               <a:lnSpc>
-                <a:spcPct val="107000"/>
+                <a:spcPct val="105000"/>
               </a:lnSpc>
               <a:buNone/>
             </a:pPr>
             <a:r>
-              <a:rPr lang="en-US" sz="1400" dirty="0">
+              <a:rPr lang="en-US" sz="1300" dirty="0">
                 <a:solidFill>
                   <a:srgbClr val="0F172A"/>
                 </a:solidFill>
@@ -3495,16 +3306,16 @@
                 <a:ea typeface="Helvetica Neue" pitchFamily="34" charset="-122"/>
                 <a:cs typeface="Helvetica Neue" pitchFamily="34" charset="-120"/>
               </a:rPr>
-              <a:t>• PDF：pdf.js 逐頁渲染，抽取文字座標（可在 Pages 編輯文字）</a:t>
+              <a:t>• PDF：pdf.js 逐頁渲染 + 抽取文字座標 (render &amp; extract text coords)</a:t>
             </a:r>
             <a:pPr indent="0" marL="0">
               <a:lnSpc>
-                <a:spcPct val="107000"/>
+                <a:spcPct val="105000"/>
               </a:lnSpc>
               <a:buNone/>
             </a:pPr>
             <a:r>
-              <a:rPr lang="en-US" sz="1400" dirty="0">
+              <a:rPr lang="en-US" sz="1300" dirty="0">
                 <a:solidFill>
                   <a:srgbClr val="0F172A"/>
                 </a:solidFill>
@@ -3512,7 +3323,7 @@
                 <a:ea typeface="Helvetica Neue" pitchFamily="34" charset="-122"/>
                 <a:cs typeface="Helvetica Neue" pitchFamily="34" charset="-120"/>
               </a:rPr>
-              <a:t>目標：把作品轉成可重排、可選擇的結構。</a:t>
+              <a:t>目標：可重排、可選擇的結構 (structure for remix)</a:t>
             </a:r>
             <a:endParaRPr lang="en-US" sz="1600" dirty="0"/>
           </a:p>
@@ -3674,7 +3485,7 @@
           <a:p>
             <a:pPr indent="0" marL="0">
               <a:lnSpc>
-                <a:spcPct val="107000"/>
+                <a:spcPct val="105000"/>
               </a:lnSpc>
               <a:buNone/>
             </a:pPr>
@@ -3691,12 +3502,12 @@
             </a:r>
             <a:pPr indent="0" marL="0">
               <a:lnSpc>
-                <a:spcPct val="107000"/>
+                <a:spcPct val="105000"/>
               </a:lnSpc>
               <a:buNone/>
             </a:pPr>
             <a:r>
-              <a:rPr lang="en-US" sz="1400" dirty="0">
+              <a:rPr lang="en-US" sz="1300" dirty="0">
                 <a:solidFill>
                   <a:srgbClr val="0F172A"/>
                 </a:solidFill>
@@ -3704,16 +3515,16 @@
                 <a:ea typeface="Helvetica Neue" pitchFamily="34" charset="-122"/>
                 <a:cs typeface="Helvetica Neue" pitchFamily="34" charset="-120"/>
               </a:rPr>
-              <a:t>• 色系 + 風格關鍵詞：即時濾鏡/字色方向</a:t>
+              <a:t>• 色系 + 風格關鍵詞：即時濾鏡/字色方向 (live palette/style filters)</a:t>
             </a:r>
             <a:pPr indent="0" marL="0">
               <a:lnSpc>
-                <a:spcPct val="107000"/>
+                <a:spcPct val="105000"/>
               </a:lnSpc>
               <a:buNone/>
             </a:pPr>
             <a:r>
-              <a:rPr lang="en-US" sz="1400" dirty="0">
+              <a:rPr lang="en-US" sz="1300" dirty="0">
                 <a:solidFill>
                   <a:srgbClr val="0F172A"/>
                 </a:solidFill>
@@ -3721,16 +3532,16 @@
                 <a:ea typeface="Helvetica Neue" pitchFamily="34" charset="-122"/>
                 <a:cs typeface="Helvetica Neue" pitchFamily="34" charset="-120"/>
               </a:rPr>
-              <a:t>• 畫布尺寸 + 敘事邏輯：影響版面比例與頁序</a:t>
+              <a:t>• 畫布尺寸 + 敘事邏輯：影響比例與頁序 (canvas &amp; narrative ordering)</a:t>
             </a:r>
             <a:pPr indent="0" marL="0">
               <a:lnSpc>
-                <a:spcPct val="107000"/>
+                <a:spcPct val="105000"/>
               </a:lnSpc>
               <a:buNone/>
             </a:pPr>
             <a:r>
-              <a:rPr lang="en-US" sz="1400" dirty="0">
+              <a:rPr lang="en-US" sz="1300" dirty="0">
                 <a:solidFill>
                   <a:srgbClr val="0F172A"/>
                 </a:solidFill>
@@ -3738,16 +3549,16 @@
                 <a:ea typeface="Helvetica Neue" pitchFamily="34" charset="-122"/>
                 <a:cs typeface="Helvetica Neue" pitchFamily="34" charset="-120"/>
               </a:rPr>
-              <a:t>• 可選網格重排 + 網格塊微調：拖曳寫入讓構圖可控</a:t>
+              <a:t>• 網格重排 + tile 微調：拖曳寫入構圖 (grid remix + tile nudge)</a:t>
             </a:r>
             <a:pPr indent="0" marL="0">
               <a:lnSpc>
-                <a:spcPct val="107000"/>
+                <a:spcPct val="105000"/>
               </a:lnSpc>
               <a:buNone/>
             </a:pPr>
             <a:r>
-              <a:rPr lang="en-US" sz="1400" dirty="0">
+              <a:rPr lang="en-US" sz="1300" dirty="0">
                 <a:solidFill>
                   <a:srgbClr val="0F172A"/>
                 </a:solidFill>
@@ -3755,7 +3566,7 @@
                 <a:ea typeface="Helvetica Neue" pitchFamily="34" charset="-122"/>
                 <a:cs typeface="Helvetica Neue" pitchFamily="34" charset="-120"/>
               </a:rPr>
-              <a:t>目標：讓設計方向可視化、可比較、可迭代。</a:t>
+              <a:t>目標：可視化方向、可比較、可迭代 (visual, compare, iterate)</a:t>
             </a:r>
             <a:endParaRPr lang="en-US" sz="1600" dirty="0"/>
           </a:p>
@@ -3917,7 +3728,7 @@
           <a:p>
             <a:pPr indent="0" marL="0">
               <a:lnSpc>
-                <a:spcPct val="107000"/>
+                <a:spcPct val="105000"/>
               </a:lnSpc>
               <a:buNone/>
             </a:pPr>
@@ -3934,12 +3745,12 @@
             </a:r>
             <a:pPr indent="0" marL="0">
               <a:lnSpc>
-                <a:spcPct val="107000"/>
+                <a:spcPct val="105000"/>
               </a:lnSpc>
               <a:buNone/>
             </a:pPr>
             <a:r>
-              <a:rPr lang="en-US" sz="1400" dirty="0">
+              <a:rPr lang="en-US" sz="1300" dirty="0">
                 <a:solidFill>
                   <a:srgbClr val="0F172A"/>
                 </a:solidFill>
@@ -3947,16 +3758,16 @@
                 <a:ea typeface="Helvetica Neue" pitchFamily="34" charset="-122"/>
                 <a:cs typeface="Helvetica Neue" pitchFamily="34" charset="-120"/>
               </a:rPr>
-              <a:t>• 每頁 3 個版本：先快速比對，再鎖定喜歡的構圖</a:t>
+              <a:t>• 每頁 3 版本：快速比對，再鎖定構圖 (3 variants per page)</a:t>
             </a:r>
             <a:pPr indent="0" marL="0">
               <a:lnSpc>
-                <a:spcPct val="107000"/>
+                <a:spcPct val="105000"/>
               </a:lnSpc>
               <a:buNone/>
             </a:pPr>
             <a:r>
-              <a:rPr lang="en-US" sz="1400" dirty="0">
+              <a:rPr lang="en-US" sz="1300" dirty="0">
                 <a:solidFill>
                   <a:srgbClr val="0F172A"/>
                 </a:solidFill>
@@ -3964,16 +3775,16 @@
                 <a:ea typeface="Helvetica Neue" pitchFamily="34" charset="-122"/>
                 <a:cs typeface="Helvetica Neue" pitchFamily="34" charset="-120"/>
               </a:rPr>
-              <a:t>• Before/After：分開看色相（顏色）與位移（版式/構圖）</a:t>
+              <a:t>• Before/After：分開看顏色與版式位移 (separate color vs layout)</a:t>
             </a:r>
             <a:pPr indent="0" marL="0">
               <a:lnSpc>
-                <a:spcPct val="107000"/>
+                <a:spcPct val="105000"/>
               </a:lnSpc>
               <a:buNone/>
             </a:pPr>
             <a:r>
-              <a:rPr lang="en-US" sz="1400" dirty="0">
+              <a:rPr lang="en-US" sz="1300" dirty="0">
                 <a:solidFill>
                   <a:srgbClr val="0F172A"/>
                 </a:solidFill>
@@ -3981,16 +3792,16 @@
                 <a:ea typeface="Helvetica Neue" pitchFamily="34" charset="-122"/>
                 <a:cs typeface="Helvetica Neue" pitchFamily="34" charset="-120"/>
               </a:rPr>
-              <a:t>• 支援 WebGL/2D 預覽：用同一套 SVG 來源保持一致</a:t>
+              <a:t>• WebGL/2D 預覽：同一套 SVG 來源 (consistent SVG preview)</a:t>
             </a:r>
             <a:pPr indent="0" marL="0">
               <a:lnSpc>
-                <a:spcPct val="107000"/>
+                <a:spcPct val="105000"/>
               </a:lnSpc>
               <a:buNone/>
             </a:pPr>
             <a:r>
-              <a:rPr lang="en-US" sz="1400" dirty="0">
+              <a:rPr lang="en-US" sz="1300" dirty="0">
                 <a:solidFill>
                   <a:srgbClr val="0F172A"/>
                 </a:solidFill>
@@ -3998,7 +3809,7 @@
                 <a:ea typeface="Helvetica Neue" pitchFamily="34" charset="-122"/>
                 <a:cs typeface="Helvetica Neue" pitchFamily="34" charset="-120"/>
               </a:rPr>
-              <a:t>目標：降低決策成本，加速版式定稿。</a:t>
+              <a:t>目標：降低決策成本、加速定稿 (faster decisions)</a:t>
             </a:r>
             <a:endParaRPr lang="en-US" sz="1600" dirty="0"/>
           </a:p>
@@ -4160,7 +3971,7 @@
           <a:p>
             <a:pPr indent="0" marL="0">
               <a:lnSpc>
-                <a:spcPct val="107000"/>
+                <a:spcPct val="105000"/>
               </a:lnSpc>
               <a:buNone/>
             </a:pPr>
@@ -4177,12 +3988,12 @@
             </a:r>
             <a:pPr indent="0" marL="0">
               <a:lnSpc>
-                <a:spcPct val="107000"/>
+                <a:spcPct val="105000"/>
               </a:lnSpc>
               <a:buNone/>
             </a:pPr>
             <a:r>
-              <a:rPr lang="en-US" sz="1400" dirty="0">
+              <a:rPr lang="en-US" sz="1300" dirty="0">
                 <a:solidFill>
                   <a:srgbClr val="0F172A"/>
                 </a:solidFill>
@@ -4190,16 +4001,16 @@
                 <a:ea typeface="Helvetica Neue" pitchFamily="34" charset="-122"/>
                 <a:cs typeface="Helvetica Neue" pitchFamily="34" charset="-120"/>
               </a:rPr>
-              <a:t>• 下載合併 PDF：適合分享與列印</a:t>
+              <a:t>• 下載合併 PDF：分享/列印用 (merged PDF for share/print)</a:t>
             </a:r>
             <a:pPr indent="0" marL="0">
               <a:lnSpc>
-                <a:spcPct val="107000"/>
+                <a:spcPct val="105000"/>
               </a:lnSpc>
               <a:buNone/>
             </a:pPr>
             <a:r>
-              <a:rPr lang="en-US" sz="1400" dirty="0">
+              <a:rPr lang="en-US" sz="1300" dirty="0">
                 <a:solidFill>
                   <a:srgbClr val="0F172A"/>
                 </a:solidFill>
@@ -4207,16 +4018,16 @@
                 <a:ea typeface="Helvetica Neue" pitchFamily="34" charset="-122"/>
                 <a:cs typeface="Helvetica Neue" pitchFamily="34" charset="-120"/>
               </a:rPr>
-              <a:t>• 下載每頁 SVG：給 Figma/編輯器繼續精修</a:t>
+              <a:t>• 下載每頁 SVG：給 Figma/編輯器精修 (per-page SVG for refinement)</a:t>
             </a:r>
             <a:pPr indent="0" marL="0">
               <a:lnSpc>
-                <a:spcPct val="107000"/>
+                <a:spcPct val="105000"/>
               </a:lnSpc>
               <a:buNone/>
             </a:pPr>
             <a:r>
-              <a:rPr lang="en-US" sz="1400" dirty="0">
+              <a:rPr lang="en-US" sz="1300" dirty="0">
                 <a:solidFill>
                   <a:srgbClr val="0F172A"/>
                 </a:solidFill>
@@ -4224,16 +4035,16 @@
                 <a:ea typeface="Helvetica Neue" pitchFamily="34" charset="-122"/>
                 <a:cs typeface="Helvetica Neue" pitchFamily="34" charset="-120"/>
               </a:rPr>
-              <a:t>• 匯出保留所選版本設定（包含網格重排/塊微調）。</a:t>
+              <a:t>• 保留所選版本设置：含網格重排/微調 (keeps chosen settings)</a:t>
             </a:r>
             <a:pPr indent="0" marL="0">
               <a:lnSpc>
-                <a:spcPct val="107000"/>
+                <a:spcPct val="105000"/>
               </a:lnSpc>
               <a:buNone/>
             </a:pPr>
             <a:r>
-              <a:rPr lang="en-US" sz="1400" dirty="0">
+              <a:rPr lang="en-US" sz="1300" dirty="0">
                 <a:solidFill>
                   <a:srgbClr val="0F172A"/>
                 </a:solidFill>
@@ -4241,7 +4052,7 @@
                 <a:ea typeface="Helvetica Neue" pitchFamily="34" charset="-122"/>
                 <a:cs typeface="Helvetica Neue" pitchFamily="34" charset="-120"/>
               </a:rPr>
-              <a:t>目標：把探索結果轉成可交付的設計稿。</a:t>
+              <a:t>目標：輸出可交付設計稿 (deliverable output)</a:t>
             </a:r>
             <a:endParaRPr lang="en-US" sz="1600" dirty="0"/>
           </a:p>
@@ -4380,13 +4191,13 @@
           <a:p>
             <a:pPr marL="342900" indent="-342900">
               <a:lnSpc>
-                <a:spcPct val="108000"/>
+                <a:spcPct val="106000"/>
               </a:lnSpc>
               <a:buSzPct val="100000"/>
               <a:buChar char="•"/>
             </a:pPr>
             <a:r>
-              <a:rPr lang="en-US" sz="1400" dirty="0">
+              <a:rPr lang="en-US" sz="1300" dirty="0">
                 <a:solidFill>
                   <a:srgbClr val="0F172A"/>
                 </a:solidFill>
@@ -4394,20 +4205,20 @@
                 <a:ea typeface="Helvetica Neue" pitchFamily="34" charset="-122"/>
                 <a:cs typeface="Helvetica Neue" pitchFamily="34" charset="-120"/>
               </a:rPr>
-              <a:t>Empathize 同理：repetitive layout work (order/grid/spacing) steals time → designer stays in control.</a:t>
-            </a:r>
-            <a:endParaRPr lang="en-US" sz="1400" dirty="0"/>
+              <a:t>Empathize: repetitive layout work (order/grid/spacing) steals time → designer stays in control. / 同理：重复的版面排版（页序/网格/字距）会占用时间 → 设计师保持掌控。</a:t>
+            </a:r>
+            <a:endParaRPr lang="en-US" sz="1300" dirty="0"/>
           </a:p>
           <a:p>
             <a:pPr marL="342900" indent="-342900">
               <a:lnSpc>
-                <a:spcPct val="108000"/>
+                <a:spcPct val="106000"/>
               </a:lnSpc>
               <a:buSzPct val="100000"/>
               <a:buChar char="•"/>
             </a:pPr>
             <a:r>
-              <a:rPr lang="en-US" sz="1400" dirty="0">
+              <a:rPr lang="en-US" sz="1300" dirty="0">
                 <a:solidFill>
                   <a:srgbClr val="0F172A"/>
                 </a:solidFill>
@@ -4415,20 +4226,20 @@
                 <a:ea typeface="Helvetica Neue" pitchFamily="34" charset="-122"/>
                 <a:cs typeface="Helvetica Neue" pitchFamily="34" charset="-120"/>
               </a:rPr>
-              <a:t>Define 定義：assist decisions, not replace authorship — keep authorship and taste.</a:t>
-            </a:r>
-            <a:endParaRPr lang="en-US" sz="1400" dirty="0"/>
+              <a:t>Define: assist decisions, not replace authorship — keep authorship and taste. / 定义：辅助决策而非取代创作权——保留创作主导与审美品味。</a:t>
+            </a:r>
+            <a:endParaRPr lang="en-US" sz="1300" dirty="0"/>
           </a:p>
           <a:p>
             <a:pPr marL="342900" indent="-342900">
               <a:lnSpc>
-                <a:spcPct val="108000"/>
+                <a:spcPct val="106000"/>
               </a:lnSpc>
               <a:buSzPct val="100000"/>
               <a:buChar char="•"/>
             </a:pPr>
             <a:r>
-              <a:rPr lang="en-US" sz="1400" dirty="0">
+              <a:rPr lang="en-US" sz="1300" dirty="0">
                 <a:solidFill>
                   <a:srgbClr val="0F172A"/>
                 </a:solidFill>
@@ -4436,20 +4247,20 @@
                 <a:ea typeface="Helvetica Neue" pitchFamily="34" charset="-122"/>
                 <a:cs typeface="Helvetica Neue" pitchFamily="34" charset="-120"/>
               </a:rPr>
-              <a:t>Ideate 發想：wizard + persistent dock + only 3 variants per page → faster comparison.</a:t>
-            </a:r>
-            <a:endParaRPr lang="en-US" sz="1400" dirty="0"/>
+              <a:t>Ideate: wizard + persistent dock + only 3 variants per page → faster comparison. / 发想：精灵流程 + 持续侧栏预览 + 每页仅 3 个版本 → 更快对比。</a:t>
+            </a:r>
+            <a:endParaRPr lang="en-US" sz="1300" dirty="0"/>
           </a:p>
           <a:p>
             <a:pPr marL="342900" indent="-342900">
               <a:lnSpc>
-                <a:spcPct val="108000"/>
+                <a:spcPct val="106000"/>
               </a:lnSpc>
               <a:buSzPct val="100000"/>
               <a:buChar char="•"/>
             </a:pPr>
             <a:r>
-              <a:rPr lang="en-US" sz="1400" dirty="0">
+              <a:rPr lang="en-US" sz="1300" dirty="0">
                 <a:solidFill>
                   <a:srgbClr val="0F172A"/>
                 </a:solidFill>
@@ -4457,20 +4268,20 @@
                 <a:ea typeface="Helvetica Neue" pitchFamily="34" charset="-122"/>
                 <a:cs typeface="Helvetica Neue" pitchFamily="34" charset="-120"/>
               </a:rPr>
-              <a:t>Prototype 原型：bilingual UI + grid remix + tile nudge + before/after compare for readability.</a:t>
-            </a:r>
-            <a:endParaRPr lang="en-US" sz="1400" dirty="0"/>
+              <a:t>Prototype: bilingual UI + grid remix + tile nudge + before/after compare for readability. / 原型：双语界面 + 网格重排 + tile 微调 + Before/After 对比，用于提升可读性。</a:t>
+            </a:r>
+            <a:endParaRPr lang="en-US" sz="1300" dirty="0"/>
           </a:p>
           <a:p>
             <a:pPr marL="342900" indent="-342900">
               <a:lnSpc>
-                <a:spcPct val="108000"/>
+                <a:spcPct val="106000"/>
               </a:lnSpc>
               <a:buSzPct val="100000"/>
               <a:buChar char="•"/>
             </a:pPr>
             <a:r>
-              <a:rPr lang="en-US" sz="1400" dirty="0">
+              <a:rPr lang="en-US" sz="1300" dirty="0">
                 <a:solidFill>
                   <a:srgbClr val="0F172A"/>
                 </a:solidFill>
@@ -4478,9 +4289,9 @@
                 <a:ea typeface="Helvetica Neue" pitchFamily="34" charset="-122"/>
                 <a:cs typeface="Helvetica Neue" pitchFamily="34" charset="-120"/>
               </a:rPr>
-              <a:t>Test 測試：synchronize previews across steps and keep typography hierarchy stable (e.g. 1×2 grids).</a:t>
-            </a:r>
-            <a:endParaRPr lang="en-US" sz="1400" dirty="0"/>
+              <a:t>Test: synchronize previews across steps and keep typography hierarchy stable (e.g. 1×2 grids). / 测试：各步骤预览保持同步，并确保字体现层级稳定（例如 1×2 网格）。</a:t>
+            </a:r>
+            <a:endParaRPr lang="en-US" sz="1300" dirty="0"/>
           </a:p>
         </p:txBody>
       </p:sp>
@@ -4817,7 +4628,7 @@
                             <a:srgbClr val="000000"/>
                           </a:solidFill>
                         </a:rPr>
-                        <a:t>Cards use padding + gap; dock preview keeps focus.</a:t>
+                        <a:t>Cards use padding + gap; dock preview keeps focus. / 卡片使用 padding + gap；dock 預覽保持焦點。</a:t>
                       </a:r>
                       <a:endParaRPr lang="en-US" sz="1200" dirty="0"/>
                     </a:p>
@@ -4935,7 +4746,7 @@
                             <a:srgbClr val="000000"/>
                           </a:solidFill>
                         </a:rPr>
-                        <a:t>Purple titles + muted body; consistent left alignment.</a:t>
+                        <a:t>Purple titles + muted body; consistent left alignment. / 紫色標題 + 低飽和正文；左對齊一致。</a:t>
                       </a:r>
                       <a:endParaRPr lang="en-US" sz="1200" dirty="0"/>
                     </a:p>
@@ -5053,7 +4864,7 @@
                             <a:srgbClr val="000000"/>
                           </a:solidFill>
                         </a:rPr>
-                        <a:t>2×2 / 1×2 / 2×1 presets + tile nudge for composition iteration.</a:t>
+                        <a:t>2×2 / 1×2 / 2×1 presets + tile nudge for iteration. / 2×2 / 1×2 / 2×1 預設 + tile nudge 迭代構圖。</a:t>
                       </a:r>
                       <a:endParaRPr lang="en-US" sz="1200" dirty="0"/>
                     </a:p>
@@ -5171,7 +4982,7 @@
                             <a:srgbClr val="000000"/>
                           </a:solidFill>
                         </a:rPr>
-                        <a:t>Before/After modes separate hue vs layout for decision confidence.</a:t>
+                        <a:t>Before/After separates hue vs layout for confident decisions. / Before/After 分開看色相 vs 版式，提升決策信心。</a:t>
                       </a:r>
                       <a:endParaRPr lang="en-US" sz="1200" dirty="0"/>
                     </a:p>
@@ -5289,7 +5100,7 @@
                             <a:srgbClr val="000000"/>
                           </a:solidFill>
                         </a:rPr>
-                        <a:t>Language toggle with persistent preference via localStorage.</a:t>
+                        <a:t>Language toggle with persistent preference via localStorage. / 語言切換透過 localStorage 記住偏好。</a:t>
                       </a:r>
                       <a:endParaRPr lang="en-US" sz="1200" dirty="0"/>
                     </a:p>

</xml_diff>